<commit_message>
WIP: Chemistry U2 deck fix round (S2.1 fixed; others in progress)
Co-Authored-By: Claude Sonnet 5.5 <noreply@anthropic.com>
Claude-Session: https://claude.ai/code/session_01CAqidLLu6PiYNMcZx5qMsE
</commit_message>
<xml_diff>
--- a/deliverables/chem-u02/SHULL_CHEM_Slides_U02_S02.1.pptx
+++ b/deliverables/chem-u02/SHULL_CHEM_Slides_U02_S02.1.pptx
@@ -523,7 +523,7 @@
           <a:p>
             <a:r>
               <a:rPr lang="en-US" dirty="0"/>
-              <a:t/>
+              <a:t>Targets: describe Bohr's hydrogen model; use E_n = −2.18 × 10^{−18} J ÷ n² for a level energy and ΔE; explain emission and absorption; state the model's limits. Hook is the next slide. PROVISIONAL (brief flag F1, Matt to confirm): E_n needs scientific notation, but the course sequencing rule delays scientific notation and heavy math. Plan used: a pre-built table plus ONE student calculation, 3 sig figs, no sig-fig rules taught. Image prompt (empty slot): a hydrogen gas discharge tube glowing pink-magenta on a dark bench, lit only by its own light.</a:t>
             </a:r>
             <a:endParaRPr lang="en-US" dirty="0"/>
           </a:p>
@@ -611,7 +611,7 @@
           <a:p>
             <a:r>
               <a:rPr lang="en-US" dirty="0"/>
-              <a:t/>
+              <a:t>Worked together. Answer: 3² = 9; −2.18 × 10^{−18} ÷ 9 = −2.42 × 10^{−19} J. Students write the setup, not just the number. Image prompt (empty slot): a pencil resting beside a scientific calculator on a lab notebook.</a:t>
             </a:r>
             <a:endParaRPr lang="en-US" dirty="0"/>
           </a:p>
@@ -699,7 +699,7 @@
           <a:p>
             <a:r>
               <a:rPr lang="en-US" dirty="0"/>
-              <a:t/>
+              <a:t>Check against slide 9: −2.42 × 10^{−19} is less negative than E₂ = −5.45 × 10^{−19}, so E₃ is higher. Calculator use is fine; 3 sig figs, no sig-fig rules taught.</a:t>
             </a:r>
             <a:endParaRPr lang="en-US" dirty="0"/>
           </a:p>
@@ -787,7 +787,7 @@
           <a:p>
             <a:r>
               <a:rPr lang="en-US" dirty="0"/>
-              <a:t/>
+              <a:t>Ground state is n = 1. Excited states are any higher n and are short-lived. Image prompt (empty slot): two hydrogen discharge tubes side by side, one dark and one glowing.</a:t>
             </a:r>
             <a:endParaRPr lang="en-US" dirty="0"/>
           </a:p>
@@ -875,7 +875,7 @@
           <a:p>
             <a:r>
               <a:rPr lang="en-US" dirty="0"/>
-              <a:t/>
+              <a:t>Absorption: the electron rises only if the photon energy equals exactly E final minus E initial. Wrong-energy photons pass through. Misconception: that any photon will do.</a:t>
             </a:r>
             <a:endParaRPr lang="en-US" dirty="0"/>
           </a:p>
@@ -963,7 +963,7 @@
           <a:p>
             <a:r>
               <a:rPr lang="en-US" dirty="0"/>
-              <a:t/>
+              <a:t>Emission: the electron drops and a photon leaves with energy |ΔE|. A bigger drop is a higher-energy photon. Misconception: emission means the electron goes up. It drops. Colors and wavelengths are S2.5, not here.</a:t>
             </a:r>
             <a:endParaRPr lang="en-US" dirty="0"/>
           </a:p>
@@ -1051,7 +1051,7 @@
           <a:p>
             <a:r>
               <a:rPr lang="en-US" dirty="0"/>
-              <a:t/>
+              <a:t>Worked together. Answer: ΔE = E₂ − E₃ = −5.45 × 10^{−19} − (−2.42 × 10^{−19}) = −3.03 × 10^{−19} J. Negative, so energy is released. Image prompt (empty slot): a camera-flash bulb mid-discharge in a dark room.</a:t>
             </a:r>
             <a:endParaRPr lang="en-US" dirty="0"/>
           </a:p>
@@ -1139,7 +1139,7 @@
           <a:p>
             <a:r>
               <a:rPr lang="en-US" dirty="0"/>
-              <a:t/>
+              <a:t>Final minus initial, keep the negatives. Photon energy is 3.03 × 10^{−19} J. Do not calculate its wavelength; that is S2.5.</a:t>
             </a:r>
             <a:endParaRPr lang="en-US" dirty="0"/>
           </a:p>
@@ -1227,7 +1227,7 @@
           <a:p>
             <a:r>
               <a:rPr lang="en-US" dirty="0"/>
-              <a:t/>
+              <a:t>Worked together. Answer: n = 1 to ∞, ΔE = 0 − (−2.18 × 10^{−18}) = +2.18 × 10^{−18} J, absorbed. Image prompt (empty slot): a spark gap between two electrodes in a dark lab.</a:t>
             </a:r>
             <a:endParaRPr lang="en-US" dirty="0"/>
           </a:p>
@@ -1315,7 +1315,7 @@
           <a:p>
             <a:r>
               <a:rPr lang="en-US" dirty="0"/>
-              <a:t/>
+              <a:t>Positive ΔE means absorbed. Ionization energy of ground-state hydrogen is 2.18 × 10^{−18} J.</a:t>
             </a:r>
             <a:endParaRPr lang="en-US" dirty="0"/>
           </a:p>
@@ -1403,7 +1403,7 @@
           <a:p>
             <a:r>
               <a:rPr lang="en-US" dirty="0"/>
-              <a:t/>
+              <a:t>Limits: correct for hydrogen only, not for atoms with 2 or more electrons. Electrons are not particles on tracks; the electron-cloud model (S2.2) replaces the orbits. Keep: quantized levels, photon in or out. Image prompt (empty slot): a worn textbook diagram of concentric orbits with a pencil strike through it.</a:t>
             </a:r>
             <a:endParaRPr lang="en-US" dirty="0"/>
           </a:p>
@@ -1491,7 +1491,7 @@
           <a:p>
             <a:r>
               <a:rPr lang="en-US" dirty="0"/>
-              <a:t/>
+              <a:t>Pose the question and leave it open; it is answered by slide 20. Do not name quantization yet. Image prompt (empty slot): a glowing hydrogen discharge tube photographed close, with a prism-split smear of four thin colored lines beside it.</a:t>
             </a:r>
             <a:endParaRPr lang="en-US" dirty="0"/>
           </a:p>
@@ -1579,7 +1579,7 @@
           <a:p>
             <a:r>
               <a:rPr lang="en-US" dirty="0"/>
-              <a:t/>
+              <a:t>Check answers. 1: Electron energy is quantized, so only certain level differences exist and only certain photon energies, hence certain colors. 2: E₂ = −2.18 × 10^{−18} ÷ 4 = −5.45 × 10^{−19} J. 3: Emitted. E₄ = −1.36 × 10^{−19}, E₂ = −5.45 × 10^{−19}, ΔE = −4.09 × 10^{−19} J, so 4.09 × 10^{−19} J leaves the atom. Image prompt (empty slot): a student's notebook page with a calculation crossed out and redone.</a:t>
             </a:r>
             <a:endParaRPr lang="en-US" dirty="0"/>
           </a:p>
@@ -1667,7 +1667,7 @@
           <a:p>
             <a:r>
               <a:rPr lang="en-US" dirty="0"/>
-              <a:t/>
+              <a:t>Check answers. 4: n = 2 to 1 releases more. ΔE(3→2) = −3.03 × 10^{−19} J; ΔE(2→1) = −2.18 × 10^{−18} − (−5.45 × 10^{−19}) = −1.64 × 10^{−18} J. 5: any one of: works only for hydrogen; cannot predict multi-electron atoms; electrons are not particles in circular orbits. Image prompt (empty slot): a stack of graded quiz papers with a red pen on top.</a:t>
             </a:r>
             <a:endParaRPr lang="en-US" dirty="0"/>
           </a:p>
@@ -1755,7 +1755,7 @@
           <a:p>
             <a:r>
               <a:rPr lang="en-US" dirty="0"/>
-              <a:t/>
+              <a:t>Bridge to S2.2 and the electron-cloud model. Do not say Bohr explains multi-electron spectra, intensities, or bonding. Image prompt (empty slot): a long laboratory bench receding into shadow, one lamp lit at the far end.</a:t>
             </a:r>
             <a:endParaRPr lang="en-US" dirty="0"/>
           </a:p>
@@ -1843,7 +1843,7 @@
           <a:p>
             <a:r>
               <a:rPr lang="en-US" dirty="0"/>
-              <a:t/>
+              <a:t>Vocabulary first so later slides can use it. Students write only the energy-level line. Image prompt (empty slot): a glass prism on a lab bench splitting a narrow white beam.</a:t>
             </a:r>
             <a:endParaRPr lang="en-US" dirty="0"/>
           </a:p>
@@ -1931,7 +1931,7 @@
           <a:p>
             <a:r>
               <a:rPr lang="en-US" dirty="0"/>
-              <a:t/>
+              <a:t>Thomson, then Rutherford 1911, then the problem: a classical orbiting charge should radiate and spiral in. Bohr, 1913. Image prompt (empty slot): a chalkboard with a hand-drawn nucleus and one looping electron path, chalk dust on the ledge.</a:t>
             </a:r>
             <a:endParaRPr lang="en-US" dirty="0"/>
           </a:p>
@@ -2019,7 +2019,7 @@
           <a:p>
             <a:r>
               <a:rPr lang="en-US" dirty="0"/>
-              <a:t/>
+              <a:t>Three rules: fixed orbits, no radiation in an orbit, photon jumps. The photon energy equals the difference between the two levels. Image prompt (empty slot): a hand-drawn set of concentric circles in a pocket notebook, pencil beside it.</a:t>
             </a:r>
             <a:endParaRPr lang="en-US" dirty="0"/>
           </a:p>
@@ -2107,7 +2107,7 @@
           <a:p>
             <a:r>
               <a:rPr lang="en-US" dirty="0"/>
-              <a:t/>
+              <a:t>Diagram: one proton, one electron, here at n = 1. Orbit radii run 1 : 4 : 9. This is the model's picture, not reality; slide 19 returns to that.</a:t>
             </a:r>
             <a:endParaRPr lang="en-US" dirty="0"/>
           </a:p>
@@ -2195,7 +2195,7 @@
           <a:p>
             <a:r>
               <a:rPr lang="en-US" dirty="0"/>
-              <a:t/>
+              <a:t>Stairs versus ramp. Stress that no energy exists between levels. Image prompt (empty slot): a wooden staircase beside a smooth ramp of the same height, side-lit.</a:t>
             </a:r>
             <a:endParaRPr lang="en-US" dirty="0"/>
           </a:p>
@@ -2283,7 +2283,7 @@
           <a:p>
             <a:r>
               <a:rPr lang="en-US" dirty="0"/>
-              <a:t/>
+              <a:t>Equation: E_n = −2.18 × 10^{−18} J ÷ n². n is a whole number. Negative means bound; E = 0 is a free electron. Hydrogen only. PROVISIONAL (brief flag F1, Matt to confirm): E_n needs scientific notation, but the course sequencing rule delays scientific notation and heavy math. Plan used: a pre-built table plus ONE student calculation, 3 sig figs, no sig-fig rules taught.</a:t>
             </a:r>
             <a:endParaRPr lang="en-US" dirty="0"/>
           </a:p>
@@ -2371,7 +2371,7 @@
           <a:p>
             <a:r>
               <a:rPr lang="en-US" dirty="0"/>
-              <a:t/>
+              <a:t>Values to n = 6: n=1 −2.18 × 10^{−18} J; n=2 −5.45 × 10^{−19}; n=3 −2.42 × 10^{−19}; n=4 −1.36 × 10^{−19}; n=5 −8.72 × 10^{−20}; n=6 −6.06 × 10^{−20}. Spacing is drawn to scale. Misconception: more negative means more energy. It means lower. n = ∞ is E = 0.</a:t>
             </a:r>
             <a:endParaRPr lang="en-US" dirty="0"/>
           </a:p>
@@ -13218,7 +13218,7 @@
                 <a:ea typeface="Trade Gothic Next" pitchFamily="34" charset="-122"/>
                 <a:cs typeface="Trade Gothic Next" pitchFamily="34" charset="-120"/>
               </a:rPr>
-              <a:t>01</a:t>
+              <a:t>2.1</a:t>
             </a:r>
             <a:endParaRPr lang="en-US" sz="4400" dirty="0"/>
           </a:p>
@@ -13262,26 +13262,6 @@
                 <a:ea typeface="Trade Gothic Next" pitchFamily="34" charset="-122"/>
                 <a:cs typeface="Trade Gothic Next" pitchFamily="34" charset="-120"/>
               </a:rPr>
-              <a:t>2.1</a:t>
-            </a:r>
-            <a:endParaRPr lang="en-US" sz="2800" dirty="0"/>
-          </a:p>
-          <a:p>
-            <a:pPr algn="l" indent="0" marL="0">
-              <a:lnSpc>
-                <a:spcPct val="106000"/>
-              </a:lnSpc>
-              <a:buNone/>
-            </a:pPr>
-            <a:r>
-              <a:rPr lang="en-US" sz="2800" b="1" dirty="0">
-                <a:solidFill>
-                  <a:srgbClr val="14161B"/>
-                </a:solidFill>
-                <a:latin typeface="Trade Gothic Next" pitchFamily="34" charset="0"/>
-                <a:ea typeface="Trade Gothic Next" pitchFamily="34" charset="-122"/>
-                <a:cs typeface="Trade Gothic Next" pitchFamily="34" charset="-120"/>
-              </a:rPr>
               <a:t>The Bohr Model</a:t>
             </a:r>
             <a:endParaRPr lang="en-US" sz="2800" dirty="0"/>
@@ -13372,7 +13352,7 @@
       </p:sp>
       <p:sp>
         <p:nvSpPr>
-          <p:cNvPr id="6" name="Text 3"/>
+          <p:cNvPr id="7" name="Text 3"/>
           <p:cNvSpPr txBox="1"/>
           <p:nvPr>
             <p:ph idx="103" hasCustomPrompt="1"/>
@@ -13794,7 +13774,35 @@
                 <a:ea typeface="Trade Gothic Next" pitchFamily="34" charset="-122"/>
                 <a:cs typeface="Trade Gothic Next" pitchFamily="34" charset="-120"/>
               </a:rPr>
-              <a:t>Eₙ = −2.18 × 10^−18 J ÷ n²</a:t>
+              <a:t>Eₙ = −2.18 × 10</a:t>
+            </a:r>
+            <a:pPr indent="0" marL="0">
+              <a:buNone/>
+            </a:pPr>
+            <a:r>
+              <a:rPr lang="en-US" sz="1600" b="1" baseline="30000" dirty="0">
+                <a:solidFill>
+                  <a:srgbClr val="EDF0E5"/>
+                </a:solidFill>
+                <a:latin typeface="Trade Gothic Next" pitchFamily="34" charset="0"/>
+                <a:ea typeface="Trade Gothic Next" pitchFamily="34" charset="-122"/>
+                <a:cs typeface="Trade Gothic Next" pitchFamily="34" charset="-120"/>
+              </a:rPr>
+              <a:t>−18</a:t>
+            </a:r>
+            <a:pPr indent="0" marL="0">
+              <a:buNone/>
+            </a:pPr>
+            <a:r>
+              <a:rPr lang="en-US" sz="1600" b="1" dirty="0">
+                <a:solidFill>
+                  <a:srgbClr val="EDF0E5"/>
+                </a:solidFill>
+                <a:latin typeface="Trade Gothic Next" pitchFamily="34" charset="0"/>
+                <a:ea typeface="Trade Gothic Next" pitchFamily="34" charset="-122"/>
+                <a:cs typeface="Trade Gothic Next" pitchFamily="34" charset="-120"/>
+              </a:rPr>
+              <a:t> J ÷ n²</a:t>
             </a:r>
             <a:endParaRPr lang="en-US" sz="1600" dirty="0"/>
           </a:p>
@@ -13884,7 +13892,7 @@
       </p:sp>
       <p:sp>
         <p:nvSpPr>
-          <p:cNvPr id="13" name="Text 4"/>
+          <p:cNvPr id="14" name="Text 4"/>
           <p:cNvSpPr txBox="1"/>
           <p:nvPr>
             <p:ph idx="107" hasCustomPrompt="1"/>
@@ -14119,7 +14127,35 @@
                 <a:ea typeface="Trade Gothic Next" pitchFamily="34" charset="-122"/>
                 <a:cs typeface="Trade Gothic Next" pitchFamily="34" charset="-120"/>
               </a:rPr>
-              <a:t>Eₙ = −2.18 × 10^−18 J ÷ n²</a:t>
+              <a:t>Eₙ = −2.18 × 10</a:t>
+            </a:r>
+            <a:pPr indent="0" marL="0">
+              <a:buNone/>
+            </a:pPr>
+            <a:r>
+              <a:rPr lang="en-US" sz="1600" baseline="30000" dirty="0">
+                <a:solidFill>
+                  <a:srgbClr val="14161B"/>
+                </a:solidFill>
+                <a:latin typeface="Trade Gothic Next" pitchFamily="34" charset="0"/>
+                <a:ea typeface="Trade Gothic Next" pitchFamily="34" charset="-122"/>
+                <a:cs typeface="Trade Gothic Next" pitchFamily="34" charset="-120"/>
+              </a:rPr>
+              <a:t>−18</a:t>
+            </a:r>
+            <a:pPr indent="0" marL="0">
+              <a:buNone/>
+            </a:pPr>
+            <a:r>
+              <a:rPr lang="en-US" sz="1600" dirty="0">
+                <a:solidFill>
+                  <a:srgbClr val="14161B"/>
+                </a:solidFill>
+                <a:latin typeface="Trade Gothic Next" pitchFamily="34" charset="0"/>
+                <a:ea typeface="Trade Gothic Next" pitchFamily="34" charset="-122"/>
+                <a:cs typeface="Trade Gothic Next" pitchFamily="34" charset="-120"/>
+              </a:rPr>
+              <a:t> J ÷ n²</a:t>
             </a:r>
             <a:endParaRPr lang="en-US" sz="1600" dirty="0"/>
           </a:p>
@@ -14177,7 +14213,35 @@
                 <a:ea typeface="Trade Gothic Next" pitchFamily="34" charset="-122"/>
                 <a:cs typeface="Trade Gothic Next" pitchFamily="34" charset="-120"/>
               </a:rPr>
-              <a:t>−2.18 × 10^−18 ÷ 9</a:t>
+              <a:t>−2.18 × 10</a:t>
+            </a:r>
+            <a:pPr indent="0" marL="0">
+              <a:buNone/>
+            </a:pPr>
+            <a:r>
+              <a:rPr lang="en-US" sz="1900" baseline="30000" dirty="0">
+                <a:solidFill>
+                  <a:srgbClr val="14161B"/>
+                </a:solidFill>
+                <a:latin typeface="Trade Gothic Next" pitchFamily="34" charset="0"/>
+                <a:ea typeface="Trade Gothic Next" pitchFamily="34" charset="-122"/>
+                <a:cs typeface="Trade Gothic Next" pitchFamily="34" charset="-120"/>
+              </a:rPr>
+              <a:t>−18</a:t>
+            </a:r>
+            <a:pPr indent="0" marL="0">
+              <a:buNone/>
+            </a:pPr>
+            <a:r>
+              <a:rPr lang="en-US" sz="1900" dirty="0">
+                <a:solidFill>
+                  <a:srgbClr val="14161B"/>
+                </a:solidFill>
+                <a:latin typeface="Trade Gothic Next" pitchFamily="34" charset="0"/>
+                <a:ea typeface="Trade Gothic Next" pitchFamily="34" charset="-122"/>
+                <a:cs typeface="Trade Gothic Next" pitchFamily="34" charset="-120"/>
+              </a:rPr>
+              <a:t> ÷ 9</a:t>
             </a:r>
             <a:endParaRPr lang="en-US" sz="1900" dirty="0"/>
           </a:p>
@@ -14194,7 +14258,35 @@
                 <a:ea typeface="Trade Gothic Next" pitchFamily="34" charset="-122"/>
                 <a:cs typeface="Trade Gothic Next" pitchFamily="34" charset="-120"/>
               </a:rPr>
-              <a:t>= −2.42 × 10^−19 J</a:t>
+              <a:t>= −2.42 × 10</a:t>
+            </a:r>
+            <a:pPr indent="0" marL="0">
+              <a:buNone/>
+            </a:pPr>
+            <a:r>
+              <a:rPr lang="en-US" sz="1900" baseline="30000" dirty="0">
+                <a:solidFill>
+                  <a:srgbClr val="14161B"/>
+                </a:solidFill>
+                <a:latin typeface="Trade Gothic Next" pitchFamily="34" charset="0"/>
+                <a:ea typeface="Trade Gothic Next" pitchFamily="34" charset="-122"/>
+                <a:cs typeface="Trade Gothic Next" pitchFamily="34" charset="-120"/>
+              </a:rPr>
+              <a:t>−19</a:t>
+            </a:r>
+            <a:pPr indent="0" marL="0">
+              <a:buNone/>
+            </a:pPr>
+            <a:r>
+              <a:rPr lang="en-US" sz="1900" dirty="0">
+                <a:solidFill>
+                  <a:srgbClr val="14161B"/>
+                </a:solidFill>
+                <a:latin typeface="Trade Gothic Next" pitchFamily="34" charset="0"/>
+                <a:ea typeface="Trade Gothic Next" pitchFamily="34" charset="-122"/>
+                <a:cs typeface="Trade Gothic Next" pitchFamily="34" charset="-120"/>
+              </a:rPr>
+              <a:t> J</a:t>
             </a:r>
             <a:endParaRPr lang="en-US" sz="1900" dirty="0"/>
           </a:p>
@@ -14325,7 +14417,7 @@
       </p:sp>
       <p:sp>
         <p:nvSpPr>
-          <p:cNvPr id="11" name="Text 4"/>
+          <p:cNvPr id="12" name="Text 4"/>
           <p:cNvSpPr txBox="1"/>
           <p:nvPr>
             <p:ph idx="107" hasCustomPrompt="1"/>
@@ -14812,7 +14904,7 @@
       </p:sp>
       <p:sp>
         <p:nvSpPr>
-          <p:cNvPr id="11" name="Text 3"/>
+          <p:cNvPr id="12" name="Text 3"/>
           <p:cNvSpPr txBox="1"/>
           <p:nvPr>
             <p:ph idx="106" hasCustomPrompt="1"/>
@@ -15301,7 +15393,7 @@
       </p:sp>
       <p:sp>
         <p:nvSpPr>
-          <p:cNvPr id="13" name="Text 3"/>
+          <p:cNvPr id="14" name="Text 3"/>
           <p:cNvSpPr txBox="1"/>
           <p:nvPr>
             <p:ph idx="106" type="body" hasCustomPrompt="1"/>
@@ -15790,7 +15882,7 @@
       </p:sp>
       <p:sp>
         <p:nvSpPr>
-          <p:cNvPr id="13" name="Text 3"/>
+          <p:cNvPr id="14" name="Text 3"/>
           <p:cNvSpPr txBox="1"/>
           <p:nvPr>
             <p:ph idx="106" type="body" hasCustomPrompt="1"/>
@@ -16059,7 +16151,35 @@
                 <a:ea typeface="Trade Gothic Next" pitchFamily="34" charset="-122"/>
                 <a:cs typeface="Trade Gothic Next" pitchFamily="34" charset="-120"/>
               </a:rPr>
-              <a:t>E₃ = −2.42 × 10^−19 J</a:t>
+              <a:t>E₃ = −2.42 × 10</a:t>
+            </a:r>
+            <a:pPr indent="0" marL="0">
+              <a:buNone/>
+            </a:pPr>
+            <a:r>
+              <a:rPr lang="en-US" sz="1600" baseline="30000" dirty="0">
+                <a:solidFill>
+                  <a:srgbClr val="14161B"/>
+                </a:solidFill>
+                <a:latin typeface="Trade Gothic Next" pitchFamily="34" charset="0"/>
+                <a:ea typeface="Trade Gothic Next" pitchFamily="34" charset="-122"/>
+                <a:cs typeface="Trade Gothic Next" pitchFamily="34" charset="-120"/>
+              </a:rPr>
+              <a:t>−19</a:t>
+            </a:r>
+            <a:pPr indent="0" marL="0">
+              <a:buNone/>
+            </a:pPr>
+            <a:r>
+              <a:rPr lang="en-US" sz="1600" dirty="0">
+                <a:solidFill>
+                  <a:srgbClr val="14161B"/>
+                </a:solidFill>
+                <a:latin typeface="Trade Gothic Next" pitchFamily="34" charset="0"/>
+                <a:ea typeface="Trade Gothic Next" pitchFamily="34" charset="-122"/>
+                <a:cs typeface="Trade Gothic Next" pitchFamily="34" charset="-120"/>
+              </a:rPr>
+              <a:t> J</a:t>
             </a:r>
             <a:endParaRPr lang="en-US" sz="1600" dirty="0"/>
           </a:p>
@@ -16076,7 +16196,35 @@
                 <a:ea typeface="Trade Gothic Next" pitchFamily="34" charset="-122"/>
                 <a:cs typeface="Trade Gothic Next" pitchFamily="34" charset="-120"/>
               </a:rPr>
-              <a:t>E₂ = −5.45 × 10^−19 J</a:t>
+              <a:t>E₂ = −5.45 × 10</a:t>
+            </a:r>
+            <a:pPr indent="0" marL="0">
+              <a:buNone/>
+            </a:pPr>
+            <a:r>
+              <a:rPr lang="en-US" sz="1600" baseline="30000" dirty="0">
+                <a:solidFill>
+                  <a:srgbClr val="14161B"/>
+                </a:solidFill>
+                <a:latin typeface="Trade Gothic Next" pitchFamily="34" charset="0"/>
+                <a:ea typeface="Trade Gothic Next" pitchFamily="34" charset="-122"/>
+                <a:cs typeface="Trade Gothic Next" pitchFamily="34" charset="-120"/>
+              </a:rPr>
+              <a:t>−19</a:t>
+            </a:r>
+            <a:pPr indent="0" marL="0">
+              <a:buNone/>
+            </a:pPr>
+            <a:r>
+              <a:rPr lang="en-US" sz="1600" dirty="0">
+                <a:solidFill>
+                  <a:srgbClr val="14161B"/>
+                </a:solidFill>
+                <a:latin typeface="Trade Gothic Next" pitchFamily="34" charset="0"/>
+                <a:ea typeface="Trade Gothic Next" pitchFamily="34" charset="-122"/>
+                <a:cs typeface="Trade Gothic Next" pitchFamily="34" charset="-120"/>
+              </a:rPr>
+              <a:t> J</a:t>
             </a:r>
             <a:endParaRPr lang="en-US" sz="1600" dirty="0"/>
           </a:p>
@@ -16336,7 +16484,7 @@
       </p:sp>
       <p:sp>
         <p:nvSpPr>
-          <p:cNvPr id="13" name="Text 4"/>
+          <p:cNvPr id="14" name="Text 4"/>
           <p:cNvSpPr txBox="1"/>
           <p:nvPr>
             <p:ph idx="107" hasCustomPrompt="1"/>
@@ -16646,7 +16794,21 @@
                 <a:ea typeface="Trade Gothic Next" pitchFamily="34" charset="-122"/>
                 <a:cs typeface="Trade Gothic Next" pitchFamily="34" charset="-120"/>
               </a:rPr>
-              <a:t>−5.45 × 10^−19</a:t>
+              <a:t>−5.45 × 10</a:t>
+            </a:r>
+            <a:pPr indent="0" marL="0">
+              <a:buNone/>
+            </a:pPr>
+            <a:r>
+              <a:rPr lang="en-US" sz="1900" baseline="30000" dirty="0">
+                <a:solidFill>
+                  <a:srgbClr val="14161B"/>
+                </a:solidFill>
+                <a:latin typeface="Trade Gothic Next" pitchFamily="34" charset="0"/>
+                <a:ea typeface="Trade Gothic Next" pitchFamily="34" charset="-122"/>
+                <a:cs typeface="Trade Gothic Next" pitchFamily="34" charset="-120"/>
+              </a:rPr>
+              <a:t>−19</a:t>
             </a:r>
             <a:endParaRPr lang="en-US" sz="1900" dirty="0"/>
           </a:p>
@@ -16663,7 +16825,35 @@
                 <a:ea typeface="Trade Gothic Next" pitchFamily="34" charset="-122"/>
                 <a:cs typeface="Trade Gothic Next" pitchFamily="34" charset="-120"/>
               </a:rPr>
-              <a:t>− (−2.42 × 10^−19)</a:t>
+              <a:t>− (−2.42 × 10</a:t>
+            </a:r>
+            <a:pPr indent="0" marL="0">
+              <a:buNone/>
+            </a:pPr>
+            <a:r>
+              <a:rPr lang="en-US" sz="1900" baseline="30000" dirty="0">
+                <a:solidFill>
+                  <a:srgbClr val="14161B"/>
+                </a:solidFill>
+                <a:latin typeface="Trade Gothic Next" pitchFamily="34" charset="0"/>
+                <a:ea typeface="Trade Gothic Next" pitchFamily="34" charset="-122"/>
+                <a:cs typeface="Trade Gothic Next" pitchFamily="34" charset="-120"/>
+              </a:rPr>
+              <a:t>−19</a:t>
+            </a:r>
+            <a:pPr indent="0" marL="0">
+              <a:buNone/>
+            </a:pPr>
+            <a:r>
+              <a:rPr lang="en-US" sz="1900" dirty="0">
+                <a:solidFill>
+                  <a:srgbClr val="14161B"/>
+                </a:solidFill>
+                <a:latin typeface="Trade Gothic Next" pitchFamily="34" charset="0"/>
+                <a:ea typeface="Trade Gothic Next" pitchFamily="34" charset="-122"/>
+                <a:cs typeface="Trade Gothic Next" pitchFamily="34" charset="-120"/>
+              </a:rPr>
+              <a:t>)</a:t>
             </a:r>
             <a:endParaRPr lang="en-US" sz="1900" dirty="0"/>
           </a:p>
@@ -16680,7 +16870,35 @@
                 <a:ea typeface="Trade Gothic Next" pitchFamily="34" charset="-122"/>
                 <a:cs typeface="Trade Gothic Next" pitchFamily="34" charset="-120"/>
               </a:rPr>
-              <a:t>= −3.03 × 10^−19 J</a:t>
+              <a:t>= −3.03 × 10</a:t>
+            </a:r>
+            <a:pPr indent="0" marL="0">
+              <a:buNone/>
+            </a:pPr>
+            <a:r>
+              <a:rPr lang="en-US" sz="1900" baseline="30000" dirty="0">
+                <a:solidFill>
+                  <a:srgbClr val="14161B"/>
+                </a:solidFill>
+                <a:latin typeface="Trade Gothic Next" pitchFamily="34" charset="0"/>
+                <a:ea typeface="Trade Gothic Next" pitchFamily="34" charset="-122"/>
+                <a:cs typeface="Trade Gothic Next" pitchFamily="34" charset="-120"/>
+              </a:rPr>
+              <a:t>−19</a:t>
+            </a:r>
+            <a:pPr indent="0" marL="0">
+              <a:buNone/>
+            </a:pPr>
+            <a:r>
+              <a:rPr lang="en-US" sz="1900" dirty="0">
+                <a:solidFill>
+                  <a:srgbClr val="14161B"/>
+                </a:solidFill>
+                <a:latin typeface="Trade Gothic Next" pitchFamily="34" charset="0"/>
+                <a:ea typeface="Trade Gothic Next" pitchFamily="34" charset="-122"/>
+                <a:cs typeface="Trade Gothic Next" pitchFamily="34" charset="-120"/>
+              </a:rPr>
+              <a:t> J</a:t>
             </a:r>
             <a:endParaRPr lang="en-US" sz="1900" dirty="0"/>
           </a:p>
@@ -16738,7 +16956,35 @@
                 <a:ea typeface="Trade Gothic Next" pitchFamily="34" charset="-122"/>
                 <a:cs typeface="Trade Gothic Next" pitchFamily="34" charset="-120"/>
               </a:rPr>
-              <a:t>Energy released: a photon of 3.03 × 10^−19 J leaves the atom.</a:t>
+              <a:t>Energy released: a photon of 3.03 × 10</a:t>
+            </a:r>
+            <a:pPr indent="0" marL="0">
+              <a:buNone/>
+            </a:pPr>
+            <a:r>
+              <a:rPr lang="en-US" sz="1600" b="1" baseline="30000" dirty="0">
+                <a:solidFill>
+                  <a:srgbClr val="EDF0E5"/>
+                </a:solidFill>
+                <a:latin typeface="Trade Gothic Next" pitchFamily="34" charset="0"/>
+                <a:ea typeface="Trade Gothic Next" pitchFamily="34" charset="-122"/>
+                <a:cs typeface="Trade Gothic Next" pitchFamily="34" charset="-120"/>
+              </a:rPr>
+              <a:t>−19</a:t>
+            </a:r>
+            <a:pPr indent="0" marL="0">
+              <a:buNone/>
+            </a:pPr>
+            <a:r>
+              <a:rPr lang="en-US" sz="1600" b="1" dirty="0">
+                <a:solidFill>
+                  <a:srgbClr val="EDF0E5"/>
+                </a:solidFill>
+                <a:latin typeface="Trade Gothic Next" pitchFamily="34" charset="0"/>
+                <a:ea typeface="Trade Gothic Next" pitchFamily="34" charset="-122"/>
+                <a:cs typeface="Trade Gothic Next" pitchFamily="34" charset="-120"/>
+              </a:rPr>
+              <a:t> J leaves the atom.</a:t>
             </a:r>
             <a:endParaRPr lang="en-US" sz="1600" dirty="0"/>
           </a:p>
@@ -16828,7 +17074,7 @@
       </p:sp>
       <p:sp>
         <p:nvSpPr>
-          <p:cNvPr id="11" name="Text 4"/>
+          <p:cNvPr id="12" name="Text 4"/>
           <p:cNvSpPr txBox="1"/>
           <p:nvPr>
             <p:ph idx="107" hasCustomPrompt="1"/>
@@ -17374,7 +17620,7 @@
       </p:sp>
       <p:sp>
         <p:nvSpPr>
-          <p:cNvPr id="13" name="Text 4"/>
+          <p:cNvPr id="14" name="Text 4"/>
           <p:cNvSpPr txBox="1"/>
           <p:nvPr>
             <p:ph idx="107" hasCustomPrompt="1"/>
@@ -17684,7 +17930,35 @@
                 <a:ea typeface="Trade Gothic Next" pitchFamily="34" charset="-122"/>
                 <a:cs typeface="Trade Gothic Next" pitchFamily="34" charset="-120"/>
               </a:rPr>
-              <a:t>E₁ = −2.18 × 10^−18 J</a:t>
+              <a:t>E₁ = −2.18 × 10</a:t>
+            </a:r>
+            <a:pPr indent="0" marL="0">
+              <a:buNone/>
+            </a:pPr>
+            <a:r>
+              <a:rPr lang="en-US" sz="1900" baseline="30000" dirty="0">
+                <a:solidFill>
+                  <a:srgbClr val="14161B"/>
+                </a:solidFill>
+                <a:latin typeface="Trade Gothic Next" pitchFamily="34" charset="0"/>
+                <a:ea typeface="Trade Gothic Next" pitchFamily="34" charset="-122"/>
+                <a:cs typeface="Trade Gothic Next" pitchFamily="34" charset="-120"/>
+              </a:rPr>
+              <a:t>−18</a:t>
+            </a:r>
+            <a:pPr indent="0" marL="0">
+              <a:buNone/>
+            </a:pPr>
+            <a:r>
+              <a:rPr lang="en-US" sz="1900" dirty="0">
+                <a:solidFill>
+                  <a:srgbClr val="14161B"/>
+                </a:solidFill>
+                <a:latin typeface="Trade Gothic Next" pitchFamily="34" charset="0"/>
+                <a:ea typeface="Trade Gothic Next" pitchFamily="34" charset="-122"/>
+                <a:cs typeface="Trade Gothic Next" pitchFamily="34" charset="-120"/>
+              </a:rPr>
+              <a:t> J</a:t>
             </a:r>
             <a:endParaRPr lang="en-US" sz="1900" dirty="0"/>
           </a:p>
@@ -17718,7 +17992,35 @@
                 <a:ea typeface="Trade Gothic Next" pitchFamily="34" charset="-122"/>
                 <a:cs typeface="Trade Gothic Next" pitchFamily="34" charset="-120"/>
               </a:rPr>
-              <a:t>= +2.18 × 10^−18 J</a:t>
+              <a:t>= +2.18 × 10</a:t>
+            </a:r>
+            <a:pPr indent="0" marL="0">
+              <a:buNone/>
+            </a:pPr>
+            <a:r>
+              <a:rPr lang="en-US" sz="1900" baseline="30000" dirty="0">
+                <a:solidFill>
+                  <a:srgbClr val="14161B"/>
+                </a:solidFill>
+                <a:latin typeface="Trade Gothic Next" pitchFamily="34" charset="0"/>
+                <a:ea typeface="Trade Gothic Next" pitchFamily="34" charset="-122"/>
+                <a:cs typeface="Trade Gothic Next" pitchFamily="34" charset="-120"/>
+              </a:rPr>
+              <a:t>−18</a:t>
+            </a:r>
+            <a:pPr indent="0" marL="0">
+              <a:buNone/>
+            </a:pPr>
+            <a:r>
+              <a:rPr lang="en-US" sz="1900" dirty="0">
+                <a:solidFill>
+                  <a:srgbClr val="14161B"/>
+                </a:solidFill>
+                <a:latin typeface="Trade Gothic Next" pitchFamily="34" charset="0"/>
+                <a:ea typeface="Trade Gothic Next" pitchFamily="34" charset="-122"/>
+                <a:cs typeface="Trade Gothic Next" pitchFamily="34" charset="-120"/>
+              </a:rPr>
+              <a:t> J</a:t>
             </a:r>
             <a:endParaRPr lang="en-US" sz="1900" dirty="0"/>
           </a:p>
@@ -17776,7 +18078,35 @@
                 <a:ea typeface="Trade Gothic Next" pitchFamily="34" charset="-122"/>
                 <a:cs typeface="Trade Gothic Next" pitchFamily="34" charset="-120"/>
               </a:rPr>
-              <a:t>A positive ΔE means energy absorbed. Ionizing hydrogen takes 2.18 × 10^−18 J.</a:t>
+              <a:t>A positive ΔE means energy absorbed. Ionizing hydrogen takes 2.18 × 10</a:t>
+            </a:r>
+            <a:pPr indent="0" marL="0">
+              <a:buNone/>
+            </a:pPr>
+            <a:r>
+              <a:rPr lang="en-US" sz="1600" b="1" baseline="30000" dirty="0">
+                <a:solidFill>
+                  <a:srgbClr val="EDF0E5"/>
+                </a:solidFill>
+                <a:latin typeface="Trade Gothic Next" pitchFamily="34" charset="0"/>
+                <a:ea typeface="Trade Gothic Next" pitchFamily="34" charset="-122"/>
+                <a:cs typeface="Trade Gothic Next" pitchFamily="34" charset="-120"/>
+              </a:rPr>
+              <a:t>−18</a:t>
+            </a:r>
+            <a:pPr indent="0" marL="0">
+              <a:buNone/>
+            </a:pPr>
+            <a:r>
+              <a:rPr lang="en-US" sz="1600" b="1" dirty="0">
+                <a:solidFill>
+                  <a:srgbClr val="EDF0E5"/>
+                </a:solidFill>
+                <a:latin typeface="Trade Gothic Next" pitchFamily="34" charset="0"/>
+                <a:ea typeface="Trade Gothic Next" pitchFamily="34" charset="-122"/>
+                <a:cs typeface="Trade Gothic Next" pitchFamily="34" charset="-120"/>
+              </a:rPr>
+              <a:t> J.</a:t>
             </a:r>
             <a:endParaRPr lang="en-US" sz="1600" dirty="0"/>
           </a:p>
@@ -17866,7 +18196,7 @@
       </p:sp>
       <p:sp>
         <p:nvSpPr>
-          <p:cNvPr id="11" name="Text 4"/>
+          <p:cNvPr id="12" name="Text 4"/>
           <p:cNvSpPr txBox="1"/>
           <p:nvPr>
             <p:ph idx="107" hasCustomPrompt="1"/>
@@ -18389,7 +18719,7 @@
       </p:sp>
       <p:sp>
         <p:nvSpPr>
-          <p:cNvPr id="13" name="Text 4"/>
+          <p:cNvPr id="14" name="Text 4"/>
           <p:cNvSpPr txBox="1"/>
           <p:nvPr>
             <p:ph idx="107" hasCustomPrompt="1"/>
@@ -18649,7 +18979,7 @@
       </p:sp>
       <p:sp>
         <p:nvSpPr>
-          <p:cNvPr id="7" name="Text 4"/>
+          <p:cNvPr id="8" name="Text 4"/>
           <p:cNvSpPr txBox="1"/>
           <p:nvPr>
             <p:ph idx="104" hasCustomPrompt="1"/>
@@ -18942,7 +19272,7 @@
                 <a:ea typeface="Trade Gothic Next" pitchFamily="34" charset="-122"/>
                 <a:cs typeface="Trade Gothic Next" pitchFamily="34" charset="-120"/>
               </a:rPr>
-              <a:t>Calculate the energy of the hydrogen electron at n = 2.</a:t>
+              <a:t>Calculate the energy of the hydrogen electron at n = 2.</a:t>
             </a:r>
             <a:endParaRPr lang="en-US" sz="1600" dirty="0"/>
           </a:p>
@@ -19024,7 +19354,7 @@
                 <a:ea typeface="Trade Gothic Next" pitchFamily="34" charset="-122"/>
                 <a:cs typeface="Trade Gothic Next" pitchFamily="34" charset="-120"/>
               </a:rPr>
-              <a:t>A hydrogen electron drops from n = 4 to n = 2. Is energy absorbed or released? How much?</a:t>
+              <a:t>A hydrogen electron drops from n = 4 to n = 2. Is energy absorbed or released? How much?</a:t>
             </a:r>
             <a:endParaRPr lang="en-US" sz="1600" dirty="0"/>
           </a:p>
@@ -19155,7 +19485,7 @@
       </p:sp>
       <p:sp>
         <p:nvSpPr>
-          <p:cNvPr id="13" name="Text 4"/>
+          <p:cNvPr id="14" name="Text 4"/>
           <p:cNvSpPr txBox="1"/>
           <p:nvPr>
             <p:ph idx="107" hasCustomPrompt="1"/>
@@ -19366,7 +19696,7 @@
                 <a:ea typeface="Trade Gothic Next" pitchFamily="34" charset="-122"/>
                 <a:cs typeface="Trade Gothic Next" pitchFamily="34" charset="-120"/>
               </a:rPr>
-              <a:t>Which drop releases more energy, n = 3 to n = 2 or n = 2 to n = 1? Find both ΔE values.</a:t>
+              <a:t>Which drop releases more energy, n = 3 to n = 2 or n = 2 to n = 1? Find both ΔE values.</a:t>
             </a:r>
             <a:endParaRPr lang="en-US" sz="1600" dirty="0"/>
           </a:p>
@@ -19489,7 +19819,7 @@
                 <a:ea typeface="Trade Gothic Next" pitchFamily="34" charset="-122"/>
                 <a:cs typeface="Trade Gothic Next" pitchFamily="34" charset="-120"/>
               </a:rPr>
-              <a:t>Check 4: put a number on both drops before you compare them.</a:t>
+              <a:t>ΔE = final energy minus initial energy.</a:t>
             </a:r>
             <a:endParaRPr lang="en-US" sz="1600" dirty="0"/>
           </a:p>
@@ -19579,7 +19909,7 @@
       </p:sp>
       <p:sp>
         <p:nvSpPr>
-          <p:cNvPr id="11" name="Text 3"/>
+          <p:cNvPr id="12" name="Text 3"/>
           <p:cNvSpPr txBox="1"/>
           <p:nvPr>
             <p:ph idx="106" hasCustomPrompt="1"/>
@@ -19772,7 +20102,7 @@
                 <a:ea typeface="Trade Gothic Next" pitchFamily="34" charset="-122"/>
                 <a:cs typeface="Trade Gothic Next" pitchFamily="34" charset="-120"/>
               </a:rPr>
-              <a:t>Bohr's model works for hydrogen and nothing bigger. Next: what replaced it, and what an orbital is.</a:t>
+              <a:t>Bohr's model works for hydrogen, not for atoms with 2 or more electrons. Next: what replaced it, and what an orbital is.</a:t>
             </a:r>
             <a:endParaRPr lang="en-US" sz="1600" dirty="0"/>
           </a:p>
@@ -19821,7 +20151,7 @@
       </p:sp>
       <p:sp>
         <p:nvSpPr>
-          <p:cNvPr id="6" name="Text 2"/>
+          <p:cNvPr id="7" name="Text 2"/>
           <p:cNvSpPr txBox="1"/>
           <p:nvPr>
             <p:ph idx="102" hasCustomPrompt="1"/>
@@ -20378,7 +20708,7 @@
       </p:sp>
       <p:sp>
         <p:nvSpPr>
-          <p:cNvPr id="13" name="Text 4"/>
+          <p:cNvPr id="14" name="Text 4"/>
           <p:cNvSpPr txBox="1"/>
           <p:nvPr>
             <p:ph idx="107" hasCustomPrompt="1"/>
@@ -20848,7 +21178,7 @@
       </p:sp>
       <p:sp>
         <p:nvSpPr>
-          <p:cNvPr id="11" name="Text 3"/>
+          <p:cNvPr id="12" name="Text 3"/>
           <p:cNvSpPr txBox="1"/>
           <p:nvPr>
             <p:ph idx="106" hasCustomPrompt="1"/>
@@ -21371,7 +21701,7 @@
       </p:sp>
       <p:sp>
         <p:nvSpPr>
-          <p:cNvPr id="13" name="Text 4"/>
+          <p:cNvPr id="14" name="Text 4"/>
           <p:cNvSpPr txBox="1"/>
           <p:nvPr>
             <p:ph idx="107" hasCustomPrompt="1"/>
@@ -21860,7 +22190,7 @@
       </p:sp>
       <p:sp>
         <p:nvSpPr>
-          <p:cNvPr id="13" name="Text 3"/>
+          <p:cNvPr id="14" name="Text 3"/>
           <p:cNvSpPr txBox="1"/>
           <p:nvPr>
             <p:ph idx="106" type="body" hasCustomPrompt="1"/>
@@ -22330,7 +22660,7 @@
       </p:sp>
       <p:sp>
         <p:nvSpPr>
-          <p:cNvPr id="11" name="Text 3"/>
+          <p:cNvPr id="12" name="Text 3"/>
           <p:cNvSpPr txBox="1"/>
           <p:nvPr>
             <p:ph idx="106" hasCustomPrompt="1"/>
@@ -22819,7 +23149,7 @@
       </p:sp>
       <p:sp>
         <p:nvSpPr>
-          <p:cNvPr id="13" name="Text 3"/>
+          <p:cNvPr id="14" name="Text 3"/>
           <p:cNvSpPr txBox="1"/>
           <p:nvPr>
             <p:ph idx="106" type="body" hasCustomPrompt="1"/>
@@ -23308,7 +23638,7 @@
       </p:sp>
       <p:sp>
         <p:nvSpPr>
-          <p:cNvPr id="13" name="Text 3"/>
+          <p:cNvPr id="14" name="Text 3"/>
           <p:cNvSpPr txBox="1"/>
           <p:nvPr>
             <p:ph idx="106" type="body" hasCustomPrompt="1"/>

</xml_diff>

<commit_message>
Chemistry U2 S2.1: remove scientific notation and energy calculations; regenerate image prompts; mark briefs as historical
Co-Authored-By: Claude Sonnet 5.5 <noreply@anthropic.com>
Claude-Session: https://claude.ai/code/session_01CAqidLLu6PiYNMcZx5qMsE
</commit_message>
<xml_diff>
--- a/deliverables/chem-u02/SHULL_CHEM_Slides_U02_S02.1.pptx
+++ b/deliverables/chem-u02/SHULL_CHEM_Slides_U02_S02.1.pptx
@@ -523,7 +523,7 @@
           <a:p>
             <a:r>
               <a:rPr lang="en-US" dirty="0"/>
-              <a:t>Targets: describe Bohr's hydrogen model; use E_n = −2.18 × 10^{−18} J ÷ n² for a level energy and ΔE; explain emission and absorption; state the model's limits. Hook is the next slide. PROVISIONAL (brief flag F1, Matt to confirm): E_n needs scientific notation, but the course sequencing rule delays scientific notation and heavy math. Plan used: a pre-built table plus ONE student calculation, 3 sig figs, no sig-fig rules taught. Image prompt (empty slot): a hydrogen gas discharge tube glowing pink-magenta on a dark bench, lit only by its own light.</a:t>
+              <a:t>Targets: describe Bohr's hydrogen model; explain that energy levels are quantized (stairs, not a ramp); tell ground state from excited state; explain absorption (electron up) and emission (electron down, photon out); compare drops by size without calculating; describe ionization as the electron leaving; state the model's limits. Hook is the next slide. Calculations removed on Matt's instruction (brief flag F1, scientific notation vs the sequencing rule, no longer applies). Numbers deliberately omitted per Matt; see S2.5 for wavelengths in nm. Image prompt (empty slot): a hydrogen gas discharge tube glowing pink-magenta on a dark bench, lit only by its own light.</a:t>
             </a:r>
             <a:endParaRPr lang="en-US" dirty="0"/>
           </a:p>
@@ -611,7 +611,7 @@
           <a:p>
             <a:r>
               <a:rPr lang="en-US" dirty="0"/>
-              <a:t>Worked together. Answer: 3² = 9; −2.18 × 10^{−18} ÷ 9 = −2.42 × 10^{−19} J. Students write the setup, not just the number. Image prompt (empty slot): a pencil resting beside a scientific calculator on a lab notebook.</a:t>
+              <a:t>Ground state is n = 1. Excited states are any higher n and are short-lived. Image prompt (empty slot): two hydrogen discharge tubes side by side, one dark and one glowing.</a:t>
             </a:r>
             <a:endParaRPr lang="en-US" dirty="0"/>
           </a:p>
@@ -699,7 +699,7 @@
           <a:p>
             <a:r>
               <a:rPr lang="en-US" dirty="0"/>
-              <a:t>Check against slide 9: −2.42 × 10^{−19} is less negative than E₂ = −5.45 × 10^{−19}, so E₃ is higher. Calculator use is fine; 3 sig figs, no sig-fig rules taught.</a:t>
+              <a:t>Absorption: the electron rises only if the photon energy matches the gap between the two levels exactly. Wrong-energy photons pass through. Misconception: that any photon will do.</a:t>
             </a:r>
             <a:endParaRPr lang="en-US" dirty="0"/>
           </a:p>
@@ -787,7 +787,7 @@
           <a:p>
             <a:r>
               <a:rPr lang="en-US" dirty="0"/>
-              <a:t>Ground state is n = 1. Excited states are any higher n and are short-lived. Image prompt (empty slot): two hydrogen discharge tubes side by side, one dark and one glowing.</a:t>
+              <a:t>Emission: the electron drops and a photon leaves carrying the energy the atom loses. A bigger drop is a higher-energy photon. Misconception: emission means the electron goes up. It drops. Colors and wavelengths are S2.5, not here.</a:t>
             </a:r>
             <a:endParaRPr lang="en-US" dirty="0"/>
           </a:p>
@@ -875,7 +875,7 @@
           <a:p>
             <a:r>
               <a:rPr lang="en-US" dirty="0"/>
-              <a:t>Absorption: the electron rises only if the photon energy equals exactly E final minus E initial. Wrong-energy photons pass through. Misconception: that any photon will do.</a:t>
+              <a:t>Worked together, after slides 10 and 11 (ground state, absorption). Answer: not the ground state, because the ground state is n = 1 and n = 3 is higher, so the electron is excited. To reach n = 5 it must absorb energy, a photon that matches the gap from n = 3 to n = 5 exactly. A photon that is too small or too large passes through. Students write the reasoning in the work area. Image prompt (empty slot): a pencil resting beside a lab notebook open to a hand-drawn ladder of energy levels.</a:t>
             </a:r>
             <a:endParaRPr lang="en-US" dirty="0"/>
           </a:p>
@@ -963,7 +963,7 @@
           <a:p>
             <a:r>
               <a:rPr lang="en-US" dirty="0"/>
-              <a:t>Emission: the electron drops and a photon leaves with energy |ΔE|. A bigger drop is a higher-energy photon. Misconception: emission means the electron goes up. It drops. Colors and wavelengths are S2.5, not here.</a:t>
+              <a:t>Check against the earlier slides: ground state is n = 1; absorption moves the electron up and needs an exact energy match. The figure is not to scale (at true scale n = 3, 4 and 5 are too close to draw an arrow). No numbers needed.</a:t>
             </a:r>
             <a:endParaRPr lang="en-US" dirty="0"/>
           </a:p>
@@ -1051,7 +1051,7 @@
           <a:p>
             <a:r>
               <a:rPr lang="en-US" dirty="0"/>
-              <a:t>Worked together. Answer: ΔE = E₂ − E₃ = −5.45 × 10^{−19} − (−2.42 × 10^{−19}) = −3.03 × 10^{−19} J. Negative, so energy is released. Image prompt (empty slot): a camera-flash bulb mid-discharge in a dark room.</a:t>
+              <a:t>Worked together. Leave the energy-levels slide (slide 9) up or flip back to it: the ranking uses the vertical gaps on that diagram, no formula. Answer: B (3 to 2) least, then A (4 to 2), then C (2 to 1) most. The bluest light comes from C, the most energy: more energy means a shorter wavelength, which is bluer. Accuracy note: C is really ultraviolet, beyond violet, so 'bluest' means furthest toward the blue-violet end; B is red and A is blue-green. S2.5 gives the wavelengths in nm. Image prompt (empty slot): a camera-flash bulb mid-discharge in a dark room.</a:t>
             </a:r>
             <a:endParaRPr lang="en-US" dirty="0"/>
           </a:p>
@@ -1139,7 +1139,7 @@
           <a:p>
             <a:r>
               <a:rPr lang="en-US" dirty="0"/>
-              <a:t>Final minus initial, keep the negatives. Photon energy is 3.03 × 10^{−19} J. Do not calculate its wavelength; that is S2.5.</a:t>
+              <a:t>Read the arrows: C is longest, then A, then B. The figure is to scale in spacing, so arrow length is the ranking. Bluer means shorter wavelength and higher energy, stated qualitatively; no wavelengths here (S2.5). C is ultraviolet in fact: say so if a student asks.</a:t>
             </a:r>
             <a:endParaRPr lang="en-US" dirty="0"/>
           </a:p>
@@ -1227,7 +1227,7 @@
           <a:p>
             <a:r>
               <a:rPr lang="en-US" dirty="0"/>
-              <a:t>Worked together. Answer: n = 1 to ∞, ΔE = 0 − (−2.18 × 10^{−18}) = +2.18 × 10^{−18} J, absorbed. Image prompt (empty slot): a spark gap between two electrodes in a dark lab.</a:t>
+              <a:t>Worked together. Answer: the electron climbs to the top of the diagram, n = ∞, which means it is no longer in the atom. Hydrogen is left with its proton and no electron: a positive ion (an atom with more protons than electrons). Qualitative only; no energy value. Extension: in an atom with more electrons the outermost electron is the one that leaves first (S2.4 and U3 develop this). Image prompt (empty slot): a spark gap between two electrodes in a dark lab.</a:t>
             </a:r>
             <a:endParaRPr lang="en-US" dirty="0"/>
           </a:p>
@@ -1315,7 +1315,7 @@
           <a:p>
             <a:r>
               <a:rPr lang="en-US" dirty="0"/>
-              <a:t>Positive ΔE means absorbed. Ionization energy of ground-state hydrogen is 2.18 × 10^{−18} J.</a:t>
+              <a:t>Positive ion: the atom lost an electron, so it has more protons than electrons. Hydrogen with its one electron gone is just a proton. Energy goes in, so this is absorption, like slide 11, but the electron does not stop at a level. Outermost-electron-first is an extension for atoms with more electrons; do not push it for hydrogen.</a:t>
             </a:r>
             <a:endParaRPr lang="en-US" dirty="0"/>
           </a:p>
@@ -1491,7 +1491,7 @@
           <a:p>
             <a:r>
               <a:rPr lang="en-US" dirty="0"/>
-              <a:t>Pose the question and leave it open; it is answered by slide 20. Do not name quantization yet. Image prompt (empty slot): a glowing hydrogen discharge tube photographed close, with a prism-split smear of four thin colored lines beside it.</a:t>
+              <a:t>Pose the question and leave it open; it is answered across slides 5 to 12 and checked on slide 20. Do not name quantization yet. Image prompt (empty slot): a glowing hydrogen discharge tube photographed close, with a prism-split smear of four thin colored lines beside it.</a:t>
             </a:r>
             <a:endParaRPr lang="en-US" dirty="0"/>
           </a:p>
@@ -1579,7 +1579,7 @@
           <a:p>
             <a:r>
               <a:rPr lang="en-US" dirty="0"/>
-              <a:t>Check answers. 1: Electron energy is quantized, so only certain level differences exist and only certain photon energies, hence certain colors. 2: E₂ = −2.18 × 10^{−18} ÷ 4 = −5.45 × 10^{−19} J. 3: Emitted. E₄ = −1.36 × 10^{−19}, E₂ = −5.45 × 10^{−19}, ΔE = −4.09 × 10^{−19} J, so 4.09 × 10^{−19} J leaves the atom. Image prompt (empty slot): a student's notebook page with a calculation crossed out and redone.</a:t>
+              <a:t>Check answers. 1: Electron energy is quantized, so only certain gaps between levels exist and only certain photon energies, hence certain colors. 2: Emitted. The electron drops, a photon leaves, and the atom loses energy. 3: Nothing: the photon passes through. No level lies between n = 1 and n = 2, so the electron can only absorb a photon that matches the gap exactly. Image prompt (empty slot): a student's notebook page with an answer crossed out and rewritten.</a:t>
             </a:r>
             <a:endParaRPr lang="en-US" dirty="0"/>
           </a:p>
@@ -1667,7 +1667,7 @@
           <a:p>
             <a:r>
               <a:rPr lang="en-US" dirty="0"/>
-              <a:t>Check answers. 4: n = 2 to 1 releases more. ΔE(3→2) = −3.03 × 10^{−19} J; ΔE(2→1) = −2.18 × 10^{−18} − (−5.45 × 10^{−19}) = −1.64 × 10^{−18} J. 5: any one of: works only for hydrogen; cannot predict multi-electron atoms; electrons are not particles in circular orbits. Image prompt (empty slot): a stack of graded quiz papers with a red pen on top.</a:t>
+              <a:t>Check answers. 4: n = 2 to n = 1 releases more, because the gap between n = 1 and n = 2 is much bigger than the gap between n = 2 and n = 3 (the levels crowd together as n rises). 5: any one of: works only for hydrogen; cannot handle atoms with 2 or more electrons; electrons are not particles in circular orbits. Image prompt (empty slot): a stack of graded quiz papers with a red pen on top.</a:t>
             </a:r>
             <a:endParaRPr lang="en-US" dirty="0"/>
           </a:p>
@@ -2107,7 +2107,7 @@
           <a:p>
             <a:r>
               <a:rPr lang="en-US" dirty="0"/>
-              <a:t>Diagram: one proton, one electron, here at n = 1. Orbit radii run 1 : 4 : 9. This is the model's picture, not reality; slide 19 returns to that.</a:t>
+              <a:t>Diagram: one proton, one electron, here at n = 1. Orbits drawn at 1 : 4 : 9 spacing. This is the model's picture, not reality; slide 19 returns to that.</a:t>
             </a:r>
             <a:endParaRPr lang="en-US" dirty="0"/>
           </a:p>
@@ -2283,7 +2283,7 @@
           <a:p>
             <a:r>
               <a:rPr lang="en-US" dirty="0"/>
-              <a:t>Equation: E_n = −2.18 × 10^{−18} J ÷ n². n is a whole number. Negative means bound; E = 0 is a free electron. Hydrogen only. PROVISIONAL (brief flag F1, Matt to confirm): E_n needs scientific notation, but the course sequencing rule delays scientific notation and heavy math. Plan used: a pre-built table plus ONE student calculation, 3 sig figs, no sig-fig rules taught.</a:t>
+              <a:t>Level numbers: n is a whole number; there is no level between n = 1 and n = 2. Higher n is higher energy, drawn higher on the page. Spacing is to scale in shape: the gaps shrink as n rises. No equation and no energy values on purpose (Matt's instruction). Hydrogen only.</a:t>
             </a:r>
             <a:endParaRPr lang="en-US" dirty="0"/>
           </a:p>
@@ -2371,7 +2371,7 @@
           <a:p>
             <a:r>
               <a:rPr lang="en-US" dirty="0"/>
-              <a:t>Values to n = 6: n=1 −2.18 × 10^{−18} J; n=2 −5.45 × 10^{−19}; n=3 −2.42 × 10^{−19}; n=4 −1.36 × 10^{−19}; n=5 −8.72 × 10^{−20}; n=6 −6.06 × 10^{−20}. Spacing is drawn to scale. Misconception: more negative means more energy. It means lower. n = ∞ is E = 0.</a:t>
+              <a:t>Gaps between levels shrink as n rises: the biggest gap is n = 1 to n = 2. No energy values printed on purpose (Matt's instruction). Misconception: that the levels are evenly spaced. Higher on the page means more energy. n = ∞ marks the electron leaving the atom.</a:t>
             </a:r>
             <a:endParaRPr lang="en-US" dirty="0"/>
           </a:p>
@@ -13303,7 +13303,7 @@
                 <a:ea typeface="Trade Gothic Next" pitchFamily="34" charset="-122"/>
                 <a:cs typeface="Trade Gothic Next" pitchFamily="34" charset="-120"/>
               </a:rPr>
-              <a:t>Find hydrogen's energy levels, and explain emission and absorption as an electron changing level.</a:t>
+              <a:t>Describe hydrogen's energy levels, and explain emission and absorption as an electron changing level.</a:t>
             </a:r>
             <a:endParaRPr lang="en-US" sz="1600" dirty="0"/>
           </a:p>
@@ -13416,7 +13416,7 @@
         <p:spPr>
           <a:xfrm>
             <a:off x="685800" y="932688"/>
-            <a:ext cx="7863840" cy="868680"/>
+            <a:ext cx="10820095" cy="868680"/>
           </a:xfrm>
           <a:prstGeom prst="rect">
             <a:avLst/>
@@ -13440,7 +13440,7 @@
                 <a:ea typeface="Trade Gothic Next" pitchFamily="34" charset="-122"/>
                 <a:cs typeface="Trade Gothic Next" pitchFamily="34" charset="-120"/>
               </a:rPr>
-              <a:t>Example: Energy at n = 3</a:t>
+              <a:t>Ground State and Excited States</a:t>
             </a:r>
             <a:endParaRPr lang="en-US" sz="2800" dirty="0"/>
           </a:p>
@@ -13457,7 +13457,7 @@
         <p:spPr>
           <a:xfrm>
             <a:off x="685800" y="1847088"/>
-            <a:ext cx="7863840" cy="384048"/>
+            <a:ext cx="10820095" cy="384048"/>
           </a:xfrm>
           <a:prstGeom prst="rect">
             <a:avLst/>
@@ -13481,7 +13481,7 @@
                 <a:ea typeface="Trade Gothic Next" pitchFamily="34" charset="-122"/>
                 <a:cs typeface="Trade Gothic Next" pitchFamily="34" charset="-120"/>
               </a:rPr>
-              <a:t>We do this one together. Write the setup, not just the number.</a:t>
+              <a:t>Hydrogen's electron has one lowest level and many higher ones.</a:t>
             </a:r>
             <a:endParaRPr lang="en-US" sz="1700" dirty="0"/>
           </a:p>
@@ -13489,16 +13489,16 @@
       </p:sp>
       <p:sp>
         <p:nvSpPr>
-          <p:cNvPr id="4" name="Text 6"/>
-          <p:cNvSpPr txBox="1"/>
-          <p:nvPr>
-            <p:ph idx="110" type="body" hasCustomPrompt="1"/>
-          </p:nvPr>
-        </p:nvSpPr>
-        <p:spPr>
-          <a:xfrm>
-            <a:off x="886968" y="2798064"/>
-            <a:ext cx="4992624" cy="548640"/>
+          <p:cNvPr id="4" name="Text 4"/>
+          <p:cNvSpPr txBox="1"/>
+          <p:nvPr>
+            <p:ph idx="108" type="body" hasCustomPrompt="1"/>
+          </p:nvPr>
+        </p:nvSpPr>
+        <p:spPr>
+          <a:xfrm>
+            <a:off x="5733288" y="2542032"/>
+            <a:ext cx="2752344" cy="219456"/>
           </a:xfrm>
           <a:prstGeom prst="rect">
             <a:avLst/>
@@ -13514,83 +13514,187 @@
               <a:buNone/>
             </a:pPr>
             <a:r>
+              <a:rPr lang="en-US" sz="1200" b="1" spc="120" kern="0" dirty="0">
+                <a:solidFill>
+                  <a:srgbClr val="2E3338"/>
+                </a:solidFill>
+                <a:latin typeface="Trade Gothic Next" pitchFamily="34" charset="0"/>
+                <a:ea typeface="Trade Gothic Next" pitchFamily="34" charset="-122"/>
+                <a:cs typeface="Trade Gothic Next" pitchFamily="34" charset="-120"/>
+              </a:rPr>
+              <a:t>GROUND STATE</a:t>
+            </a:r>
+            <a:endParaRPr lang="en-US" sz="1200" dirty="0"/>
+          </a:p>
+        </p:txBody>
+      </p:sp>
+      <p:sp>
+        <p:nvSpPr>
+          <p:cNvPr id="5" name="Text 4"/>
+          <p:cNvSpPr txBox="1"/>
+          <p:nvPr>
+            <p:ph idx="109" type="body" hasCustomPrompt="1"/>
+          </p:nvPr>
+        </p:nvSpPr>
+        <p:spPr>
+          <a:xfrm>
+            <a:off x="5733288" y="2834640"/>
+            <a:ext cx="2752344" cy="1965960"/>
+          </a:xfrm>
+          <a:prstGeom prst="rect">
+            <a:avLst/>
+          </a:prstGeom>
+          <a:noFill/>
+          <a:ln/>
+        </p:spPr>
+        <p:txBody>
+          <a:bodyPr wrap="square" lIns="0" tIns="0" rIns="0" bIns="0" rtlCol="0"/>
+          <a:lstStyle/>
+          <a:p>
+            <a:pPr indent="0" marL="0">
+              <a:buNone/>
+            </a:pPr>
+            <a:r>
               <a:rPr lang="en-US" sz="1600" dirty="0">
                 <a:solidFill>
+                  <a:srgbClr val="14161B"/>
+                </a:solidFill>
+                <a:latin typeface="Trade Gothic Next" pitchFamily="34" charset="0"/>
+                <a:ea typeface="Trade Gothic Next" pitchFamily="34" charset="-122"/>
+                <a:cs typeface="Trade Gothic Next" pitchFamily="34" charset="-120"/>
+              </a:rPr>
+              <a:t>n = 1.</a:t>
+            </a:r>
+            <a:endParaRPr lang="en-US" sz="1600" dirty="0"/>
+          </a:p>
+          <a:p>
+            <a:pPr indent="0" marL="0">
+              <a:buNone/>
+            </a:pPr>
+            <a:r>
+              <a:rPr lang="en-US" sz="1600" dirty="0">
+                <a:solidFill>
+                  <a:srgbClr val="14161B"/>
+                </a:solidFill>
+                <a:latin typeface="Trade Gothic Next" pitchFamily="34" charset="0"/>
+                <a:ea typeface="Trade Gothic Next" pitchFamily="34" charset="-122"/>
+                <a:cs typeface="Trade Gothic Next" pitchFamily="34" charset="-120"/>
+              </a:rPr>
+              <a:t>The lowest energy level.</a:t>
+            </a:r>
+            <a:endParaRPr lang="en-US" sz="1600" dirty="0"/>
+          </a:p>
+          <a:p>
+            <a:pPr indent="0" marL="0">
+              <a:buNone/>
+            </a:pPr>
+            <a:endParaRPr lang="en-US" sz="1600" dirty="0"/>
+          </a:p>
+          <a:p>
+            <a:pPr indent="0" marL="0">
+              <a:buNone/>
+            </a:pPr>
+            <a:r>
+              <a:rPr lang="en-US" sz="1600" dirty="0">
+                <a:solidFill>
+                  <a:srgbClr val="14161B"/>
+                </a:solidFill>
+                <a:latin typeface="Trade Gothic Next" pitchFamily="34" charset="0"/>
+                <a:ea typeface="Trade Gothic Next" pitchFamily="34" charset="-122"/>
+                <a:cs typeface="Trade Gothic Next" pitchFamily="34" charset="-120"/>
+              </a:rPr>
+              <a:t>Where the electron normally sits.</a:t>
+            </a:r>
+            <a:endParaRPr lang="en-US" sz="1600" dirty="0"/>
+          </a:p>
+        </p:txBody>
+      </p:sp>
+      <p:sp>
+        <p:nvSpPr>
+          <p:cNvPr id="6" name="Text 5"/>
+          <p:cNvSpPr txBox="1"/>
+          <p:nvPr>
+            <p:ph idx="111" type="body" hasCustomPrompt="1"/>
+          </p:nvPr>
+        </p:nvSpPr>
+        <p:spPr>
+          <a:xfrm>
+            <a:off x="9116568" y="2542032"/>
+            <a:ext cx="2752344" cy="219456"/>
+          </a:xfrm>
+          <a:prstGeom prst="rect">
+            <a:avLst/>
+          </a:prstGeom>
+          <a:noFill/>
+          <a:ln/>
+        </p:spPr>
+        <p:txBody>
+          <a:bodyPr wrap="square" lIns="0" tIns="0" rIns="0" bIns="0" rtlCol="0"/>
+          <a:lstStyle/>
+          <a:p>
+            <a:pPr indent="0" marL="0">
+              <a:buNone/>
+            </a:pPr>
+            <a:r>
+              <a:rPr lang="en-US" sz="1200" b="1" spc="120" kern="0" dirty="0">
+                <a:solidFill>
+                  <a:srgbClr val="BDB6AA"/>
+                </a:solidFill>
+                <a:latin typeface="Trade Gothic Next" pitchFamily="34" charset="0"/>
+                <a:ea typeface="Trade Gothic Next" pitchFamily="34" charset="-122"/>
+                <a:cs typeface="Trade Gothic Next" pitchFamily="34" charset="-120"/>
+              </a:rPr>
+              <a:t>EXCITED STATE</a:t>
+            </a:r>
+            <a:endParaRPr lang="en-US" sz="1200" dirty="0"/>
+          </a:p>
+        </p:txBody>
+      </p:sp>
+      <p:sp>
+        <p:nvSpPr>
+          <p:cNvPr id="7" name="Text 5"/>
+          <p:cNvSpPr txBox="1"/>
+          <p:nvPr>
+            <p:ph idx="112" type="body" hasCustomPrompt="1"/>
+          </p:nvPr>
+        </p:nvSpPr>
+        <p:spPr>
+          <a:xfrm>
+            <a:off x="9116568" y="2834640"/>
+            <a:ext cx="2752344" cy="1965960"/>
+          </a:xfrm>
+          <a:prstGeom prst="rect">
+            <a:avLst/>
+          </a:prstGeom>
+          <a:noFill/>
+          <a:ln/>
+        </p:spPr>
+        <p:txBody>
+          <a:bodyPr wrap="square" lIns="0" tIns="0" rIns="0" bIns="0" rtlCol="0"/>
+          <a:lstStyle/>
+          <a:p>
+            <a:pPr indent="0" marL="0">
+              <a:buNone/>
+            </a:pPr>
+            <a:r>
+              <a:rPr lang="en-US" sz="1600" dirty="0">
+                <a:solidFill>
                   <a:srgbClr val="EDF0E5"/>
                 </a:solidFill>
                 <a:latin typeface="Trade Gothic Next" pitchFamily="34" charset="0"/>
                 <a:ea typeface="Trade Gothic Next" pitchFamily="34" charset="-122"/>
                 <a:cs typeface="Trade Gothic Next" pitchFamily="34" charset="-120"/>
               </a:rPr>
-              <a:t>What is the energy of the hydrogen electron when n = 3?</a:t>
+              <a:t>Any level above n = 1.</a:t>
             </a:r>
             <a:endParaRPr lang="en-US" sz="1600" dirty="0"/>
           </a:p>
-        </p:txBody>
-      </p:sp>
-      <p:sp>
-        <p:nvSpPr>
-          <p:cNvPr id="5" name="Text 7"/>
-          <p:cNvSpPr txBox="1"/>
-          <p:nvPr>
-            <p:ph idx="112" type="body" hasCustomPrompt="1"/>
-          </p:nvPr>
-        </p:nvSpPr>
-        <p:spPr>
-          <a:xfrm>
-            <a:off x="886968" y="3776472"/>
-            <a:ext cx="2203704" cy="219456"/>
-          </a:xfrm>
-          <a:prstGeom prst="rect">
-            <a:avLst/>
-          </a:prstGeom>
-          <a:noFill/>
-          <a:ln/>
-        </p:spPr>
-        <p:txBody>
-          <a:bodyPr wrap="square" lIns="0" tIns="0" rIns="0" bIns="0" rtlCol="0"/>
-          <a:lstStyle/>
-          <a:p>
-            <a:pPr indent="0" marL="0">
-              <a:buNone/>
-            </a:pPr>
-            <a:r>
-              <a:rPr lang="en-US" sz="1200" b="1" spc="120" kern="0" dirty="0">
-                <a:solidFill>
-                  <a:srgbClr val="2E3338"/>
-                </a:solidFill>
-                <a:latin typeface="Trade Gothic Next" pitchFamily="34" charset="0"/>
-                <a:ea typeface="Trade Gothic Next" pitchFamily="34" charset="-122"/>
-                <a:cs typeface="Trade Gothic Next" pitchFamily="34" charset="-120"/>
-              </a:rPr>
-              <a:t>GIVEN</a:t>
-            </a:r>
-            <a:endParaRPr lang="en-US" sz="1200" dirty="0"/>
-          </a:p>
-        </p:txBody>
-      </p:sp>
-      <p:sp>
-        <p:nvSpPr>
-          <p:cNvPr id="6" name="Text 7"/>
-          <p:cNvSpPr txBox="1"/>
-          <p:nvPr>
-            <p:ph idx="113" type="body" hasCustomPrompt="1"/>
-          </p:nvPr>
-        </p:nvSpPr>
-        <p:spPr>
-          <a:xfrm>
-            <a:off x="886968" y="4069080"/>
-            <a:ext cx="2203704" cy="1078992"/>
-          </a:xfrm>
-          <a:prstGeom prst="rect">
-            <a:avLst/>
-          </a:prstGeom>
-          <a:noFill/>
-          <a:ln/>
-        </p:spPr>
-        <p:txBody>
-          <a:bodyPr wrap="square" lIns="0" tIns="0" rIns="0" bIns="0" rtlCol="0"/>
-          <a:lstStyle/>
+          <a:p>
+            <a:pPr indent="0" marL="0">
+              <a:buNone/>
+            </a:pPr>
+            <a:endParaRPr lang="en-US" sz="1600" dirty="0"/>
+          </a:p>
           <a:p>
             <a:pPr indent="0" marL="0">
               <a:buNone/>
@@ -13598,30 +13702,54 @@
             <a:r>
               <a:rPr lang="en-US" sz="1600" dirty="0">
                 <a:solidFill>
-                  <a:srgbClr val="14161B"/>
-                </a:solidFill>
-                <a:latin typeface="Trade Gothic Next" pitchFamily="34" charset="0"/>
-                <a:ea typeface="Trade Gothic Next" pitchFamily="34" charset="-122"/>
-                <a:cs typeface="Trade Gothic Next" pitchFamily="34" charset="-120"/>
-              </a:rPr>
-              <a:t>Hydrogen</a:t>
+                  <a:srgbClr val="EDF0E5"/>
+                </a:solidFill>
+                <a:latin typeface="Trade Gothic Next" pitchFamily="34" charset="0"/>
+                <a:ea typeface="Trade Gothic Next" pitchFamily="34" charset="-122"/>
+                <a:cs typeface="Trade Gothic Next" pitchFamily="34" charset="-120"/>
+              </a:rPr>
+              <a:t>Short-lived. The electron falls back down.</a:t>
             </a:r>
             <a:endParaRPr lang="en-US" sz="1600" dirty="0"/>
           </a:p>
-          <a:p>
-            <a:pPr indent="0" marL="0">
-              <a:buNone/>
-            </a:pPr>
-            <a:r>
-              <a:rPr lang="en-US" sz="1600" dirty="0">
-                <a:solidFill>
-                  <a:srgbClr val="14161B"/>
-                </a:solidFill>
-                <a:latin typeface="Trade Gothic Next" pitchFamily="34" charset="0"/>
-                <a:ea typeface="Trade Gothic Next" pitchFamily="34" charset="-122"/>
-                <a:cs typeface="Trade Gothic Next" pitchFamily="34" charset="-120"/>
-              </a:rPr>
-              <a:t>n = 3</a:t>
+        </p:txBody>
+      </p:sp>
+      <p:sp>
+        <p:nvSpPr>
+          <p:cNvPr id="8" name="Text 7"/>
+          <p:cNvSpPr txBox="1"/>
+          <p:nvPr>
+            <p:ph idx="115" type="body" hasCustomPrompt="1"/>
+          </p:nvPr>
+        </p:nvSpPr>
+        <p:spPr>
+          <a:xfrm>
+            <a:off x="2240280" y="5394960"/>
+            <a:ext cx="8991295" cy="402336"/>
+          </a:xfrm>
+          <a:prstGeom prst="rect">
+            <a:avLst/>
+          </a:prstGeom>
+          <a:noFill/>
+          <a:ln/>
+        </p:spPr>
+        <p:txBody>
+          <a:bodyPr wrap="square" lIns="0" tIns="0" rIns="0" bIns="0" rtlCol="0" anchor="ctr"/>
+          <a:lstStyle/>
+          <a:p>
+            <a:pPr indent="0" marL="0">
+              <a:buNone/>
+            </a:pPr>
+            <a:r>
+              <a:rPr lang="en-US" sz="1600" b="1" dirty="0">
+                <a:solidFill>
+                  <a:srgbClr val="EDF0E5"/>
+                </a:solidFill>
+                <a:latin typeface="Trade Gothic Next" pitchFamily="34" charset="0"/>
+                <a:ea typeface="Trade Gothic Next" pitchFamily="34" charset="-122"/>
+                <a:cs typeface="Trade Gothic Next" pitchFamily="34" charset="-120"/>
+              </a:rPr>
+              <a:t>Ground state: n = 1. Excited state: any higher n.</a:t>
             </a:r>
             <a:endParaRPr lang="en-US" sz="1600" dirty="0"/>
           </a:p>
@@ -13629,188 +13757,7 @@
       </p:sp>
       <p:sp>
         <p:nvSpPr>
-          <p:cNvPr id="7" name="Text 8"/>
-          <p:cNvSpPr txBox="1"/>
-          <p:nvPr>
-            <p:ph idx="115" type="body" hasCustomPrompt="1"/>
-          </p:nvPr>
-        </p:nvSpPr>
-        <p:spPr>
-          <a:xfrm>
-            <a:off x="3675888" y="3776472"/>
-            <a:ext cx="2203704" cy="219456"/>
-          </a:xfrm>
-          <a:prstGeom prst="rect">
-            <a:avLst/>
-          </a:prstGeom>
-          <a:noFill/>
-          <a:ln/>
-        </p:spPr>
-        <p:txBody>
-          <a:bodyPr wrap="square" lIns="0" tIns="0" rIns="0" bIns="0" rtlCol="0"/>
-          <a:lstStyle/>
-          <a:p>
-            <a:pPr indent="0" marL="0">
-              <a:buNone/>
-            </a:pPr>
-            <a:r>
-              <a:rPr lang="en-US" sz="1200" b="1" spc="120" kern="0" dirty="0">
-                <a:solidFill>
-                  <a:srgbClr val="2E3338"/>
-                </a:solidFill>
-                <a:latin typeface="Trade Gothic Next" pitchFamily="34" charset="0"/>
-                <a:ea typeface="Trade Gothic Next" pitchFamily="34" charset="-122"/>
-                <a:cs typeface="Trade Gothic Next" pitchFamily="34" charset="-120"/>
-              </a:rPr>
-              <a:t>NEED</a:t>
-            </a:r>
-            <a:endParaRPr lang="en-US" sz="1200" dirty="0"/>
-          </a:p>
-        </p:txBody>
-      </p:sp>
-      <p:sp>
-        <p:nvSpPr>
-          <p:cNvPr id="8" name="Text 8"/>
-          <p:cNvSpPr txBox="1"/>
-          <p:nvPr>
-            <p:ph idx="116" type="body" hasCustomPrompt="1"/>
-          </p:nvPr>
-        </p:nvSpPr>
-        <p:spPr>
-          <a:xfrm>
-            <a:off x="3675888" y="4069080"/>
-            <a:ext cx="2203704" cy="1078992"/>
-          </a:xfrm>
-          <a:prstGeom prst="rect">
-            <a:avLst/>
-          </a:prstGeom>
-          <a:noFill/>
-          <a:ln/>
-        </p:spPr>
-        <p:txBody>
-          <a:bodyPr wrap="square" lIns="0" tIns="0" rIns="0" bIns="0" rtlCol="0"/>
-          <a:lstStyle/>
-          <a:p>
-            <a:pPr indent="0" marL="0">
-              <a:buNone/>
-            </a:pPr>
-            <a:r>
-              <a:rPr lang="en-US" sz="1600" dirty="0">
-                <a:solidFill>
-                  <a:srgbClr val="14161B"/>
-                </a:solidFill>
-                <a:latin typeface="Trade Gothic Next" pitchFamily="34" charset="0"/>
-                <a:ea typeface="Trade Gothic Next" pitchFamily="34" charset="-122"/>
-                <a:cs typeface="Trade Gothic Next" pitchFamily="34" charset="-120"/>
-              </a:rPr>
-              <a:t>E₃, in joules</a:t>
-            </a:r>
-            <a:endParaRPr lang="en-US" sz="1600" dirty="0"/>
-          </a:p>
-        </p:txBody>
-      </p:sp>
-      <p:sp>
-        <p:nvSpPr>
-          <p:cNvPr id="9" name="Text 10"/>
-          <p:cNvSpPr txBox="1"/>
-          <p:nvPr>
-            <p:ph idx="119" type="body" hasCustomPrompt="1"/>
-          </p:nvPr>
-        </p:nvSpPr>
-        <p:spPr>
-          <a:xfrm>
-            <a:off x="6464808" y="2880360"/>
-            <a:ext cx="4837176" cy="2286000"/>
-          </a:xfrm>
-          <a:prstGeom prst="rect">
-            <a:avLst/>
-          </a:prstGeom>
-          <a:noFill/>
-          <a:ln/>
-        </p:spPr>
-        <p:txBody>
-          <a:bodyPr wrap="square" lIns="0" tIns="0" rIns="0" bIns="0" rtlCol="0"/>
-          <a:lstStyle/>
-          <a:p>
-            <a:pPr indent="0" marL="0">
-              <a:buNone/>
-            </a:pPr>
-            <a:endParaRPr lang="en-US" sz="1900" dirty="0"/>
-          </a:p>
-        </p:txBody>
-      </p:sp>
-      <p:sp>
-        <p:nvSpPr>
-          <p:cNvPr id="10" name="Text 12"/>
-          <p:cNvSpPr txBox="1"/>
-          <p:nvPr>
-            <p:ph idx="122" type="body" hasCustomPrompt="1"/>
-          </p:nvPr>
-        </p:nvSpPr>
-        <p:spPr>
-          <a:xfrm>
-            <a:off x="2240280" y="5605272"/>
-            <a:ext cx="8991295" cy="402336"/>
-          </a:xfrm>
-          <a:prstGeom prst="rect">
-            <a:avLst/>
-          </a:prstGeom>
-          <a:noFill/>
-          <a:ln/>
-        </p:spPr>
-        <p:txBody>
-          <a:bodyPr wrap="square" lIns="0" tIns="0" rIns="0" bIns="0" rtlCol="0" anchor="ctr"/>
-          <a:lstStyle/>
-          <a:p>
-            <a:pPr indent="0" marL="0">
-              <a:buNone/>
-            </a:pPr>
-            <a:r>
-              <a:rPr lang="en-US" sz="1600" b="1" dirty="0">
-                <a:solidFill>
-                  <a:srgbClr val="EDF0E5"/>
-                </a:solidFill>
-                <a:latin typeface="Trade Gothic Next" pitchFamily="34" charset="0"/>
-                <a:ea typeface="Trade Gothic Next" pitchFamily="34" charset="-122"/>
-                <a:cs typeface="Trade Gothic Next" pitchFamily="34" charset="-120"/>
-              </a:rPr>
-              <a:t>Eₙ = −2.18 × 10</a:t>
-            </a:r>
-            <a:pPr indent="0" marL="0">
-              <a:buNone/>
-            </a:pPr>
-            <a:r>
-              <a:rPr lang="en-US" sz="1600" b="1" baseline="30000" dirty="0">
-                <a:solidFill>
-                  <a:srgbClr val="EDF0E5"/>
-                </a:solidFill>
-                <a:latin typeface="Trade Gothic Next" pitchFamily="34" charset="0"/>
-                <a:ea typeface="Trade Gothic Next" pitchFamily="34" charset="-122"/>
-                <a:cs typeface="Trade Gothic Next" pitchFamily="34" charset="-120"/>
-              </a:rPr>
-              <a:t>−18</a:t>
-            </a:r>
-            <a:pPr indent="0" marL="0">
-              <a:buNone/>
-            </a:pPr>
-            <a:r>
-              <a:rPr lang="en-US" sz="1600" b="1" dirty="0">
-                <a:solidFill>
-                  <a:srgbClr val="EDF0E5"/>
-                </a:solidFill>
-                <a:latin typeface="Trade Gothic Next" pitchFamily="34" charset="0"/>
-                <a:ea typeface="Trade Gothic Next" pitchFamily="34" charset="-122"/>
-                <a:cs typeface="Trade Gothic Next" pitchFamily="34" charset="-120"/>
-              </a:rPr>
-              <a:t> J ÷ n²</a:t>
-            </a:r>
-            <a:endParaRPr lang="en-US" sz="1600" dirty="0"/>
-          </a:p>
-        </p:txBody>
-      </p:sp>
-      <p:sp>
-        <p:nvSpPr>
-          <p:cNvPr id="11" name="Text 1"/>
+          <p:cNvPr id="9" name="Text 1"/>
           <p:cNvSpPr txBox="1"/>
           <p:nvPr>
             <p:ph idx="101" type="body" hasCustomPrompt="1"/>
@@ -13851,10 +13798,10 @@
       </p:sp>
       <p:sp>
         <p:nvSpPr>
-          <p:cNvPr id="12" name="Text 13"/>
-          <p:cNvSpPr txBox="1"/>
-          <p:nvPr>
-            <p:ph idx="124" type="body" hasCustomPrompt="1"/>
+          <p:cNvPr id="10" name="Text 8"/>
+          <p:cNvSpPr txBox="1"/>
+          <p:nvPr>
+            <p:ph idx="117" type="body" hasCustomPrompt="1"/>
           </p:nvPr>
         </p:nvSpPr>
         <p:spPr>
@@ -13892,16 +13839,16 @@
       </p:sp>
       <p:sp>
         <p:nvSpPr>
-          <p:cNvPr id="14" name="Text 4"/>
-          <p:cNvSpPr txBox="1"/>
-          <p:nvPr>
-            <p:ph idx="107" hasCustomPrompt="1"/>
-          </p:nvPr>
-        </p:nvSpPr>
-        <p:spPr>
-          <a:xfrm>
-            <a:off x="9262872" y="1088136"/>
-            <a:ext cx="1901952" cy="1069848"/>
+          <p:cNvPr id="12" name="Text 3"/>
+          <p:cNvSpPr txBox="1"/>
+          <p:nvPr>
+            <p:ph idx="106" hasCustomPrompt="1"/>
+          </p:nvPr>
+        </p:nvSpPr>
+        <p:spPr>
+          <a:xfrm>
+            <a:off x="685800" y="2377440"/>
+            <a:ext cx="4663440" cy="2624328"/>
           </a:xfrm>
           <a:prstGeom prst="rect">
             <a:avLst/>
@@ -13931,1018 +13878,6 @@
 <file path=ppt/slides/slide11.xml><?xml version="1.0" encoding="utf-8"?>
 <p:sld xmlns:a="http://schemas.openxmlformats.org/drawingml/2006/main" xmlns:r="http://schemas.openxmlformats.org/officeDocument/2006/relationships" xmlns:p="http://schemas.openxmlformats.org/presentationml/2006/main">
   <p:cSld name="Slide 11">
-    <p:spTree>
-      <p:nvGrpSpPr>
-        <p:cNvPr id="1" name=""/>
-        <p:cNvGrpSpPr/>
-        <p:nvPr/>
-      </p:nvGrpSpPr>
-      <p:grpSpPr>
-        <a:xfrm>
-          <a:off x="0" y="0"/>
-          <a:ext cx="0" cy="0"/>
-          <a:chOff x="0" y="0"/>
-          <a:chExt cx="0" cy="0"/>
-        </a:xfrm>
-      </p:grpSpPr>
-      <p:pic>
-        <p:nvPicPr>
-          <p:cNvPr id="2" name="Image 0" descr="/home/user/WorkWork/templates/slide/assets/chem_u02_s2.1_level_n3.png">    </p:cNvPr>
-          <p:cNvPicPr>
-            <a:picLocks noChangeAspect="1"/>
-          </p:cNvPicPr>
-          <p:nvPr/>
-        </p:nvPicPr>
-        <p:blipFill>
-          <a:blip r:embed="rId1"/>
-          <a:stretch>
-            <a:fillRect/>
-          </a:stretch>
-        </p:blipFill>
-        <p:spPr>
-          <a:xfrm>
-            <a:off x="832104" y="2542817"/>
-            <a:ext cx="3867912" cy="2266141"/>
-          </a:xfrm>
-          <a:prstGeom prst="rect">
-            <a:avLst/>
-          </a:prstGeom>
-        </p:spPr>
-      </p:pic>
-      <p:sp>
-        <p:nvSpPr>
-          <p:cNvPr id="3" name="Text 2"/>
-          <p:cNvSpPr txBox="1"/>
-          <p:nvPr>
-            <p:ph idx="103" type="title" hasCustomPrompt="1"/>
-          </p:nvPr>
-        </p:nvSpPr>
-        <p:spPr>
-          <a:xfrm>
-            <a:off x="685800" y="932688"/>
-            <a:ext cx="10820095" cy="868680"/>
-          </a:xfrm>
-          <a:prstGeom prst="rect">
-            <a:avLst/>
-          </a:prstGeom>
-          <a:noFill/>
-          <a:ln/>
-        </p:spPr>
-        <p:txBody>
-          <a:bodyPr wrap="square" lIns="0" tIns="0" rIns="0" bIns="0" rtlCol="0" anchor="t"/>
-          <a:lstStyle/>
-          <a:p>
-            <a:pPr algn="l" indent="0" marL="0">
-              <a:buNone/>
-            </a:pPr>
-            <a:r>
-              <a:rPr lang="en-US" sz="2800" b="1" dirty="0">
-                <a:solidFill>
-                  <a:srgbClr val="14161B"/>
-                </a:solidFill>
-                <a:latin typeface="Trade Gothic Next" pitchFamily="34" charset="0"/>
-                <a:ea typeface="Trade Gothic Next" pitchFamily="34" charset="-122"/>
-                <a:cs typeface="Trade Gothic Next" pitchFamily="34" charset="-120"/>
-              </a:rPr>
-              <a:t>n = 3, Worked</a:t>
-            </a:r>
-            <a:endParaRPr lang="en-US" sz="2800" dirty="0"/>
-          </a:p>
-        </p:txBody>
-      </p:sp>
-      <p:sp>
-        <p:nvSpPr>
-          <p:cNvPr id="4" name="Text 2"/>
-          <p:cNvSpPr txBox="1"/>
-          <p:nvPr>
-            <p:ph idx="104" type="body" hasCustomPrompt="1"/>
-          </p:nvPr>
-        </p:nvSpPr>
-        <p:spPr>
-          <a:xfrm>
-            <a:off x="685800" y="1847088"/>
-            <a:ext cx="10820095" cy="384048"/>
-          </a:xfrm>
-          <a:prstGeom prst="rect">
-            <a:avLst/>
-          </a:prstGeom>
-          <a:noFill/>
-          <a:ln/>
-        </p:spPr>
-        <p:txBody>
-          <a:bodyPr wrap="square" lIns="0" tIns="0" rIns="0" bIns="0" rtlCol="0"/>
-          <a:lstStyle/>
-          <a:p>
-            <a:pPr indent="0" marL="0">
-              <a:buNone/>
-            </a:pPr>
-            <a:r>
-              <a:rPr lang="en-US" sz="1700" dirty="0">
-                <a:solidFill>
-                  <a:srgbClr val="2E3338"/>
-                </a:solidFill>
-                <a:latin typeface="Trade Gothic Next" pitchFamily="34" charset="0"/>
-                <a:ea typeface="Trade Gothic Next" pitchFamily="34" charset="-122"/>
-                <a:cs typeface="Trade Gothic Next" pitchFamily="34" charset="-120"/>
-              </a:rPr>
-              <a:t>Square n first, then divide.</a:t>
-            </a:r>
-            <a:endParaRPr lang="en-US" sz="1700" dirty="0"/>
-          </a:p>
-        </p:txBody>
-      </p:sp>
-      <p:sp>
-        <p:nvSpPr>
-          <p:cNvPr id="5" name="Text 5"/>
-          <p:cNvSpPr txBox="1"/>
-          <p:nvPr>
-            <p:ph idx="109" type="body" hasCustomPrompt="1"/>
-          </p:nvPr>
-        </p:nvSpPr>
-        <p:spPr>
-          <a:xfrm>
-            <a:off x="5276088" y="2560320"/>
-            <a:ext cx="2752344" cy="219456"/>
-          </a:xfrm>
-          <a:prstGeom prst="rect">
-            <a:avLst/>
-          </a:prstGeom>
-          <a:noFill/>
-          <a:ln/>
-        </p:spPr>
-        <p:txBody>
-          <a:bodyPr wrap="square" lIns="0" tIns="0" rIns="0" bIns="0" rtlCol="0"/>
-          <a:lstStyle/>
-          <a:p>
-            <a:pPr indent="0" marL="0">
-              <a:buNone/>
-            </a:pPr>
-            <a:r>
-              <a:rPr lang="en-US" sz="1200" b="1" spc="120" kern="0" dirty="0">
-                <a:solidFill>
-                  <a:srgbClr val="2E3338"/>
-                </a:solidFill>
-                <a:latin typeface="Trade Gothic Next" pitchFamily="34" charset="0"/>
-                <a:ea typeface="Trade Gothic Next" pitchFamily="34" charset="-122"/>
-                <a:cs typeface="Trade Gothic Next" pitchFamily="34" charset="-120"/>
-              </a:rPr>
-              <a:t>FORMULA</a:t>
-            </a:r>
-            <a:endParaRPr lang="en-US" sz="1200" dirty="0"/>
-          </a:p>
-        </p:txBody>
-      </p:sp>
-      <p:sp>
-        <p:nvSpPr>
-          <p:cNvPr id="6" name="Text 5"/>
-          <p:cNvSpPr txBox="1"/>
-          <p:nvPr>
-            <p:ph idx="110" type="body" hasCustomPrompt="1"/>
-          </p:nvPr>
-        </p:nvSpPr>
-        <p:spPr>
-          <a:xfrm>
-            <a:off x="5276088" y="2852928"/>
-            <a:ext cx="2752344" cy="1901952"/>
-          </a:xfrm>
-          <a:prstGeom prst="rect">
-            <a:avLst/>
-          </a:prstGeom>
-          <a:noFill/>
-          <a:ln/>
-        </p:spPr>
-        <p:txBody>
-          <a:bodyPr wrap="square" lIns="0" tIns="0" rIns="0" bIns="0" rtlCol="0"/>
-          <a:lstStyle/>
-          <a:p>
-            <a:pPr indent="0" marL="0">
-              <a:buNone/>
-            </a:pPr>
-            <a:r>
-              <a:rPr lang="en-US" sz="1600" dirty="0">
-                <a:solidFill>
-                  <a:srgbClr val="14161B"/>
-                </a:solidFill>
-                <a:latin typeface="Trade Gothic Next" pitchFamily="34" charset="0"/>
-                <a:ea typeface="Trade Gothic Next" pitchFamily="34" charset="-122"/>
-                <a:cs typeface="Trade Gothic Next" pitchFamily="34" charset="-120"/>
-              </a:rPr>
-              <a:t>Eₙ = −2.18 × 10</a:t>
-            </a:r>
-            <a:pPr indent="0" marL="0">
-              <a:buNone/>
-            </a:pPr>
-            <a:r>
-              <a:rPr lang="en-US" sz="1600" baseline="30000" dirty="0">
-                <a:solidFill>
-                  <a:srgbClr val="14161B"/>
-                </a:solidFill>
-                <a:latin typeface="Trade Gothic Next" pitchFamily="34" charset="0"/>
-                <a:ea typeface="Trade Gothic Next" pitchFamily="34" charset="-122"/>
-                <a:cs typeface="Trade Gothic Next" pitchFamily="34" charset="-120"/>
-              </a:rPr>
-              <a:t>−18</a:t>
-            </a:r>
-            <a:pPr indent="0" marL="0">
-              <a:buNone/>
-            </a:pPr>
-            <a:r>
-              <a:rPr lang="en-US" sz="1600" dirty="0">
-                <a:solidFill>
-                  <a:srgbClr val="14161B"/>
-                </a:solidFill>
-                <a:latin typeface="Trade Gothic Next" pitchFamily="34" charset="0"/>
-                <a:ea typeface="Trade Gothic Next" pitchFamily="34" charset="-122"/>
-                <a:cs typeface="Trade Gothic Next" pitchFamily="34" charset="-120"/>
-              </a:rPr>
-              <a:t> J ÷ n²</a:t>
-            </a:r>
-            <a:endParaRPr lang="en-US" sz="1600" dirty="0"/>
-          </a:p>
-        </p:txBody>
-      </p:sp>
-      <p:sp>
-        <p:nvSpPr>
-          <p:cNvPr id="7" name="Text 7"/>
-          <p:cNvSpPr txBox="1"/>
-          <p:nvPr>
-            <p:ph idx="113" type="body" hasCustomPrompt="1"/>
-          </p:nvPr>
-        </p:nvSpPr>
-        <p:spPr>
-          <a:xfrm>
-            <a:off x="8613648" y="2871216"/>
-            <a:ext cx="2688336" cy="1920240"/>
-          </a:xfrm>
-          <a:prstGeom prst="rect">
-            <a:avLst/>
-          </a:prstGeom>
-          <a:noFill/>
-          <a:ln/>
-        </p:spPr>
-        <p:txBody>
-          <a:bodyPr wrap="square" lIns="0" tIns="0" rIns="0" bIns="0" rtlCol="0"/>
-          <a:lstStyle/>
-          <a:p>
-            <a:pPr indent="0" marL="0">
-              <a:buNone/>
-            </a:pPr>
-            <a:r>
-              <a:rPr lang="en-US" sz="1900" dirty="0">
-                <a:solidFill>
-                  <a:srgbClr val="14161B"/>
-                </a:solidFill>
-                <a:latin typeface="Trade Gothic Next" pitchFamily="34" charset="0"/>
-                <a:ea typeface="Trade Gothic Next" pitchFamily="34" charset="-122"/>
-                <a:cs typeface="Trade Gothic Next" pitchFamily="34" charset="-120"/>
-              </a:rPr>
-              <a:t>3² = 9</a:t>
-            </a:r>
-            <a:endParaRPr lang="en-US" sz="1900" dirty="0"/>
-          </a:p>
-          <a:p>
-            <a:pPr indent="0" marL="0">
-              <a:buNone/>
-            </a:pPr>
-            <a:r>
-              <a:rPr lang="en-US" sz="1900" dirty="0">
-                <a:solidFill>
-                  <a:srgbClr val="14161B"/>
-                </a:solidFill>
-                <a:latin typeface="Trade Gothic Next" pitchFamily="34" charset="0"/>
-                <a:ea typeface="Trade Gothic Next" pitchFamily="34" charset="-122"/>
-                <a:cs typeface="Trade Gothic Next" pitchFamily="34" charset="-120"/>
-              </a:rPr>
-              <a:t>−2.18 × 10</a:t>
-            </a:r>
-            <a:pPr indent="0" marL="0">
-              <a:buNone/>
-            </a:pPr>
-            <a:r>
-              <a:rPr lang="en-US" sz="1900" baseline="30000" dirty="0">
-                <a:solidFill>
-                  <a:srgbClr val="14161B"/>
-                </a:solidFill>
-                <a:latin typeface="Trade Gothic Next" pitchFamily="34" charset="0"/>
-                <a:ea typeface="Trade Gothic Next" pitchFamily="34" charset="-122"/>
-                <a:cs typeface="Trade Gothic Next" pitchFamily="34" charset="-120"/>
-              </a:rPr>
-              <a:t>−18</a:t>
-            </a:r>
-            <a:pPr indent="0" marL="0">
-              <a:buNone/>
-            </a:pPr>
-            <a:r>
-              <a:rPr lang="en-US" sz="1900" dirty="0">
-                <a:solidFill>
-                  <a:srgbClr val="14161B"/>
-                </a:solidFill>
-                <a:latin typeface="Trade Gothic Next" pitchFamily="34" charset="0"/>
-                <a:ea typeface="Trade Gothic Next" pitchFamily="34" charset="-122"/>
-                <a:cs typeface="Trade Gothic Next" pitchFamily="34" charset="-120"/>
-              </a:rPr>
-              <a:t> ÷ 9</a:t>
-            </a:r>
-            <a:endParaRPr lang="en-US" sz="1900" dirty="0"/>
-          </a:p>
-          <a:p>
-            <a:pPr indent="0" marL="0">
-              <a:buNone/>
-            </a:pPr>
-            <a:r>
-              <a:rPr lang="en-US" sz="1900" dirty="0">
-                <a:solidFill>
-                  <a:srgbClr val="14161B"/>
-                </a:solidFill>
-                <a:latin typeface="Trade Gothic Next" pitchFamily="34" charset="0"/>
-                <a:ea typeface="Trade Gothic Next" pitchFamily="34" charset="-122"/>
-                <a:cs typeface="Trade Gothic Next" pitchFamily="34" charset="-120"/>
-              </a:rPr>
-              <a:t>= −2.42 × 10</a:t>
-            </a:r>
-            <a:pPr indent="0" marL="0">
-              <a:buNone/>
-            </a:pPr>
-            <a:r>
-              <a:rPr lang="en-US" sz="1900" baseline="30000" dirty="0">
-                <a:solidFill>
-                  <a:srgbClr val="14161B"/>
-                </a:solidFill>
-                <a:latin typeface="Trade Gothic Next" pitchFamily="34" charset="0"/>
-                <a:ea typeface="Trade Gothic Next" pitchFamily="34" charset="-122"/>
-                <a:cs typeface="Trade Gothic Next" pitchFamily="34" charset="-120"/>
-              </a:rPr>
-              <a:t>−19</a:t>
-            </a:r>
-            <a:pPr indent="0" marL="0">
-              <a:buNone/>
-            </a:pPr>
-            <a:r>
-              <a:rPr lang="en-US" sz="1900" dirty="0">
-                <a:solidFill>
-                  <a:srgbClr val="14161B"/>
-                </a:solidFill>
-                <a:latin typeface="Trade Gothic Next" pitchFamily="34" charset="0"/>
-                <a:ea typeface="Trade Gothic Next" pitchFamily="34" charset="-122"/>
-                <a:cs typeface="Trade Gothic Next" pitchFamily="34" charset="-120"/>
-              </a:rPr>
-              <a:t> J</a:t>
-            </a:r>
-            <a:endParaRPr lang="en-US" sz="1900" dirty="0"/>
-          </a:p>
-        </p:txBody>
-      </p:sp>
-      <p:sp>
-        <p:nvSpPr>
-          <p:cNvPr id="8" name="Text 9"/>
-          <p:cNvSpPr txBox="1"/>
-          <p:nvPr>
-            <p:ph idx="116" type="body" hasCustomPrompt="1"/>
-          </p:nvPr>
-        </p:nvSpPr>
-        <p:spPr>
-          <a:xfrm>
-            <a:off x="2240280" y="5212080"/>
-            <a:ext cx="8991295" cy="402336"/>
-          </a:xfrm>
-          <a:prstGeom prst="rect">
-            <a:avLst/>
-          </a:prstGeom>
-          <a:noFill/>
-          <a:ln/>
-        </p:spPr>
-        <p:txBody>
-          <a:bodyPr wrap="square" lIns="0" tIns="0" rIns="0" bIns="0" rtlCol="0" anchor="ctr"/>
-          <a:lstStyle/>
-          <a:p>
-            <a:pPr indent="0" marL="0">
-              <a:buNone/>
-            </a:pPr>
-            <a:r>
-              <a:rPr lang="en-US" sz="1600" b="1" dirty="0">
-                <a:solidFill>
-                  <a:srgbClr val="EDF0E5"/>
-                </a:solidFill>
-                <a:latin typeface="Trade Gothic Next" pitchFamily="34" charset="0"/>
-                <a:ea typeface="Trade Gothic Next" pitchFamily="34" charset="-122"/>
-                <a:cs typeface="Trade Gothic Next" pitchFamily="34" charset="-120"/>
-              </a:rPr>
-              <a:t>Less negative means higher energy. E₃ is above E₂.</a:t>
-            </a:r>
-            <a:endParaRPr lang="en-US" sz="1600" dirty="0"/>
-          </a:p>
-        </p:txBody>
-      </p:sp>
-      <p:sp>
-        <p:nvSpPr>
-          <p:cNvPr id="9" name="Text 1"/>
-          <p:cNvSpPr txBox="1"/>
-          <p:nvPr>
-            <p:ph idx="101" type="body" hasCustomPrompt="1"/>
-          </p:nvPr>
-        </p:nvSpPr>
-        <p:spPr>
-          <a:xfrm>
-            <a:off x="685800" y="384048"/>
-            <a:ext cx="6400800" cy="237744"/>
-          </a:xfrm>
-          <a:prstGeom prst="rect">
-            <a:avLst/>
-          </a:prstGeom>
-          <a:noFill/>
-          <a:ln/>
-        </p:spPr>
-        <p:txBody>
-          <a:bodyPr wrap="square" lIns="0" tIns="0" rIns="0" bIns="0" rtlCol="0" anchor="ctr"/>
-          <a:lstStyle/>
-          <a:p>
-            <a:pPr indent="0" marL="0">
-              <a:buNone/>
-            </a:pPr>
-            <a:r>
-              <a:rPr lang="en-US" sz="1100" b="1" spc="160" kern="0" dirty="0">
-                <a:solidFill>
-                  <a:srgbClr val="14161B"/>
-                </a:solidFill>
-                <a:latin typeface="Trade Gothic Next" pitchFamily="34" charset="0"/>
-                <a:ea typeface="Trade Gothic Next" pitchFamily="34" charset="-122"/>
-                <a:cs typeface="Trade Gothic Next" pitchFamily="34" charset="-120"/>
-              </a:rPr>
-              <a:t>UNIT 02  •  CHEMISTRY</a:t>
-            </a:r>
-            <a:endParaRPr lang="en-US" sz="1100" dirty="0"/>
-          </a:p>
-        </p:txBody>
-      </p:sp>
-      <p:sp>
-        <p:nvSpPr>
-          <p:cNvPr id="10" name="Text 10"/>
-          <p:cNvSpPr txBox="1"/>
-          <p:nvPr>
-            <p:ph idx="118" type="body" hasCustomPrompt="1"/>
-          </p:nvPr>
-        </p:nvSpPr>
-        <p:spPr>
-          <a:xfrm>
-            <a:off x="8762695" y="6382512"/>
-            <a:ext cx="2743200" cy="237744"/>
-          </a:xfrm>
-          <a:prstGeom prst="rect">
-            <a:avLst/>
-          </a:prstGeom>
-          <a:noFill/>
-          <a:ln/>
-        </p:spPr>
-        <p:txBody>
-          <a:bodyPr wrap="square" lIns="0" tIns="0" rIns="0" bIns="0" rtlCol="0" anchor="ctr"/>
-          <a:lstStyle/>
-          <a:p>
-            <a:pPr algn="r" indent="0" marL="0">
-              <a:buNone/>
-            </a:pPr>
-            <a:r>
-              <a:rPr lang="en-US" sz="1000" b="1" spc="140" kern="0" dirty="0">
-                <a:solidFill>
-                  <a:srgbClr val="2E3338"/>
-                </a:solidFill>
-                <a:latin typeface="Trade Gothic Next" pitchFamily="34" charset="0"/>
-                <a:ea typeface="Trade Gothic Next" pitchFamily="34" charset="-122"/>
-                <a:cs typeface="Trade Gothic Next" pitchFamily="34" charset="-120"/>
-              </a:rPr>
-              <a:t>U02 • S02.1</a:t>
-            </a:r>
-            <a:endParaRPr lang="en-US" sz="1000" dirty="0"/>
-          </a:p>
-        </p:txBody>
-      </p:sp>
-      <p:sp>
-        <p:nvSpPr>
-          <p:cNvPr id="12" name="Text 4"/>
-          <p:cNvSpPr txBox="1"/>
-          <p:nvPr>
-            <p:ph idx="107" hasCustomPrompt="1"/>
-          </p:nvPr>
-        </p:nvSpPr>
-        <p:spPr>
-          <a:xfrm>
-            <a:off x="832104" y="2542032"/>
-            <a:ext cx="3867912" cy="2267712"/>
-          </a:xfrm>
-          <a:prstGeom prst="rect">
-            <a:avLst/>
-          </a:prstGeom>
-          <a:noFill/>
-          <a:ln/>
-        </p:spPr>
-        <p:txBody>
-          <a:bodyPr wrap="square" lIns="0" tIns="0" rIns="0" bIns="0" rtlCol="0" anchor="ctr"/>
-          <a:lstStyle/>
-          <a:p>
-            <a:pPr algn="ctr" indent="0" marL="0">
-              <a:buNone/>
-            </a:pPr>
-            <a:endParaRPr lang="en-US" sz="1200" dirty="0"/>
-          </a:p>
-        </p:txBody>
-      </p:sp>
-    </p:spTree>
-  </p:cSld>
-  <p:clrMapOvr>
-    <a:masterClrMapping/>
-  </p:clrMapOvr>
-</p:sld>
-</file>
-
-<file path=ppt/slides/slide12.xml><?xml version="1.0" encoding="utf-8"?>
-<p:sld xmlns:a="http://schemas.openxmlformats.org/drawingml/2006/main" xmlns:r="http://schemas.openxmlformats.org/officeDocument/2006/relationships" xmlns:p="http://schemas.openxmlformats.org/presentationml/2006/main">
-  <p:cSld name="Slide 12">
-    <p:spTree>
-      <p:nvGrpSpPr>
-        <p:cNvPr id="1" name=""/>
-        <p:cNvGrpSpPr/>
-        <p:nvPr/>
-      </p:nvGrpSpPr>
-      <p:grpSpPr>
-        <a:xfrm>
-          <a:off x="0" y="0"/>
-          <a:ext cx="0" cy="0"/>
-          <a:chOff x="0" y="0"/>
-          <a:chExt cx="0" cy="0"/>
-        </a:xfrm>
-      </p:grpSpPr>
-      <p:sp>
-        <p:nvSpPr>
-          <p:cNvPr id="2" name="Text 2"/>
-          <p:cNvSpPr txBox="1"/>
-          <p:nvPr>
-            <p:ph idx="103" type="title" hasCustomPrompt="1"/>
-          </p:nvPr>
-        </p:nvSpPr>
-        <p:spPr>
-          <a:xfrm>
-            <a:off x="685800" y="932688"/>
-            <a:ext cx="10820095" cy="868680"/>
-          </a:xfrm>
-          <a:prstGeom prst="rect">
-            <a:avLst/>
-          </a:prstGeom>
-          <a:noFill/>
-          <a:ln/>
-        </p:spPr>
-        <p:txBody>
-          <a:bodyPr wrap="square" lIns="0" tIns="0" rIns="0" bIns="0" rtlCol="0" anchor="t"/>
-          <a:lstStyle/>
-          <a:p>
-            <a:pPr algn="l" indent="0" marL="0">
-              <a:buNone/>
-            </a:pPr>
-            <a:r>
-              <a:rPr lang="en-US" sz="2800" b="1" dirty="0">
-                <a:solidFill>
-                  <a:srgbClr val="14161B"/>
-                </a:solidFill>
-                <a:latin typeface="Trade Gothic Next" pitchFamily="34" charset="0"/>
-                <a:ea typeface="Trade Gothic Next" pitchFamily="34" charset="-122"/>
-                <a:cs typeface="Trade Gothic Next" pitchFamily="34" charset="-120"/>
-              </a:rPr>
-              <a:t>Ground State and Excited States</a:t>
-            </a:r>
-            <a:endParaRPr lang="en-US" sz="2800" dirty="0"/>
-          </a:p>
-        </p:txBody>
-      </p:sp>
-      <p:sp>
-        <p:nvSpPr>
-          <p:cNvPr id="3" name="Text 2"/>
-          <p:cNvSpPr txBox="1"/>
-          <p:nvPr>
-            <p:ph idx="104" type="body" hasCustomPrompt="1"/>
-          </p:nvPr>
-        </p:nvSpPr>
-        <p:spPr>
-          <a:xfrm>
-            <a:off x="685800" y="1847088"/>
-            <a:ext cx="10820095" cy="384048"/>
-          </a:xfrm>
-          <a:prstGeom prst="rect">
-            <a:avLst/>
-          </a:prstGeom>
-          <a:noFill/>
-          <a:ln/>
-        </p:spPr>
-        <p:txBody>
-          <a:bodyPr wrap="square" lIns="0" tIns="0" rIns="0" bIns="0" rtlCol="0"/>
-          <a:lstStyle/>
-          <a:p>
-            <a:pPr indent="0" marL="0">
-              <a:buNone/>
-            </a:pPr>
-            <a:r>
-              <a:rPr lang="en-US" sz="1700" dirty="0">
-                <a:solidFill>
-                  <a:srgbClr val="2E3338"/>
-                </a:solidFill>
-                <a:latin typeface="Trade Gothic Next" pitchFamily="34" charset="0"/>
-                <a:ea typeface="Trade Gothic Next" pitchFamily="34" charset="-122"/>
-                <a:cs typeface="Trade Gothic Next" pitchFamily="34" charset="-120"/>
-              </a:rPr>
-              <a:t>Hydrogen's electron has one lowest level and many higher ones.</a:t>
-            </a:r>
-            <a:endParaRPr lang="en-US" sz="1700" dirty="0"/>
-          </a:p>
-        </p:txBody>
-      </p:sp>
-      <p:sp>
-        <p:nvSpPr>
-          <p:cNvPr id="4" name="Text 4"/>
-          <p:cNvSpPr txBox="1"/>
-          <p:nvPr>
-            <p:ph idx="108" type="body" hasCustomPrompt="1"/>
-          </p:nvPr>
-        </p:nvSpPr>
-        <p:spPr>
-          <a:xfrm>
-            <a:off x="5733288" y="2542032"/>
-            <a:ext cx="2752344" cy="219456"/>
-          </a:xfrm>
-          <a:prstGeom prst="rect">
-            <a:avLst/>
-          </a:prstGeom>
-          <a:noFill/>
-          <a:ln/>
-        </p:spPr>
-        <p:txBody>
-          <a:bodyPr wrap="square" lIns="0" tIns="0" rIns="0" bIns="0" rtlCol="0"/>
-          <a:lstStyle/>
-          <a:p>
-            <a:pPr indent="0" marL="0">
-              <a:buNone/>
-            </a:pPr>
-            <a:r>
-              <a:rPr lang="en-US" sz="1200" b="1" spc="120" kern="0" dirty="0">
-                <a:solidFill>
-                  <a:srgbClr val="2E3338"/>
-                </a:solidFill>
-                <a:latin typeface="Trade Gothic Next" pitchFamily="34" charset="0"/>
-                <a:ea typeface="Trade Gothic Next" pitchFamily="34" charset="-122"/>
-                <a:cs typeface="Trade Gothic Next" pitchFamily="34" charset="-120"/>
-              </a:rPr>
-              <a:t>GROUND STATE</a:t>
-            </a:r>
-            <a:endParaRPr lang="en-US" sz="1200" dirty="0"/>
-          </a:p>
-        </p:txBody>
-      </p:sp>
-      <p:sp>
-        <p:nvSpPr>
-          <p:cNvPr id="5" name="Text 4"/>
-          <p:cNvSpPr txBox="1"/>
-          <p:nvPr>
-            <p:ph idx="109" type="body" hasCustomPrompt="1"/>
-          </p:nvPr>
-        </p:nvSpPr>
-        <p:spPr>
-          <a:xfrm>
-            <a:off x="5733288" y="2834640"/>
-            <a:ext cx="2752344" cy="1965960"/>
-          </a:xfrm>
-          <a:prstGeom prst="rect">
-            <a:avLst/>
-          </a:prstGeom>
-          <a:noFill/>
-          <a:ln/>
-        </p:spPr>
-        <p:txBody>
-          <a:bodyPr wrap="square" lIns="0" tIns="0" rIns="0" bIns="0" rtlCol="0"/>
-          <a:lstStyle/>
-          <a:p>
-            <a:pPr indent="0" marL="0">
-              <a:buNone/>
-            </a:pPr>
-            <a:r>
-              <a:rPr lang="en-US" sz="1600" dirty="0">
-                <a:solidFill>
-                  <a:srgbClr val="14161B"/>
-                </a:solidFill>
-                <a:latin typeface="Trade Gothic Next" pitchFamily="34" charset="0"/>
-                <a:ea typeface="Trade Gothic Next" pitchFamily="34" charset="-122"/>
-                <a:cs typeface="Trade Gothic Next" pitchFamily="34" charset="-120"/>
-              </a:rPr>
-              <a:t>n = 1.</a:t>
-            </a:r>
-            <a:endParaRPr lang="en-US" sz="1600" dirty="0"/>
-          </a:p>
-          <a:p>
-            <a:pPr indent="0" marL="0">
-              <a:buNone/>
-            </a:pPr>
-            <a:r>
-              <a:rPr lang="en-US" sz="1600" dirty="0">
-                <a:solidFill>
-                  <a:srgbClr val="14161B"/>
-                </a:solidFill>
-                <a:latin typeface="Trade Gothic Next" pitchFamily="34" charset="0"/>
-                <a:ea typeface="Trade Gothic Next" pitchFamily="34" charset="-122"/>
-                <a:cs typeface="Trade Gothic Next" pitchFamily="34" charset="-120"/>
-              </a:rPr>
-              <a:t>The lowest energy level.</a:t>
-            </a:r>
-            <a:endParaRPr lang="en-US" sz="1600" dirty="0"/>
-          </a:p>
-          <a:p>
-            <a:pPr indent="0" marL="0">
-              <a:buNone/>
-            </a:pPr>
-            <a:endParaRPr lang="en-US" sz="1600" dirty="0"/>
-          </a:p>
-          <a:p>
-            <a:pPr indent="0" marL="0">
-              <a:buNone/>
-            </a:pPr>
-            <a:r>
-              <a:rPr lang="en-US" sz="1600" dirty="0">
-                <a:solidFill>
-                  <a:srgbClr val="14161B"/>
-                </a:solidFill>
-                <a:latin typeface="Trade Gothic Next" pitchFamily="34" charset="0"/>
-                <a:ea typeface="Trade Gothic Next" pitchFamily="34" charset="-122"/>
-                <a:cs typeface="Trade Gothic Next" pitchFamily="34" charset="-120"/>
-              </a:rPr>
-              <a:t>Where the electron normally sits.</a:t>
-            </a:r>
-            <a:endParaRPr lang="en-US" sz="1600" dirty="0"/>
-          </a:p>
-        </p:txBody>
-      </p:sp>
-      <p:sp>
-        <p:nvSpPr>
-          <p:cNvPr id="6" name="Text 5"/>
-          <p:cNvSpPr txBox="1"/>
-          <p:nvPr>
-            <p:ph idx="111" type="body" hasCustomPrompt="1"/>
-          </p:nvPr>
-        </p:nvSpPr>
-        <p:spPr>
-          <a:xfrm>
-            <a:off x="9116568" y="2542032"/>
-            <a:ext cx="2752344" cy="219456"/>
-          </a:xfrm>
-          <a:prstGeom prst="rect">
-            <a:avLst/>
-          </a:prstGeom>
-          <a:noFill/>
-          <a:ln/>
-        </p:spPr>
-        <p:txBody>
-          <a:bodyPr wrap="square" lIns="0" tIns="0" rIns="0" bIns="0" rtlCol="0"/>
-          <a:lstStyle/>
-          <a:p>
-            <a:pPr indent="0" marL="0">
-              <a:buNone/>
-            </a:pPr>
-            <a:r>
-              <a:rPr lang="en-US" sz="1200" b="1" spc="120" kern="0" dirty="0">
-                <a:solidFill>
-                  <a:srgbClr val="BDB6AA"/>
-                </a:solidFill>
-                <a:latin typeface="Trade Gothic Next" pitchFamily="34" charset="0"/>
-                <a:ea typeface="Trade Gothic Next" pitchFamily="34" charset="-122"/>
-                <a:cs typeface="Trade Gothic Next" pitchFamily="34" charset="-120"/>
-              </a:rPr>
-              <a:t>EXCITED STATE</a:t>
-            </a:r>
-            <a:endParaRPr lang="en-US" sz="1200" dirty="0"/>
-          </a:p>
-        </p:txBody>
-      </p:sp>
-      <p:sp>
-        <p:nvSpPr>
-          <p:cNvPr id="7" name="Text 5"/>
-          <p:cNvSpPr txBox="1"/>
-          <p:nvPr>
-            <p:ph idx="112" type="body" hasCustomPrompt="1"/>
-          </p:nvPr>
-        </p:nvSpPr>
-        <p:spPr>
-          <a:xfrm>
-            <a:off x="9116568" y="2834640"/>
-            <a:ext cx="2752344" cy="1965960"/>
-          </a:xfrm>
-          <a:prstGeom prst="rect">
-            <a:avLst/>
-          </a:prstGeom>
-          <a:noFill/>
-          <a:ln/>
-        </p:spPr>
-        <p:txBody>
-          <a:bodyPr wrap="square" lIns="0" tIns="0" rIns="0" bIns="0" rtlCol="0"/>
-          <a:lstStyle/>
-          <a:p>
-            <a:pPr indent="0" marL="0">
-              <a:buNone/>
-            </a:pPr>
-            <a:r>
-              <a:rPr lang="en-US" sz="1600" dirty="0">
-                <a:solidFill>
-                  <a:srgbClr val="EDF0E5"/>
-                </a:solidFill>
-                <a:latin typeface="Trade Gothic Next" pitchFamily="34" charset="0"/>
-                <a:ea typeface="Trade Gothic Next" pitchFamily="34" charset="-122"/>
-                <a:cs typeface="Trade Gothic Next" pitchFamily="34" charset="-120"/>
-              </a:rPr>
-              <a:t>Any level above n = 1.</a:t>
-            </a:r>
-            <a:endParaRPr lang="en-US" sz="1600" dirty="0"/>
-          </a:p>
-          <a:p>
-            <a:pPr indent="0" marL="0">
-              <a:buNone/>
-            </a:pPr>
-            <a:endParaRPr lang="en-US" sz="1600" dirty="0"/>
-          </a:p>
-          <a:p>
-            <a:pPr indent="0" marL="0">
-              <a:buNone/>
-            </a:pPr>
-            <a:r>
-              <a:rPr lang="en-US" sz="1600" dirty="0">
-                <a:solidFill>
-                  <a:srgbClr val="EDF0E5"/>
-                </a:solidFill>
-                <a:latin typeface="Trade Gothic Next" pitchFamily="34" charset="0"/>
-                <a:ea typeface="Trade Gothic Next" pitchFamily="34" charset="-122"/>
-                <a:cs typeface="Trade Gothic Next" pitchFamily="34" charset="-120"/>
-              </a:rPr>
-              <a:t>Short-lived. The electron falls back down.</a:t>
-            </a:r>
-            <a:endParaRPr lang="en-US" sz="1600" dirty="0"/>
-          </a:p>
-        </p:txBody>
-      </p:sp>
-      <p:sp>
-        <p:nvSpPr>
-          <p:cNvPr id="8" name="Text 7"/>
-          <p:cNvSpPr txBox="1"/>
-          <p:nvPr>
-            <p:ph idx="115" type="body" hasCustomPrompt="1"/>
-          </p:nvPr>
-        </p:nvSpPr>
-        <p:spPr>
-          <a:xfrm>
-            <a:off x="2240280" y="5394960"/>
-            <a:ext cx="8991295" cy="402336"/>
-          </a:xfrm>
-          <a:prstGeom prst="rect">
-            <a:avLst/>
-          </a:prstGeom>
-          <a:noFill/>
-          <a:ln/>
-        </p:spPr>
-        <p:txBody>
-          <a:bodyPr wrap="square" lIns="0" tIns="0" rIns="0" bIns="0" rtlCol="0" anchor="ctr"/>
-          <a:lstStyle/>
-          <a:p>
-            <a:pPr indent="0" marL="0">
-              <a:buNone/>
-            </a:pPr>
-            <a:r>
-              <a:rPr lang="en-US" sz="1600" b="1" dirty="0">
-                <a:solidFill>
-                  <a:srgbClr val="EDF0E5"/>
-                </a:solidFill>
-                <a:latin typeface="Trade Gothic Next" pitchFamily="34" charset="0"/>
-                <a:ea typeface="Trade Gothic Next" pitchFamily="34" charset="-122"/>
-                <a:cs typeface="Trade Gothic Next" pitchFamily="34" charset="-120"/>
-              </a:rPr>
-              <a:t>Ground state: n = 1. Excited state: any higher n.</a:t>
-            </a:r>
-            <a:endParaRPr lang="en-US" sz="1600" dirty="0"/>
-          </a:p>
-        </p:txBody>
-      </p:sp>
-      <p:sp>
-        <p:nvSpPr>
-          <p:cNvPr id="9" name="Text 1"/>
-          <p:cNvSpPr txBox="1"/>
-          <p:nvPr>
-            <p:ph idx="101" type="body" hasCustomPrompt="1"/>
-          </p:nvPr>
-        </p:nvSpPr>
-        <p:spPr>
-          <a:xfrm>
-            <a:off x="685800" y="384048"/>
-            <a:ext cx="6400800" cy="237744"/>
-          </a:xfrm>
-          <a:prstGeom prst="rect">
-            <a:avLst/>
-          </a:prstGeom>
-          <a:noFill/>
-          <a:ln/>
-        </p:spPr>
-        <p:txBody>
-          <a:bodyPr wrap="square" lIns="0" tIns="0" rIns="0" bIns="0" rtlCol="0" anchor="ctr"/>
-          <a:lstStyle/>
-          <a:p>
-            <a:pPr indent="0" marL="0">
-              <a:buNone/>
-            </a:pPr>
-            <a:r>
-              <a:rPr lang="en-US" sz="1100" b="1" spc="160" kern="0" dirty="0">
-                <a:solidFill>
-                  <a:srgbClr val="14161B"/>
-                </a:solidFill>
-                <a:latin typeface="Trade Gothic Next" pitchFamily="34" charset="0"/>
-                <a:ea typeface="Trade Gothic Next" pitchFamily="34" charset="-122"/>
-                <a:cs typeface="Trade Gothic Next" pitchFamily="34" charset="-120"/>
-              </a:rPr>
-              <a:t>UNIT 02  •  CHEMISTRY</a:t>
-            </a:r>
-            <a:endParaRPr lang="en-US" sz="1100" dirty="0"/>
-          </a:p>
-        </p:txBody>
-      </p:sp>
-      <p:sp>
-        <p:nvSpPr>
-          <p:cNvPr id="10" name="Text 8"/>
-          <p:cNvSpPr txBox="1"/>
-          <p:nvPr>
-            <p:ph idx="117" type="body" hasCustomPrompt="1"/>
-          </p:nvPr>
-        </p:nvSpPr>
-        <p:spPr>
-          <a:xfrm>
-            <a:off x="8762695" y="6382512"/>
-            <a:ext cx="2743200" cy="237744"/>
-          </a:xfrm>
-          <a:prstGeom prst="rect">
-            <a:avLst/>
-          </a:prstGeom>
-          <a:noFill/>
-          <a:ln/>
-        </p:spPr>
-        <p:txBody>
-          <a:bodyPr wrap="square" lIns="0" tIns="0" rIns="0" bIns="0" rtlCol="0" anchor="ctr"/>
-          <a:lstStyle/>
-          <a:p>
-            <a:pPr algn="r" indent="0" marL="0">
-              <a:buNone/>
-            </a:pPr>
-            <a:r>
-              <a:rPr lang="en-US" sz="1000" b="1" spc="140" kern="0" dirty="0">
-                <a:solidFill>
-                  <a:srgbClr val="2E3338"/>
-                </a:solidFill>
-                <a:latin typeface="Trade Gothic Next" pitchFamily="34" charset="0"/>
-                <a:ea typeface="Trade Gothic Next" pitchFamily="34" charset="-122"/>
-                <a:cs typeface="Trade Gothic Next" pitchFamily="34" charset="-120"/>
-              </a:rPr>
-              <a:t>U02 • S02.1</a:t>
-            </a:r>
-            <a:endParaRPr lang="en-US" sz="1000" dirty="0"/>
-          </a:p>
-        </p:txBody>
-      </p:sp>
-      <p:sp>
-        <p:nvSpPr>
-          <p:cNvPr id="12" name="Text 3"/>
-          <p:cNvSpPr txBox="1"/>
-          <p:nvPr>
-            <p:ph idx="106" hasCustomPrompt="1"/>
-          </p:nvPr>
-        </p:nvSpPr>
-        <p:spPr>
-          <a:xfrm>
-            <a:off x="685800" y="2377440"/>
-            <a:ext cx="4663440" cy="2624328"/>
-          </a:xfrm>
-          <a:prstGeom prst="rect">
-            <a:avLst/>
-          </a:prstGeom>
-          <a:noFill/>
-          <a:ln/>
-        </p:spPr>
-        <p:txBody>
-          <a:bodyPr wrap="square" lIns="0" tIns="0" rIns="0" bIns="0" rtlCol="0" anchor="ctr"/>
-          <a:lstStyle/>
-          <a:p>
-            <a:pPr algn="ctr" indent="0" marL="0">
-              <a:buNone/>
-            </a:pPr>
-            <a:endParaRPr lang="en-US" sz="1200" dirty="0"/>
-          </a:p>
-        </p:txBody>
-      </p:sp>
-    </p:spTree>
-  </p:cSld>
-  <p:clrMapOvr>
-    <a:masterClrMapping/>
-  </p:clrMapOvr>
-</p:sld>
-</file>
-
-<file path=ppt/slides/slide13.xml><?xml version="1.0" encoding="utf-8"?>
-<p:sld xmlns:a="http://schemas.openxmlformats.org/drawingml/2006/main" xmlns:r="http://schemas.openxmlformats.org/officeDocument/2006/relationships" xmlns:p="http://schemas.openxmlformats.org/presentationml/2006/main">
-  <p:cSld name="Slide 13">
     <p:spTree>
       <p:nvGrpSpPr>
         <p:cNvPr id="1" name=""/>
@@ -15139,7 +14074,7 @@
                 <a:ea typeface="Trade Gothic Next" pitchFamily="34" charset="-122"/>
                 <a:cs typeface="Trade Gothic Next" pitchFamily="34" charset="-120"/>
               </a:rPr>
-              <a:t>Photon energy must equal E final minus E initial.</a:t>
+              <a:t>Photon energy must match the gap between the two levels exactly.</a:t>
             </a:r>
             <a:endParaRPr lang="en-US" sz="1600" dirty="0"/>
           </a:p>
@@ -15429,9 +14364,9 @@
 </p:sld>
 </file>
 
-<file path=ppt/slides/slide14.xml><?xml version="1.0" encoding="utf-8"?>
+<file path=ppt/slides/slide12.xml><?xml version="1.0" encoding="utf-8"?>
 <p:sld xmlns:a="http://schemas.openxmlformats.org/drawingml/2006/main" xmlns:r="http://schemas.openxmlformats.org/officeDocument/2006/relationships" xmlns:p="http://schemas.openxmlformats.org/presentationml/2006/main">
-  <p:cSld name="Slide 14">
+  <p:cSld name="Slide 12">
     <p:spTree>
       <p:nvGrpSpPr>
         <p:cNvPr id="1" name=""/>
@@ -15710,7 +14645,7 @@
                 <a:ea typeface="Trade Gothic Next" pitchFamily="34" charset="-122"/>
                 <a:cs typeface="Trade Gothic Next" pitchFamily="34" charset="-120"/>
               </a:rPr>
-              <a:t>Its energy is the absolute value of ΔE.</a:t>
+              <a:t>Its energy equals the gap the electron just crossed.</a:t>
             </a:r>
             <a:endParaRPr lang="en-US" sz="1600" dirty="0"/>
           </a:p>
@@ -15907,6 +14842,1044 @@
               <a:buNone/>
             </a:pPr>
             <a:endParaRPr lang="en-US" sz="2000" dirty="0"/>
+          </a:p>
+        </p:txBody>
+      </p:sp>
+    </p:spTree>
+  </p:cSld>
+  <p:clrMapOvr>
+    <a:masterClrMapping/>
+  </p:clrMapOvr>
+</p:sld>
+</file>
+
+<file path=ppt/slides/slide13.xml><?xml version="1.0" encoding="utf-8"?>
+<p:sld xmlns:a="http://schemas.openxmlformats.org/drawingml/2006/main" xmlns:r="http://schemas.openxmlformats.org/officeDocument/2006/relationships" xmlns:p="http://schemas.openxmlformats.org/presentationml/2006/main">
+  <p:cSld name="Slide 13">
+    <p:spTree>
+      <p:nvGrpSpPr>
+        <p:cNvPr id="1" name=""/>
+        <p:cNvGrpSpPr/>
+        <p:nvPr/>
+      </p:nvGrpSpPr>
+      <p:grpSpPr>
+        <a:xfrm>
+          <a:off x="0" y="0"/>
+          <a:ext cx="0" cy="0"/>
+          <a:chOff x="0" y="0"/>
+          <a:chExt cx="0" cy="0"/>
+        </a:xfrm>
+      </p:grpSpPr>
+      <p:sp>
+        <p:nvSpPr>
+          <p:cNvPr id="2" name="Text 2"/>
+          <p:cNvSpPr txBox="1"/>
+          <p:nvPr>
+            <p:ph idx="103" type="title" hasCustomPrompt="1"/>
+          </p:nvPr>
+        </p:nvSpPr>
+        <p:spPr>
+          <a:xfrm>
+            <a:off x="685800" y="932688"/>
+            <a:ext cx="7863840" cy="868680"/>
+          </a:xfrm>
+          <a:prstGeom prst="rect">
+            <a:avLst/>
+          </a:prstGeom>
+          <a:noFill/>
+          <a:ln/>
+        </p:spPr>
+        <p:txBody>
+          <a:bodyPr wrap="square" lIns="0" tIns="0" rIns="0" bIns="0" rtlCol="0" anchor="t"/>
+          <a:lstStyle/>
+          <a:p>
+            <a:pPr algn="l" indent="0" marL="0">
+              <a:buNone/>
+            </a:pPr>
+            <a:r>
+              <a:rPr lang="en-US" sz="2800" b="1" dirty="0">
+                <a:solidFill>
+                  <a:srgbClr val="14161B"/>
+                </a:solidFill>
+                <a:latin typeface="Trade Gothic Next" pitchFamily="34" charset="0"/>
+                <a:ea typeface="Trade Gothic Next" pitchFamily="34" charset="-122"/>
+                <a:cs typeface="Trade Gothic Next" pitchFamily="34" charset="-120"/>
+              </a:rPr>
+              <a:t>Example: Ground or Excited?</a:t>
+            </a:r>
+            <a:endParaRPr lang="en-US" sz="2800" dirty="0"/>
+          </a:p>
+        </p:txBody>
+      </p:sp>
+      <p:sp>
+        <p:nvSpPr>
+          <p:cNvPr id="3" name="Text 2"/>
+          <p:cNvSpPr txBox="1"/>
+          <p:nvPr>
+            <p:ph idx="104" type="body" hasCustomPrompt="1"/>
+          </p:nvPr>
+        </p:nvSpPr>
+        <p:spPr>
+          <a:xfrm>
+            <a:off x="685800" y="1847088"/>
+            <a:ext cx="7863840" cy="384048"/>
+          </a:xfrm>
+          <a:prstGeom prst="rect">
+            <a:avLst/>
+          </a:prstGeom>
+          <a:noFill/>
+          <a:ln/>
+        </p:spPr>
+        <p:txBody>
+          <a:bodyPr wrap="square" lIns="0" tIns="0" rIns="0" bIns="0" rtlCol="0"/>
+          <a:lstStyle/>
+          <a:p>
+            <a:pPr indent="0" marL="0">
+              <a:buNone/>
+            </a:pPr>
+            <a:r>
+              <a:rPr lang="en-US" sz="1700" dirty="0">
+                <a:solidFill>
+                  <a:srgbClr val="2E3338"/>
+                </a:solidFill>
+                <a:latin typeface="Trade Gothic Next" pitchFamily="34" charset="0"/>
+                <a:ea typeface="Trade Gothic Next" pitchFamily="34" charset="-122"/>
+                <a:cs typeface="Trade Gothic Next" pitchFamily="34" charset="-120"/>
+              </a:rPr>
+              <a:t>We do this one together. Write the reasoning, not just the answer.</a:t>
+            </a:r>
+            <a:endParaRPr lang="en-US" sz="1700" dirty="0"/>
+          </a:p>
+        </p:txBody>
+      </p:sp>
+      <p:sp>
+        <p:nvSpPr>
+          <p:cNvPr id="4" name="Text 6"/>
+          <p:cNvSpPr txBox="1"/>
+          <p:nvPr>
+            <p:ph idx="110" type="body" hasCustomPrompt="1"/>
+          </p:nvPr>
+        </p:nvSpPr>
+        <p:spPr>
+          <a:xfrm>
+            <a:off x="886968" y="2798064"/>
+            <a:ext cx="4992624" cy="548640"/>
+          </a:xfrm>
+          <a:prstGeom prst="rect">
+            <a:avLst/>
+          </a:prstGeom>
+          <a:noFill/>
+          <a:ln/>
+        </p:spPr>
+        <p:txBody>
+          <a:bodyPr wrap="square" lIns="0" tIns="0" rIns="0" bIns="0" rtlCol="0"/>
+          <a:lstStyle/>
+          <a:p>
+            <a:pPr indent="0" marL="0">
+              <a:buNone/>
+            </a:pPr>
+            <a:r>
+              <a:rPr lang="en-US" sz="1600" dirty="0">
+                <a:solidFill>
+                  <a:srgbClr val="EDF0E5"/>
+                </a:solidFill>
+                <a:latin typeface="Trade Gothic Next" pitchFamily="34" charset="0"/>
+                <a:ea typeface="Trade Gothic Next" pitchFamily="34" charset="-122"/>
+                <a:cs typeface="Trade Gothic Next" pitchFamily="34" charset="-120"/>
+              </a:rPr>
+              <a:t>A hydrogen electron is in n = 3. Is it in the ground state? What must happen to move it to n = 5?</a:t>
+            </a:r>
+            <a:endParaRPr lang="en-US" sz="1600" dirty="0"/>
+          </a:p>
+        </p:txBody>
+      </p:sp>
+      <p:sp>
+        <p:nvSpPr>
+          <p:cNvPr id="5" name="Text 7"/>
+          <p:cNvSpPr txBox="1"/>
+          <p:nvPr>
+            <p:ph idx="112" type="body" hasCustomPrompt="1"/>
+          </p:nvPr>
+        </p:nvSpPr>
+        <p:spPr>
+          <a:xfrm>
+            <a:off x="886968" y="3776472"/>
+            <a:ext cx="2203704" cy="219456"/>
+          </a:xfrm>
+          <a:prstGeom prst="rect">
+            <a:avLst/>
+          </a:prstGeom>
+          <a:noFill/>
+          <a:ln/>
+        </p:spPr>
+        <p:txBody>
+          <a:bodyPr wrap="square" lIns="0" tIns="0" rIns="0" bIns="0" rtlCol="0"/>
+          <a:lstStyle/>
+          <a:p>
+            <a:pPr indent="0" marL="0">
+              <a:buNone/>
+            </a:pPr>
+            <a:r>
+              <a:rPr lang="en-US" sz="1200" b="1" spc="120" kern="0" dirty="0">
+                <a:solidFill>
+                  <a:srgbClr val="2E3338"/>
+                </a:solidFill>
+                <a:latin typeface="Trade Gothic Next" pitchFamily="34" charset="0"/>
+                <a:ea typeface="Trade Gothic Next" pitchFamily="34" charset="-122"/>
+                <a:cs typeface="Trade Gothic Next" pitchFamily="34" charset="-120"/>
+              </a:rPr>
+              <a:t>GIVEN</a:t>
+            </a:r>
+            <a:endParaRPr lang="en-US" sz="1200" dirty="0"/>
+          </a:p>
+        </p:txBody>
+      </p:sp>
+      <p:sp>
+        <p:nvSpPr>
+          <p:cNvPr id="6" name="Text 7"/>
+          <p:cNvSpPr txBox="1"/>
+          <p:nvPr>
+            <p:ph idx="113" type="body" hasCustomPrompt="1"/>
+          </p:nvPr>
+        </p:nvSpPr>
+        <p:spPr>
+          <a:xfrm>
+            <a:off x="886968" y="4069080"/>
+            <a:ext cx="2203704" cy="1078992"/>
+          </a:xfrm>
+          <a:prstGeom prst="rect">
+            <a:avLst/>
+          </a:prstGeom>
+          <a:noFill/>
+          <a:ln/>
+        </p:spPr>
+        <p:txBody>
+          <a:bodyPr wrap="square" lIns="0" tIns="0" rIns="0" bIns="0" rtlCol="0"/>
+          <a:lstStyle/>
+          <a:p>
+            <a:pPr indent="0" marL="0">
+              <a:buNone/>
+            </a:pPr>
+            <a:r>
+              <a:rPr lang="en-US" sz="1600" dirty="0">
+                <a:solidFill>
+                  <a:srgbClr val="14161B"/>
+                </a:solidFill>
+                <a:latin typeface="Trade Gothic Next" pitchFamily="34" charset="0"/>
+                <a:ea typeface="Trade Gothic Next" pitchFamily="34" charset="-122"/>
+                <a:cs typeface="Trade Gothic Next" pitchFamily="34" charset="-120"/>
+              </a:rPr>
+              <a:t>Hydrogen</a:t>
+            </a:r>
+            <a:endParaRPr lang="en-US" sz="1600" dirty="0"/>
+          </a:p>
+          <a:p>
+            <a:pPr indent="0" marL="0">
+              <a:buNone/>
+            </a:pPr>
+            <a:r>
+              <a:rPr lang="en-US" sz="1600" dirty="0">
+                <a:solidFill>
+                  <a:srgbClr val="14161B"/>
+                </a:solidFill>
+                <a:latin typeface="Trade Gothic Next" pitchFamily="34" charset="0"/>
+                <a:ea typeface="Trade Gothic Next" pitchFamily="34" charset="-122"/>
+                <a:cs typeface="Trade Gothic Next" pitchFamily="34" charset="-120"/>
+              </a:rPr>
+              <a:t>Electron in n = 3</a:t>
+            </a:r>
+            <a:endParaRPr lang="en-US" sz="1600" dirty="0"/>
+          </a:p>
+          <a:p>
+            <a:pPr indent="0" marL="0">
+              <a:buNone/>
+            </a:pPr>
+            <a:r>
+              <a:rPr lang="en-US" sz="1600" dirty="0">
+                <a:solidFill>
+                  <a:srgbClr val="14161B"/>
+                </a:solidFill>
+                <a:latin typeface="Trade Gothic Next" pitchFamily="34" charset="0"/>
+                <a:ea typeface="Trade Gothic Next" pitchFamily="34" charset="-122"/>
+                <a:cs typeface="Trade Gothic Next" pitchFamily="34" charset="-120"/>
+              </a:rPr>
+              <a:t>Target level: n = 5</a:t>
+            </a:r>
+            <a:endParaRPr lang="en-US" sz="1600" dirty="0"/>
+          </a:p>
+        </p:txBody>
+      </p:sp>
+      <p:sp>
+        <p:nvSpPr>
+          <p:cNvPr id="7" name="Text 8"/>
+          <p:cNvSpPr txBox="1"/>
+          <p:nvPr>
+            <p:ph idx="115" type="body" hasCustomPrompt="1"/>
+          </p:nvPr>
+        </p:nvSpPr>
+        <p:spPr>
+          <a:xfrm>
+            <a:off x="3675888" y="3776472"/>
+            <a:ext cx="2203704" cy="219456"/>
+          </a:xfrm>
+          <a:prstGeom prst="rect">
+            <a:avLst/>
+          </a:prstGeom>
+          <a:noFill/>
+          <a:ln/>
+        </p:spPr>
+        <p:txBody>
+          <a:bodyPr wrap="square" lIns="0" tIns="0" rIns="0" bIns="0" rtlCol="0"/>
+          <a:lstStyle/>
+          <a:p>
+            <a:pPr indent="0" marL="0">
+              <a:buNone/>
+            </a:pPr>
+            <a:r>
+              <a:rPr lang="en-US" sz="1200" b="1" spc="120" kern="0" dirty="0">
+                <a:solidFill>
+                  <a:srgbClr val="2E3338"/>
+                </a:solidFill>
+                <a:latin typeface="Trade Gothic Next" pitchFamily="34" charset="0"/>
+                <a:ea typeface="Trade Gothic Next" pitchFamily="34" charset="-122"/>
+                <a:cs typeface="Trade Gothic Next" pitchFamily="34" charset="-120"/>
+              </a:rPr>
+              <a:t>NEED</a:t>
+            </a:r>
+            <a:endParaRPr lang="en-US" sz="1200" dirty="0"/>
+          </a:p>
+        </p:txBody>
+      </p:sp>
+      <p:sp>
+        <p:nvSpPr>
+          <p:cNvPr id="8" name="Text 8"/>
+          <p:cNvSpPr txBox="1"/>
+          <p:nvPr>
+            <p:ph idx="116" type="body" hasCustomPrompt="1"/>
+          </p:nvPr>
+        </p:nvSpPr>
+        <p:spPr>
+          <a:xfrm>
+            <a:off x="3675888" y="4069080"/>
+            <a:ext cx="2203704" cy="1078992"/>
+          </a:xfrm>
+          <a:prstGeom prst="rect">
+            <a:avLst/>
+          </a:prstGeom>
+          <a:noFill/>
+          <a:ln/>
+        </p:spPr>
+        <p:txBody>
+          <a:bodyPr wrap="square" lIns="0" tIns="0" rIns="0" bIns="0" rtlCol="0"/>
+          <a:lstStyle/>
+          <a:p>
+            <a:pPr indent="0" marL="0">
+              <a:buNone/>
+            </a:pPr>
+            <a:r>
+              <a:rPr lang="en-US" sz="1600" dirty="0">
+                <a:solidFill>
+                  <a:srgbClr val="14161B"/>
+                </a:solidFill>
+                <a:latin typeface="Trade Gothic Next" pitchFamily="34" charset="0"/>
+                <a:ea typeface="Trade Gothic Next" pitchFamily="34" charset="-122"/>
+                <a:cs typeface="Trade Gothic Next" pitchFamily="34" charset="-120"/>
+              </a:rPr>
+              <a:t>Ground state or excited?</a:t>
+            </a:r>
+            <a:endParaRPr lang="en-US" sz="1600" dirty="0"/>
+          </a:p>
+          <a:p>
+            <a:pPr indent="0" marL="0">
+              <a:buNone/>
+            </a:pPr>
+            <a:r>
+              <a:rPr lang="en-US" sz="1600" dirty="0">
+                <a:solidFill>
+                  <a:srgbClr val="14161B"/>
+                </a:solidFill>
+                <a:latin typeface="Trade Gothic Next" pitchFamily="34" charset="0"/>
+                <a:ea typeface="Trade Gothic Next" pitchFamily="34" charset="-122"/>
+                <a:cs typeface="Trade Gothic Next" pitchFamily="34" charset="-120"/>
+              </a:rPr>
+              <a:t>What moves it up?</a:t>
+            </a:r>
+            <a:endParaRPr lang="en-US" sz="1600" dirty="0"/>
+          </a:p>
+        </p:txBody>
+      </p:sp>
+      <p:sp>
+        <p:nvSpPr>
+          <p:cNvPr id="9" name="Text 10"/>
+          <p:cNvSpPr txBox="1"/>
+          <p:nvPr>
+            <p:ph idx="119" type="body" hasCustomPrompt="1"/>
+          </p:nvPr>
+        </p:nvSpPr>
+        <p:spPr>
+          <a:xfrm>
+            <a:off x="6464808" y="2880360"/>
+            <a:ext cx="4837176" cy="2286000"/>
+          </a:xfrm>
+          <a:prstGeom prst="rect">
+            <a:avLst/>
+          </a:prstGeom>
+          <a:noFill/>
+          <a:ln/>
+        </p:spPr>
+        <p:txBody>
+          <a:bodyPr wrap="square" lIns="0" tIns="0" rIns="0" bIns="0" rtlCol="0"/>
+          <a:lstStyle/>
+          <a:p>
+            <a:pPr indent="0" marL="0">
+              <a:buNone/>
+            </a:pPr>
+            <a:endParaRPr lang="en-US" sz="1900" dirty="0"/>
+          </a:p>
+        </p:txBody>
+      </p:sp>
+      <p:sp>
+        <p:nvSpPr>
+          <p:cNvPr id="10" name="Text 12"/>
+          <p:cNvSpPr txBox="1"/>
+          <p:nvPr>
+            <p:ph idx="122" type="body" hasCustomPrompt="1"/>
+          </p:nvPr>
+        </p:nvSpPr>
+        <p:spPr>
+          <a:xfrm>
+            <a:off x="2240280" y="5605272"/>
+            <a:ext cx="8991295" cy="402336"/>
+          </a:xfrm>
+          <a:prstGeom prst="rect">
+            <a:avLst/>
+          </a:prstGeom>
+          <a:noFill/>
+          <a:ln/>
+        </p:spPr>
+        <p:txBody>
+          <a:bodyPr wrap="square" lIns="0" tIns="0" rIns="0" bIns="0" rtlCol="0" anchor="ctr"/>
+          <a:lstStyle/>
+          <a:p>
+            <a:pPr indent="0" marL="0">
+              <a:buNone/>
+            </a:pPr>
+            <a:r>
+              <a:rPr lang="en-US" sz="1600" b="1" dirty="0">
+                <a:solidFill>
+                  <a:srgbClr val="EDF0E5"/>
+                </a:solidFill>
+                <a:latin typeface="Trade Gothic Next" pitchFamily="34" charset="0"/>
+                <a:ea typeface="Trade Gothic Next" pitchFamily="34" charset="-122"/>
+                <a:cs typeface="Trade Gothic Next" pitchFamily="34" charset="-120"/>
+              </a:rPr>
+              <a:t>To move up, the electron absorbs a photon of exactly the right energy.</a:t>
+            </a:r>
+            <a:endParaRPr lang="en-US" sz="1600" dirty="0"/>
+          </a:p>
+        </p:txBody>
+      </p:sp>
+      <p:sp>
+        <p:nvSpPr>
+          <p:cNvPr id="11" name="Text 1"/>
+          <p:cNvSpPr txBox="1"/>
+          <p:nvPr>
+            <p:ph idx="101" type="body" hasCustomPrompt="1"/>
+          </p:nvPr>
+        </p:nvSpPr>
+        <p:spPr>
+          <a:xfrm>
+            <a:off x="685800" y="384048"/>
+            <a:ext cx="6400800" cy="237744"/>
+          </a:xfrm>
+          <a:prstGeom prst="rect">
+            <a:avLst/>
+          </a:prstGeom>
+          <a:noFill/>
+          <a:ln/>
+        </p:spPr>
+        <p:txBody>
+          <a:bodyPr wrap="square" lIns="0" tIns="0" rIns="0" bIns="0" rtlCol="0" anchor="ctr"/>
+          <a:lstStyle/>
+          <a:p>
+            <a:pPr indent="0" marL="0">
+              <a:buNone/>
+            </a:pPr>
+            <a:r>
+              <a:rPr lang="en-US" sz="1100" b="1" spc="160" kern="0" dirty="0">
+                <a:solidFill>
+                  <a:srgbClr val="14161B"/>
+                </a:solidFill>
+                <a:latin typeface="Trade Gothic Next" pitchFamily="34" charset="0"/>
+                <a:ea typeface="Trade Gothic Next" pitchFamily="34" charset="-122"/>
+                <a:cs typeface="Trade Gothic Next" pitchFamily="34" charset="-120"/>
+              </a:rPr>
+              <a:t>UNIT 02  •  CHEMISTRY</a:t>
+            </a:r>
+            <a:endParaRPr lang="en-US" sz="1100" dirty="0"/>
+          </a:p>
+        </p:txBody>
+      </p:sp>
+      <p:sp>
+        <p:nvSpPr>
+          <p:cNvPr id="12" name="Text 13"/>
+          <p:cNvSpPr txBox="1"/>
+          <p:nvPr>
+            <p:ph idx="124" type="body" hasCustomPrompt="1"/>
+          </p:nvPr>
+        </p:nvSpPr>
+        <p:spPr>
+          <a:xfrm>
+            <a:off x="8762695" y="6382512"/>
+            <a:ext cx="2743200" cy="237744"/>
+          </a:xfrm>
+          <a:prstGeom prst="rect">
+            <a:avLst/>
+          </a:prstGeom>
+          <a:noFill/>
+          <a:ln/>
+        </p:spPr>
+        <p:txBody>
+          <a:bodyPr wrap="square" lIns="0" tIns="0" rIns="0" bIns="0" rtlCol="0" anchor="ctr"/>
+          <a:lstStyle/>
+          <a:p>
+            <a:pPr algn="r" indent="0" marL="0">
+              <a:buNone/>
+            </a:pPr>
+            <a:r>
+              <a:rPr lang="en-US" sz="1000" b="1" spc="140" kern="0" dirty="0">
+                <a:solidFill>
+                  <a:srgbClr val="2E3338"/>
+                </a:solidFill>
+                <a:latin typeface="Trade Gothic Next" pitchFamily="34" charset="0"/>
+                <a:ea typeface="Trade Gothic Next" pitchFamily="34" charset="-122"/>
+                <a:cs typeface="Trade Gothic Next" pitchFamily="34" charset="-120"/>
+              </a:rPr>
+              <a:t>U02 • S02.1</a:t>
+            </a:r>
+            <a:endParaRPr lang="en-US" sz="1000" dirty="0"/>
+          </a:p>
+        </p:txBody>
+      </p:sp>
+      <p:sp>
+        <p:nvSpPr>
+          <p:cNvPr id="14" name="Text 4"/>
+          <p:cNvSpPr txBox="1"/>
+          <p:nvPr>
+            <p:ph idx="107" hasCustomPrompt="1"/>
+          </p:nvPr>
+        </p:nvSpPr>
+        <p:spPr>
+          <a:xfrm>
+            <a:off x="9262872" y="1088136"/>
+            <a:ext cx="1901952" cy="1069848"/>
+          </a:xfrm>
+          <a:prstGeom prst="rect">
+            <a:avLst/>
+          </a:prstGeom>
+          <a:noFill/>
+          <a:ln/>
+        </p:spPr>
+        <p:txBody>
+          <a:bodyPr wrap="square" lIns="0" tIns="0" rIns="0" bIns="0" rtlCol="0" anchor="ctr"/>
+          <a:lstStyle/>
+          <a:p>
+            <a:pPr algn="ctr" indent="0" marL="0">
+              <a:buNone/>
+            </a:pPr>
+            <a:endParaRPr lang="en-US" sz="1200" dirty="0"/>
+          </a:p>
+        </p:txBody>
+      </p:sp>
+    </p:spTree>
+  </p:cSld>
+  <p:clrMapOvr>
+    <a:masterClrMapping/>
+  </p:clrMapOvr>
+</p:sld>
+</file>
+
+<file path=ppt/slides/slide14.xml><?xml version="1.0" encoding="utf-8"?>
+<p:sld xmlns:a="http://schemas.openxmlformats.org/drawingml/2006/main" xmlns:r="http://schemas.openxmlformats.org/officeDocument/2006/relationships" xmlns:p="http://schemas.openxmlformats.org/presentationml/2006/main">
+  <p:cSld name="Slide 14">
+    <p:spTree>
+      <p:nvGrpSpPr>
+        <p:cNvPr id="1" name=""/>
+        <p:cNvGrpSpPr/>
+        <p:nvPr/>
+      </p:nvGrpSpPr>
+      <p:grpSpPr>
+        <a:xfrm>
+          <a:off x="0" y="0"/>
+          <a:ext cx="0" cy="0"/>
+          <a:chOff x="0" y="0"/>
+          <a:chExt cx="0" cy="0"/>
+        </a:xfrm>
+      </p:grpSpPr>
+      <p:pic>
+        <p:nvPicPr>
+          <p:cNvPr id="2" name="Image 0" descr="/home/user/WorkWork/templates/slide/assets/chem_u02_s2.1_ground_excited.png">    </p:cNvPr>
+          <p:cNvPicPr>
+            <a:picLocks noChangeAspect="1"/>
+          </p:cNvPicPr>
+          <p:nvPr/>
+        </p:nvPicPr>
+        <p:blipFill>
+          <a:blip r:embed="rId1"/>
+          <a:stretch>
+            <a:fillRect/>
+          </a:stretch>
+        </p:blipFill>
+        <p:spPr>
+          <a:xfrm>
+            <a:off x="832104" y="2542817"/>
+            <a:ext cx="3867912" cy="2266141"/>
+          </a:xfrm>
+          <a:prstGeom prst="rect">
+            <a:avLst/>
+          </a:prstGeom>
+        </p:spPr>
+      </p:pic>
+      <p:sp>
+        <p:nvSpPr>
+          <p:cNvPr id="3" name="Text 2"/>
+          <p:cNvSpPr txBox="1"/>
+          <p:nvPr>
+            <p:ph idx="103" type="title" hasCustomPrompt="1"/>
+          </p:nvPr>
+        </p:nvSpPr>
+        <p:spPr>
+          <a:xfrm>
+            <a:off x="685800" y="932688"/>
+            <a:ext cx="10820095" cy="868680"/>
+          </a:xfrm>
+          <a:prstGeom prst="rect">
+            <a:avLst/>
+          </a:prstGeom>
+          <a:noFill/>
+          <a:ln/>
+        </p:spPr>
+        <p:txBody>
+          <a:bodyPr wrap="square" lIns="0" tIns="0" rIns="0" bIns="0" rtlCol="0" anchor="t"/>
+          <a:lstStyle/>
+          <a:p>
+            <a:pPr algn="l" indent="0" marL="0">
+              <a:buNone/>
+            </a:pPr>
+            <a:r>
+              <a:rPr lang="en-US" sz="2800" b="1" dirty="0">
+                <a:solidFill>
+                  <a:srgbClr val="14161B"/>
+                </a:solidFill>
+                <a:latin typeface="Trade Gothic Next" pitchFamily="34" charset="0"/>
+                <a:ea typeface="Trade Gothic Next" pitchFamily="34" charset="-122"/>
+                <a:cs typeface="Trade Gothic Next" pitchFamily="34" charset="-120"/>
+              </a:rPr>
+              <a:t>Ground or Excited, Worked</a:t>
+            </a:r>
+            <a:endParaRPr lang="en-US" sz="2800" dirty="0"/>
+          </a:p>
+        </p:txBody>
+      </p:sp>
+      <p:sp>
+        <p:nvSpPr>
+          <p:cNvPr id="4" name="Text 2"/>
+          <p:cNvSpPr txBox="1"/>
+          <p:nvPr>
+            <p:ph idx="104" type="body" hasCustomPrompt="1"/>
+          </p:nvPr>
+        </p:nvSpPr>
+        <p:spPr>
+          <a:xfrm>
+            <a:off x="685800" y="1847088"/>
+            <a:ext cx="10820095" cy="384048"/>
+          </a:xfrm>
+          <a:prstGeom prst="rect">
+            <a:avLst/>
+          </a:prstGeom>
+          <a:noFill/>
+          <a:ln/>
+        </p:spPr>
+        <p:txBody>
+          <a:bodyPr wrap="square" lIns="0" tIns="0" rIns="0" bIns="0" rtlCol="0"/>
+          <a:lstStyle/>
+          <a:p>
+            <a:pPr indent="0" marL="0">
+              <a:buNone/>
+            </a:pPr>
+            <a:r>
+              <a:rPr lang="en-US" sz="1700" dirty="0">
+                <a:solidFill>
+                  <a:srgbClr val="2E3338"/>
+                </a:solidFill>
+                <a:latin typeface="Trade Gothic Next" pitchFamily="34" charset="0"/>
+                <a:ea typeface="Trade Gothic Next" pitchFamily="34" charset="-122"/>
+                <a:cs typeface="Trade Gothic Next" pitchFamily="34" charset="-120"/>
+              </a:rPr>
+              <a:t>Find the level, then say which way the energy goes.</a:t>
+            </a:r>
+            <a:endParaRPr lang="en-US" sz="1700" dirty="0"/>
+          </a:p>
+        </p:txBody>
+      </p:sp>
+      <p:sp>
+        <p:nvSpPr>
+          <p:cNvPr id="5" name="Text 5"/>
+          <p:cNvSpPr txBox="1"/>
+          <p:nvPr>
+            <p:ph idx="109" type="body" hasCustomPrompt="1"/>
+          </p:nvPr>
+        </p:nvSpPr>
+        <p:spPr>
+          <a:xfrm>
+            <a:off x="5276088" y="2560320"/>
+            <a:ext cx="2752344" cy="219456"/>
+          </a:xfrm>
+          <a:prstGeom prst="rect">
+            <a:avLst/>
+          </a:prstGeom>
+          <a:noFill/>
+          <a:ln/>
+        </p:spPr>
+        <p:txBody>
+          <a:bodyPr wrap="square" lIns="0" tIns="0" rIns="0" bIns="0" rtlCol="0"/>
+          <a:lstStyle/>
+          <a:p>
+            <a:pPr indent="0" marL="0">
+              <a:buNone/>
+            </a:pPr>
+            <a:r>
+              <a:rPr lang="en-US" sz="1200" b="1" spc="120" kern="0" dirty="0">
+                <a:solidFill>
+                  <a:srgbClr val="2E3338"/>
+                </a:solidFill>
+                <a:latin typeface="Trade Gothic Next" pitchFamily="34" charset="0"/>
+                <a:ea typeface="Trade Gothic Next" pitchFamily="34" charset="-122"/>
+                <a:cs typeface="Trade Gothic Next" pitchFamily="34" charset="-120"/>
+              </a:rPr>
+              <a:t>IDEAS</a:t>
+            </a:r>
+            <a:endParaRPr lang="en-US" sz="1200" dirty="0"/>
+          </a:p>
+        </p:txBody>
+      </p:sp>
+      <p:sp>
+        <p:nvSpPr>
+          <p:cNvPr id="6" name="Text 5"/>
+          <p:cNvSpPr txBox="1"/>
+          <p:nvPr>
+            <p:ph idx="110" type="body" hasCustomPrompt="1"/>
+          </p:nvPr>
+        </p:nvSpPr>
+        <p:spPr>
+          <a:xfrm>
+            <a:off x="5276088" y="2852928"/>
+            <a:ext cx="2752344" cy="1901952"/>
+          </a:xfrm>
+          <a:prstGeom prst="rect">
+            <a:avLst/>
+          </a:prstGeom>
+          <a:noFill/>
+          <a:ln/>
+        </p:spPr>
+        <p:txBody>
+          <a:bodyPr wrap="square" lIns="0" tIns="0" rIns="0" bIns="0" rtlCol="0"/>
+          <a:lstStyle/>
+          <a:p>
+            <a:pPr indent="0" marL="0">
+              <a:buNone/>
+            </a:pPr>
+            <a:r>
+              <a:rPr lang="en-US" sz="1600" dirty="0">
+                <a:solidFill>
+                  <a:srgbClr val="14161B"/>
+                </a:solidFill>
+                <a:latin typeface="Trade Gothic Next" pitchFamily="34" charset="0"/>
+                <a:ea typeface="Trade Gothic Next" pitchFamily="34" charset="-122"/>
+                <a:cs typeface="Trade Gothic Next" pitchFamily="34" charset="-120"/>
+              </a:rPr>
+              <a:t>Ground state: n = 1 only.</a:t>
+            </a:r>
+            <a:endParaRPr lang="en-US" sz="1600" dirty="0"/>
+          </a:p>
+          <a:p>
+            <a:pPr indent="0" marL="0">
+              <a:buNone/>
+            </a:pPr>
+            <a:r>
+              <a:rPr lang="en-US" sz="1600" dirty="0">
+                <a:solidFill>
+                  <a:srgbClr val="14161B"/>
+                </a:solidFill>
+                <a:latin typeface="Trade Gothic Next" pitchFamily="34" charset="0"/>
+                <a:ea typeface="Trade Gothic Next" pitchFamily="34" charset="-122"/>
+                <a:cs typeface="Trade Gothic Next" pitchFamily="34" charset="-120"/>
+              </a:rPr>
+              <a:t>Any higher n: excited.</a:t>
+            </a:r>
+            <a:endParaRPr lang="en-US" sz="1600" dirty="0"/>
+          </a:p>
+          <a:p>
+            <a:pPr indent="0" marL="0">
+              <a:buNone/>
+            </a:pPr>
+            <a:r>
+              <a:rPr lang="en-US" sz="1600" dirty="0">
+                <a:solidFill>
+                  <a:srgbClr val="14161B"/>
+                </a:solidFill>
+                <a:latin typeface="Trade Gothic Next" pitchFamily="34" charset="0"/>
+                <a:ea typeface="Trade Gothic Next" pitchFamily="34" charset="-122"/>
+                <a:cs typeface="Trade Gothic Next" pitchFamily="34" charset="-120"/>
+              </a:rPr>
+              <a:t>Up needs energy in.</a:t>
+            </a:r>
+            <a:endParaRPr lang="en-US" sz="1600" dirty="0"/>
+          </a:p>
+        </p:txBody>
+      </p:sp>
+      <p:sp>
+        <p:nvSpPr>
+          <p:cNvPr id="7" name="Text 7"/>
+          <p:cNvSpPr txBox="1"/>
+          <p:nvPr>
+            <p:ph idx="113" type="body" hasCustomPrompt="1"/>
+          </p:nvPr>
+        </p:nvSpPr>
+        <p:spPr>
+          <a:xfrm>
+            <a:off x="8613648" y="2871216"/>
+            <a:ext cx="2688336" cy="1920240"/>
+          </a:xfrm>
+          <a:prstGeom prst="rect">
+            <a:avLst/>
+          </a:prstGeom>
+          <a:noFill/>
+          <a:ln/>
+        </p:spPr>
+        <p:txBody>
+          <a:bodyPr wrap="square" lIns="0" tIns="0" rIns="0" bIns="0" rtlCol="0"/>
+          <a:lstStyle/>
+          <a:p>
+            <a:pPr indent="0" marL="0">
+              <a:buNone/>
+            </a:pPr>
+            <a:r>
+              <a:rPr lang="en-US" sz="1900" dirty="0">
+                <a:solidFill>
+                  <a:srgbClr val="14161B"/>
+                </a:solidFill>
+                <a:latin typeface="Trade Gothic Next" pitchFamily="34" charset="0"/>
+                <a:ea typeface="Trade Gothic Next" pitchFamily="34" charset="-122"/>
+                <a:cs typeface="Trade Gothic Next" pitchFamily="34" charset="-120"/>
+              </a:rPr>
+              <a:t>n = 3 is above n = 1</a:t>
+            </a:r>
+            <a:endParaRPr lang="en-US" sz="1900" dirty="0"/>
+          </a:p>
+          <a:p>
+            <a:pPr indent="0" marL="0">
+              <a:buNone/>
+            </a:pPr>
+            <a:r>
+              <a:rPr lang="en-US" sz="1900" dirty="0">
+                <a:solidFill>
+                  <a:srgbClr val="14161B"/>
+                </a:solidFill>
+                <a:latin typeface="Trade Gothic Next" pitchFamily="34" charset="0"/>
+                <a:ea typeface="Trade Gothic Next" pitchFamily="34" charset="-122"/>
+                <a:cs typeface="Trade Gothic Next" pitchFamily="34" charset="-120"/>
+              </a:rPr>
+              <a:t>So: excited state</a:t>
+            </a:r>
+            <a:endParaRPr lang="en-US" sz="1900" dirty="0"/>
+          </a:p>
+          <a:p>
+            <a:pPr indent="0" marL="0">
+              <a:buNone/>
+            </a:pPr>
+            <a:r>
+              <a:rPr lang="en-US" sz="1900" dirty="0">
+                <a:solidFill>
+                  <a:srgbClr val="14161B"/>
+                </a:solidFill>
+                <a:latin typeface="Trade Gothic Next" pitchFamily="34" charset="0"/>
+                <a:ea typeface="Trade Gothic Next" pitchFamily="34" charset="-122"/>
+                <a:cs typeface="Trade Gothic Next" pitchFamily="34" charset="-120"/>
+              </a:rPr>
+              <a:t>To reach n = 5:</a:t>
+            </a:r>
+            <a:endParaRPr lang="en-US" sz="1900" dirty="0"/>
+          </a:p>
+          <a:p>
+            <a:pPr indent="0" marL="0">
+              <a:buNone/>
+            </a:pPr>
+            <a:r>
+              <a:rPr lang="en-US" sz="1900" dirty="0">
+                <a:solidFill>
+                  <a:srgbClr val="14161B"/>
+                </a:solidFill>
+                <a:latin typeface="Trade Gothic Next" pitchFamily="34" charset="0"/>
+                <a:ea typeface="Trade Gothic Next" pitchFamily="34" charset="-122"/>
+                <a:cs typeface="Trade Gothic Next" pitchFamily="34" charset="-120"/>
+              </a:rPr>
+              <a:t>absorb a matching photon</a:t>
+            </a:r>
+            <a:endParaRPr lang="en-US" sz="1900" dirty="0"/>
+          </a:p>
+        </p:txBody>
+      </p:sp>
+      <p:sp>
+        <p:nvSpPr>
+          <p:cNvPr id="8" name="Text 9"/>
+          <p:cNvSpPr txBox="1"/>
+          <p:nvPr>
+            <p:ph idx="116" type="body" hasCustomPrompt="1"/>
+          </p:nvPr>
+        </p:nvSpPr>
+        <p:spPr>
+          <a:xfrm>
+            <a:off x="2240280" y="5212080"/>
+            <a:ext cx="8991295" cy="402336"/>
+          </a:xfrm>
+          <a:prstGeom prst="rect">
+            <a:avLst/>
+          </a:prstGeom>
+          <a:noFill/>
+          <a:ln/>
+        </p:spPr>
+        <p:txBody>
+          <a:bodyPr wrap="square" lIns="0" tIns="0" rIns="0" bIns="0" rtlCol="0" anchor="ctr"/>
+          <a:lstStyle/>
+          <a:p>
+            <a:pPr indent="0" marL="0">
+              <a:buNone/>
+            </a:pPr>
+            <a:r>
+              <a:rPr lang="en-US" sz="1600" b="1" dirty="0">
+                <a:solidFill>
+                  <a:srgbClr val="EDF0E5"/>
+                </a:solidFill>
+                <a:latin typeface="Trade Gothic Next" pitchFamily="34" charset="0"/>
+                <a:ea typeface="Trade Gothic Next" pitchFamily="34" charset="-122"/>
+                <a:cs typeface="Trade Gothic Next" pitchFamily="34" charset="-120"/>
+              </a:rPr>
+              <a:t>n = 3 is above n = 1, so the electron is excited, not in the ground state.</a:t>
+            </a:r>
+            <a:endParaRPr lang="en-US" sz="1600" dirty="0"/>
+          </a:p>
+        </p:txBody>
+      </p:sp>
+      <p:sp>
+        <p:nvSpPr>
+          <p:cNvPr id="9" name="Text 1"/>
+          <p:cNvSpPr txBox="1"/>
+          <p:nvPr>
+            <p:ph idx="101" type="body" hasCustomPrompt="1"/>
+          </p:nvPr>
+        </p:nvSpPr>
+        <p:spPr>
+          <a:xfrm>
+            <a:off x="685800" y="384048"/>
+            <a:ext cx="6400800" cy="237744"/>
+          </a:xfrm>
+          <a:prstGeom prst="rect">
+            <a:avLst/>
+          </a:prstGeom>
+          <a:noFill/>
+          <a:ln/>
+        </p:spPr>
+        <p:txBody>
+          <a:bodyPr wrap="square" lIns="0" tIns="0" rIns="0" bIns="0" rtlCol="0" anchor="ctr"/>
+          <a:lstStyle/>
+          <a:p>
+            <a:pPr indent="0" marL="0">
+              <a:buNone/>
+            </a:pPr>
+            <a:r>
+              <a:rPr lang="en-US" sz="1100" b="1" spc="160" kern="0" dirty="0">
+                <a:solidFill>
+                  <a:srgbClr val="14161B"/>
+                </a:solidFill>
+                <a:latin typeface="Trade Gothic Next" pitchFamily="34" charset="0"/>
+                <a:ea typeface="Trade Gothic Next" pitchFamily="34" charset="-122"/>
+                <a:cs typeface="Trade Gothic Next" pitchFamily="34" charset="-120"/>
+              </a:rPr>
+              <a:t>UNIT 02  •  CHEMISTRY</a:t>
+            </a:r>
+            <a:endParaRPr lang="en-US" sz="1100" dirty="0"/>
+          </a:p>
+        </p:txBody>
+      </p:sp>
+      <p:sp>
+        <p:nvSpPr>
+          <p:cNvPr id="10" name="Text 10"/>
+          <p:cNvSpPr txBox="1"/>
+          <p:nvPr>
+            <p:ph idx="118" type="body" hasCustomPrompt="1"/>
+          </p:nvPr>
+        </p:nvSpPr>
+        <p:spPr>
+          <a:xfrm>
+            <a:off x="8762695" y="6382512"/>
+            <a:ext cx="2743200" cy="237744"/>
+          </a:xfrm>
+          <a:prstGeom prst="rect">
+            <a:avLst/>
+          </a:prstGeom>
+          <a:noFill/>
+          <a:ln/>
+        </p:spPr>
+        <p:txBody>
+          <a:bodyPr wrap="square" lIns="0" tIns="0" rIns="0" bIns="0" rtlCol="0" anchor="ctr"/>
+          <a:lstStyle/>
+          <a:p>
+            <a:pPr algn="r" indent="0" marL="0">
+              <a:buNone/>
+            </a:pPr>
+            <a:r>
+              <a:rPr lang="en-US" sz="1000" b="1" spc="140" kern="0" dirty="0">
+                <a:solidFill>
+                  <a:srgbClr val="2E3338"/>
+                </a:solidFill>
+                <a:latin typeface="Trade Gothic Next" pitchFamily="34" charset="0"/>
+                <a:ea typeface="Trade Gothic Next" pitchFamily="34" charset="-122"/>
+                <a:cs typeface="Trade Gothic Next" pitchFamily="34" charset="-120"/>
+              </a:rPr>
+              <a:t>U02 • S02.1</a:t>
+            </a:r>
+            <a:endParaRPr lang="en-US" sz="1000" dirty="0"/>
+          </a:p>
+        </p:txBody>
+      </p:sp>
+      <p:sp>
+        <p:nvSpPr>
+          <p:cNvPr id="12" name="Text 4"/>
+          <p:cNvSpPr txBox="1"/>
+          <p:nvPr>
+            <p:ph idx="107" hasCustomPrompt="1"/>
+          </p:nvPr>
+        </p:nvSpPr>
+        <p:spPr>
+          <a:xfrm>
+            <a:off x="832104" y="2542032"/>
+            <a:ext cx="3867912" cy="2267712"/>
+          </a:xfrm>
+          <a:prstGeom prst="rect">
+            <a:avLst/>
+          </a:prstGeom>
+          <a:noFill/>
+          <a:ln/>
+        </p:spPr>
+        <p:txBody>
+          <a:bodyPr wrap="square" lIns="0" tIns="0" rIns="0" bIns="0" rtlCol="0" anchor="ctr"/>
+          <a:lstStyle/>
+          <a:p>
+            <a:pPr algn="ctr" indent="0" marL="0">
+              <a:buNone/>
+            </a:pPr>
+            <a:endParaRPr lang="en-US" sz="1200" dirty="0"/>
           </a:p>
         </p:txBody>
       </p:sp>
@@ -15970,7 +15943,7 @@
                 <a:ea typeface="Trade Gothic Next" pitchFamily="34" charset="-122"/>
                 <a:cs typeface="Trade Gothic Next" pitchFamily="34" charset="-120"/>
               </a:rPr>
-              <a:t>Example: Drop from n = 3 to n = 2</a:t>
+              <a:t>Example: Ranking Three Drops</a:t>
             </a:r>
             <a:endParaRPr lang="en-US" sz="2800" dirty="0"/>
           </a:p>
@@ -16011,7 +15984,7 @@
                 <a:ea typeface="Trade Gothic Next" pitchFamily="34" charset="-122"/>
                 <a:cs typeface="Trade Gothic Next" pitchFamily="34" charset="-120"/>
               </a:rPr>
-              <a:t>Find the energy change, then say where the energy went.</a:t>
+              <a:t>Use the to-scale level diagram. A longer drop is a bigger drop.</a:t>
             </a:r>
             <a:endParaRPr lang="en-US" sz="1700" dirty="0"/>
           </a:p>
@@ -16052,7 +16025,7 @@
                 <a:ea typeface="Trade Gothic Next" pitchFamily="34" charset="-122"/>
                 <a:cs typeface="Trade Gothic Next" pitchFamily="34" charset="-120"/>
               </a:rPr>
-              <a:t>A hydrogen electron drops from n = 3 to n = 2. Find ΔE. Is energy absorbed or released?</a:t>
+              <a:t>Rank drops A, B and C from least to most energy released. Which gives the bluest light?</a:t>
             </a:r>
             <a:endParaRPr lang="en-US" sz="1600" dirty="0"/>
           </a:p>
@@ -16134,7 +16107,7 @@
                 <a:ea typeface="Trade Gothic Next" pitchFamily="34" charset="-122"/>
                 <a:cs typeface="Trade Gothic Next" pitchFamily="34" charset="-120"/>
               </a:rPr>
-              <a:t>n = 3 to n = 2</a:t>
+              <a:t>A: n = 4 to n = 2</a:t>
             </a:r>
             <a:endParaRPr lang="en-US" sz="1600" dirty="0"/>
           </a:p>
@@ -16151,13 +16124,16 @@
                 <a:ea typeface="Trade Gothic Next" pitchFamily="34" charset="-122"/>
                 <a:cs typeface="Trade Gothic Next" pitchFamily="34" charset="-120"/>
               </a:rPr>
-              <a:t>E₃ = −2.42 × 10</a:t>
-            </a:r>
-            <a:pPr indent="0" marL="0">
-              <a:buNone/>
-            </a:pPr>
-            <a:r>
-              <a:rPr lang="en-US" sz="1600" baseline="30000" dirty="0">
+              <a:t>B: n = 3 to n = 2</a:t>
+            </a:r>
+            <a:endParaRPr lang="en-US" sz="1600" dirty="0"/>
+          </a:p>
+          <a:p>
+            <a:pPr indent="0" marL="0">
+              <a:buNone/>
+            </a:pPr>
+            <a:r>
+              <a:rPr lang="en-US" sz="1600" dirty="0">
                 <a:solidFill>
                   <a:srgbClr val="14161B"/>
                 </a:solidFill>
@@ -16165,66 +16141,7 @@
                 <a:ea typeface="Trade Gothic Next" pitchFamily="34" charset="-122"/>
                 <a:cs typeface="Trade Gothic Next" pitchFamily="34" charset="-120"/>
               </a:rPr>
-              <a:t>−19</a:t>
-            </a:r>
-            <a:pPr indent="0" marL="0">
-              <a:buNone/>
-            </a:pPr>
-            <a:r>
-              <a:rPr lang="en-US" sz="1600" dirty="0">
-                <a:solidFill>
-                  <a:srgbClr val="14161B"/>
-                </a:solidFill>
-                <a:latin typeface="Trade Gothic Next" pitchFamily="34" charset="0"/>
-                <a:ea typeface="Trade Gothic Next" pitchFamily="34" charset="-122"/>
-                <a:cs typeface="Trade Gothic Next" pitchFamily="34" charset="-120"/>
-              </a:rPr>
-              <a:t> J</a:t>
-            </a:r>
-            <a:endParaRPr lang="en-US" sz="1600" dirty="0"/>
-          </a:p>
-          <a:p>
-            <a:pPr indent="0" marL="0">
-              <a:buNone/>
-            </a:pPr>
-            <a:r>
-              <a:rPr lang="en-US" sz="1600" dirty="0">
-                <a:solidFill>
-                  <a:srgbClr val="14161B"/>
-                </a:solidFill>
-                <a:latin typeface="Trade Gothic Next" pitchFamily="34" charset="0"/>
-                <a:ea typeface="Trade Gothic Next" pitchFamily="34" charset="-122"/>
-                <a:cs typeface="Trade Gothic Next" pitchFamily="34" charset="-120"/>
-              </a:rPr>
-              <a:t>E₂ = −5.45 × 10</a:t>
-            </a:r>
-            <a:pPr indent="0" marL="0">
-              <a:buNone/>
-            </a:pPr>
-            <a:r>
-              <a:rPr lang="en-US" sz="1600" baseline="30000" dirty="0">
-                <a:solidFill>
-                  <a:srgbClr val="14161B"/>
-                </a:solidFill>
-                <a:latin typeface="Trade Gothic Next" pitchFamily="34" charset="0"/>
-                <a:ea typeface="Trade Gothic Next" pitchFamily="34" charset="-122"/>
-                <a:cs typeface="Trade Gothic Next" pitchFamily="34" charset="-120"/>
-              </a:rPr>
-              <a:t>−19</a:t>
-            </a:r>
-            <a:pPr indent="0" marL="0">
-              <a:buNone/>
-            </a:pPr>
-            <a:r>
-              <a:rPr lang="en-US" sz="1600" dirty="0">
-                <a:solidFill>
-                  <a:srgbClr val="14161B"/>
-                </a:solidFill>
-                <a:latin typeface="Trade Gothic Next" pitchFamily="34" charset="0"/>
-                <a:ea typeface="Trade Gothic Next" pitchFamily="34" charset="-122"/>
-                <a:cs typeface="Trade Gothic Next" pitchFamily="34" charset="-120"/>
-              </a:rPr>
-              <a:t> J</a:t>
+              <a:t>C: n = 2 to n = 1</a:t>
             </a:r>
             <a:endParaRPr lang="en-US" sz="1600" dirty="0"/>
           </a:p>
@@ -16306,7 +16223,7 @@
                 <a:ea typeface="Trade Gothic Next" pitchFamily="34" charset="-122"/>
                 <a:cs typeface="Trade Gothic Next" pitchFamily="34" charset="-120"/>
               </a:rPr>
-              <a:t>ΔE</a:t>
+              <a:t>Order, least to most</a:t>
             </a:r>
             <a:endParaRPr lang="en-US" sz="1600" dirty="0"/>
           </a:p>
@@ -16323,7 +16240,7 @@
                 <a:ea typeface="Trade Gothic Next" pitchFamily="34" charset="-122"/>
                 <a:cs typeface="Trade Gothic Next" pitchFamily="34" charset="-120"/>
               </a:rPr>
-              <a:t>Absorbed or released?</a:t>
+              <a:t>The bluest light</a:t>
             </a:r>
             <a:endParaRPr lang="en-US" sz="1600" dirty="0"/>
           </a:p>
@@ -16394,7 +16311,7 @@
                 <a:ea typeface="Trade Gothic Next" pitchFamily="34" charset="-122"/>
                 <a:cs typeface="Trade Gothic Next" pitchFamily="34" charset="-120"/>
               </a:rPr>
-              <a:t>ΔE = final energy minus initial energy. A negative ΔE means energy leaves the atom.</a:t>
+              <a:t>A bigger vertical drop on the diagram means more energy released.</a:t>
             </a:r>
             <a:endParaRPr lang="en-US" sz="1600" dirty="0"/>
           </a:p>
@@ -16539,7 +16456,7 @@
       </p:grpSpPr>
       <p:pic>
         <p:nvPicPr>
-          <p:cNvPr id="2" name="Image 0" descr="/home/user/WorkWork/templates/slide/assets/chem_u02_s2.1_transition_3_to_2.png">    </p:cNvPr>
+          <p:cNvPr id="2" name="Image 0" descr="/home/user/WorkWork/templates/slide/assets/chem_u02_s2.1_drops_ranked.png">    </p:cNvPr>
           <p:cNvPicPr>
             <a:picLocks noChangeAspect="1"/>
           </p:cNvPicPr>
@@ -16596,7 +16513,7 @@
                 <a:ea typeface="Trade Gothic Next" pitchFamily="34" charset="-122"/>
                 <a:cs typeface="Trade Gothic Next" pitchFamily="34" charset="-120"/>
               </a:rPr>
-              <a:t>n = 3 to n = 2, Worked</a:t>
+              <a:t>Ranking Three Drops, Worked</a:t>
             </a:r>
             <a:endParaRPr lang="en-US" sz="2800" dirty="0"/>
           </a:p>
@@ -16637,7 +16554,7 @@
                 <a:ea typeface="Trade Gothic Next" pitchFamily="34" charset="-122"/>
                 <a:cs typeface="Trade Gothic Next" pitchFamily="34" charset="-120"/>
               </a:rPr>
-              <a:t>Final minus initial. Keep the negative signs.</a:t>
+              <a:t>Longer arrow, more energy, bluer light.</a:t>
             </a:r>
             <a:endParaRPr lang="en-US" sz="1700" dirty="0"/>
           </a:p>
@@ -16678,7 +16595,7 @@
                 <a:ea typeface="Trade Gothic Next" pitchFamily="34" charset="-122"/>
                 <a:cs typeface="Trade Gothic Next" pitchFamily="34" charset="-120"/>
               </a:rPr>
-              <a:t>SETUP</a:t>
+              <a:t>RULES</a:t>
             </a:r>
             <a:endParaRPr lang="en-US" sz="1200" dirty="0"/>
           </a:p>
@@ -16719,7 +16636,7 @@
                 <a:ea typeface="Trade Gothic Next" pitchFamily="34" charset="-122"/>
                 <a:cs typeface="Trade Gothic Next" pitchFamily="34" charset="-120"/>
               </a:rPr>
-              <a:t>ΔE = E₂ − E₃</a:t>
+              <a:t>Bigger drop,</a:t>
             </a:r>
             <a:endParaRPr lang="en-US" sz="1600" dirty="0"/>
           </a:p>
@@ -16736,7 +16653,7 @@
                 <a:ea typeface="Trade Gothic Next" pitchFamily="34" charset="-122"/>
                 <a:cs typeface="Trade Gothic Next" pitchFamily="34" charset="-120"/>
               </a:rPr>
-              <a:t>Final level: n = 2</a:t>
+              <a:t>more energy released.</a:t>
             </a:r>
             <a:endParaRPr lang="en-US" sz="1600" dirty="0"/>
           </a:p>
@@ -16753,7 +16670,7 @@
                 <a:ea typeface="Trade Gothic Next" pitchFamily="34" charset="-122"/>
                 <a:cs typeface="Trade Gothic Next" pitchFamily="34" charset="-120"/>
               </a:rPr>
-              <a:t>Initial level: n = 3</a:t>
+              <a:t>More energy, bluer light.</a:t>
             </a:r>
             <a:endParaRPr lang="en-US" sz="1600" dirty="0"/>
           </a:p>
@@ -16794,13 +16711,16 @@
                 <a:ea typeface="Trade Gothic Next" pitchFamily="34" charset="-122"/>
                 <a:cs typeface="Trade Gothic Next" pitchFamily="34" charset="-120"/>
               </a:rPr>
-              <a:t>−5.45 × 10</a:t>
-            </a:r>
-            <a:pPr indent="0" marL="0">
-              <a:buNone/>
-            </a:pPr>
-            <a:r>
-              <a:rPr lang="en-US" sz="1900" baseline="30000" dirty="0">
+              <a:t>Least: B (3 to 2)</a:t>
+            </a:r>
+            <a:endParaRPr lang="en-US" sz="1900" dirty="0"/>
+          </a:p>
+          <a:p>
+            <a:pPr indent="0" marL="0">
+              <a:buNone/>
+            </a:pPr>
+            <a:r>
+              <a:rPr lang="en-US" sz="1900" dirty="0">
                 <a:solidFill>
                   <a:srgbClr val="14161B"/>
                 </a:solidFill>
@@ -16808,7 +16728,7 @@
                 <a:ea typeface="Trade Gothic Next" pitchFamily="34" charset="-122"/>
                 <a:cs typeface="Trade Gothic Next" pitchFamily="34" charset="-120"/>
               </a:rPr>
-              <a:t>−19</a:t>
+              <a:t>Then: A (4 to 2)</a:t>
             </a:r>
             <a:endParaRPr lang="en-US" sz="1900" dirty="0"/>
           </a:p>
@@ -16825,13 +16745,16 @@
                 <a:ea typeface="Trade Gothic Next" pitchFamily="34" charset="-122"/>
                 <a:cs typeface="Trade Gothic Next" pitchFamily="34" charset="-120"/>
               </a:rPr>
-              <a:t>− (−2.42 × 10</a:t>
-            </a:r>
-            <a:pPr indent="0" marL="0">
-              <a:buNone/>
-            </a:pPr>
-            <a:r>
-              <a:rPr lang="en-US" sz="1900" baseline="30000" dirty="0">
+              <a:t>Most: C (2 to 1)</a:t>
+            </a:r>
+            <a:endParaRPr lang="en-US" sz="1900" dirty="0"/>
+          </a:p>
+          <a:p>
+            <a:pPr indent="0" marL="0">
+              <a:buNone/>
+            </a:pPr>
+            <a:r>
+              <a:rPr lang="en-US" sz="1900" dirty="0">
                 <a:solidFill>
                   <a:srgbClr val="14161B"/>
                 </a:solidFill>
@@ -16839,83 +16762,7 @@
                 <a:ea typeface="Trade Gothic Next" pitchFamily="34" charset="-122"/>
                 <a:cs typeface="Trade Gothic Next" pitchFamily="34" charset="-120"/>
               </a:rPr>
-              <a:t>−19</a:t>
-            </a:r>
-            <a:pPr indent="0" marL="0">
-              <a:buNone/>
-            </a:pPr>
-            <a:r>
-              <a:rPr lang="en-US" sz="1900" dirty="0">
-                <a:solidFill>
-                  <a:srgbClr val="14161B"/>
-                </a:solidFill>
-                <a:latin typeface="Trade Gothic Next" pitchFamily="34" charset="0"/>
-                <a:ea typeface="Trade Gothic Next" pitchFamily="34" charset="-122"/>
-                <a:cs typeface="Trade Gothic Next" pitchFamily="34" charset="-120"/>
-              </a:rPr>
-              <a:t>)</a:t>
-            </a:r>
-            <a:endParaRPr lang="en-US" sz="1900" dirty="0"/>
-          </a:p>
-          <a:p>
-            <a:pPr indent="0" marL="0">
-              <a:buNone/>
-            </a:pPr>
-            <a:r>
-              <a:rPr lang="en-US" sz="1900" dirty="0">
-                <a:solidFill>
-                  <a:srgbClr val="14161B"/>
-                </a:solidFill>
-                <a:latin typeface="Trade Gothic Next" pitchFamily="34" charset="0"/>
-                <a:ea typeface="Trade Gothic Next" pitchFamily="34" charset="-122"/>
-                <a:cs typeface="Trade Gothic Next" pitchFamily="34" charset="-120"/>
-              </a:rPr>
-              <a:t>= −3.03 × 10</a:t>
-            </a:r>
-            <a:pPr indent="0" marL="0">
-              <a:buNone/>
-            </a:pPr>
-            <a:r>
-              <a:rPr lang="en-US" sz="1900" baseline="30000" dirty="0">
-                <a:solidFill>
-                  <a:srgbClr val="14161B"/>
-                </a:solidFill>
-                <a:latin typeface="Trade Gothic Next" pitchFamily="34" charset="0"/>
-                <a:ea typeface="Trade Gothic Next" pitchFamily="34" charset="-122"/>
-                <a:cs typeface="Trade Gothic Next" pitchFamily="34" charset="-120"/>
-              </a:rPr>
-              <a:t>−19</a:t>
-            </a:r>
-            <a:pPr indent="0" marL="0">
-              <a:buNone/>
-            </a:pPr>
-            <a:r>
-              <a:rPr lang="en-US" sz="1900" dirty="0">
-                <a:solidFill>
-                  <a:srgbClr val="14161B"/>
-                </a:solidFill>
-                <a:latin typeface="Trade Gothic Next" pitchFamily="34" charset="0"/>
-                <a:ea typeface="Trade Gothic Next" pitchFamily="34" charset="-122"/>
-                <a:cs typeface="Trade Gothic Next" pitchFamily="34" charset="-120"/>
-              </a:rPr>
-              <a:t> J</a:t>
-            </a:r>
-            <a:endParaRPr lang="en-US" sz="1900" dirty="0"/>
-          </a:p>
-          <a:p>
-            <a:pPr indent="0" marL="0">
-              <a:buNone/>
-            </a:pPr>
-            <a:r>
-              <a:rPr lang="en-US" sz="1900" dirty="0">
-                <a:solidFill>
-                  <a:srgbClr val="14161B"/>
-                </a:solidFill>
-                <a:latin typeface="Trade Gothic Next" pitchFamily="34" charset="0"/>
-                <a:ea typeface="Trade Gothic Next" pitchFamily="34" charset="-122"/>
-                <a:cs typeface="Trade Gothic Next" pitchFamily="34" charset="-120"/>
-              </a:rPr>
-              <a:t>Released.</a:t>
+              <a:t>Bluest: C (ultraviolet)</a:t>
             </a:r>
             <a:endParaRPr lang="en-US" sz="1900" dirty="0"/>
           </a:p>
@@ -16956,35 +16803,7 @@
                 <a:ea typeface="Trade Gothic Next" pitchFamily="34" charset="-122"/>
                 <a:cs typeface="Trade Gothic Next" pitchFamily="34" charset="-120"/>
               </a:rPr>
-              <a:t>Energy released: a photon of 3.03 × 10</a:t>
-            </a:r>
-            <a:pPr indent="0" marL="0">
-              <a:buNone/>
-            </a:pPr>
-            <a:r>
-              <a:rPr lang="en-US" sz="1600" b="1" baseline="30000" dirty="0">
-                <a:solidFill>
-                  <a:srgbClr val="EDF0E5"/>
-                </a:solidFill>
-                <a:latin typeface="Trade Gothic Next" pitchFamily="34" charset="0"/>
-                <a:ea typeface="Trade Gothic Next" pitchFamily="34" charset="-122"/>
-                <a:cs typeface="Trade Gothic Next" pitchFamily="34" charset="-120"/>
-              </a:rPr>
-              <a:t>−19</a:t>
-            </a:r>
-            <a:pPr indent="0" marL="0">
-              <a:buNone/>
-            </a:pPr>
-            <a:r>
-              <a:rPr lang="en-US" sz="1600" b="1" dirty="0">
-                <a:solidFill>
-                  <a:srgbClr val="EDF0E5"/>
-                </a:solidFill>
-                <a:latin typeface="Trade Gothic Next" pitchFamily="34" charset="0"/>
-                <a:ea typeface="Trade Gothic Next" pitchFamily="34" charset="-122"/>
-                <a:cs typeface="Trade Gothic Next" pitchFamily="34" charset="-120"/>
-              </a:rPr>
-              <a:t> J leaves the atom.</a:t>
+              <a:t>More energy released means a shorter wavelength, which is bluer light.</a:t>
             </a:r>
             <a:endParaRPr lang="en-US" sz="1600" dirty="0"/>
           </a:p>
@@ -17203,7 +17022,7 @@
                 <a:ea typeface="Trade Gothic Next" pitchFamily="34" charset="-122"/>
                 <a:cs typeface="Trade Gothic Next" pitchFamily="34" charset="-120"/>
               </a:rPr>
-              <a:t>Ionization means n goes all the way to infinity.</a:t>
+              <a:t>Ionization means the electron leaves the atom.</a:t>
             </a:r>
             <a:endParaRPr lang="en-US" sz="1700" dirty="0"/>
           </a:p>
@@ -17244,7 +17063,7 @@
                 <a:ea typeface="Trade Gothic Next" pitchFamily="34" charset="-122"/>
                 <a:cs typeface="Trade Gothic Next" pitchFamily="34" charset="-120"/>
               </a:rPr>
-              <a:t>How much energy removes the electron from a hydrogen atom in its ground state?</a:t>
+              <a:t>Hydrogen's electron absorbs enough energy to escape. Which level does it reach? What is the atom afterward?</a:t>
             </a:r>
             <a:endParaRPr lang="en-US" sz="1600" dirty="0"/>
           </a:p>
@@ -17343,24 +17162,7 @@
                 <a:ea typeface="Trade Gothic Next" pitchFamily="34" charset="-122"/>
                 <a:cs typeface="Trade Gothic Next" pitchFamily="34" charset="-120"/>
               </a:rPr>
-              <a:t>n = 1 to n = ∞</a:t>
-            </a:r>
-            <a:endParaRPr lang="en-US" sz="1600" dirty="0"/>
-          </a:p>
-          <a:p>
-            <a:pPr indent="0" marL="0">
-              <a:buNone/>
-            </a:pPr>
-            <a:r>
-              <a:rPr lang="en-US" sz="1600" dirty="0">
-                <a:solidFill>
-                  <a:srgbClr val="14161B"/>
-                </a:solidFill>
-                <a:latin typeface="Trade Gothic Next" pitchFamily="34" charset="0"/>
-                <a:ea typeface="Trade Gothic Next" pitchFamily="34" charset="-122"/>
-                <a:cs typeface="Trade Gothic Next" pitchFamily="34" charset="-120"/>
-              </a:rPr>
-              <a:t>E at n = ∞ is 0</a:t>
+              <a:t>Electron starts in n = 1</a:t>
             </a:r>
             <a:endParaRPr lang="en-US" sz="1600" dirty="0"/>
           </a:p>
@@ -17442,7 +17244,7 @@
                 <a:ea typeface="Trade Gothic Next" pitchFamily="34" charset="-122"/>
                 <a:cs typeface="Trade Gothic Next" pitchFamily="34" charset="-120"/>
               </a:rPr>
-              <a:t>ΔE</a:t>
+              <a:t>The level it reaches</a:t>
             </a:r>
             <a:endParaRPr lang="en-US" sz="1600" dirty="0"/>
           </a:p>
@@ -17459,7 +17261,7 @@
                 <a:ea typeface="Trade Gothic Next" pitchFamily="34" charset="-122"/>
                 <a:cs typeface="Trade Gothic Next" pitchFamily="34" charset="-120"/>
               </a:rPr>
-              <a:t>Absorbed or released?</a:t>
+              <a:t>What the atom becomes</a:t>
             </a:r>
             <a:endParaRPr lang="en-US" sz="1600" dirty="0"/>
           </a:p>
@@ -17530,7 +17332,7 @@
                 <a:ea typeface="Trade Gothic Next" pitchFamily="34" charset="-122"/>
                 <a:cs typeface="Trade Gothic Next" pitchFamily="34" charset="-120"/>
               </a:rPr>
-              <a:t>Ionization: the electron goes from its level to n = ∞, where E = 0.</a:t>
+              <a:t>Ionization: the electron leaves the atom, which becomes a positive ion.</a:t>
             </a:r>
             <a:endParaRPr lang="en-US" sz="1600" dirty="0"/>
           </a:p>
@@ -17773,7 +17575,7 @@
                 <a:ea typeface="Trade Gothic Next" pitchFamily="34" charset="-122"/>
                 <a:cs typeface="Trade Gothic Next" pitchFamily="34" charset="-120"/>
               </a:rPr>
-              <a:t>Final minus initial again. The sign tells you the direction.</a:t>
+              <a:t>The electron climbs to the top of the diagram and leaves.</a:t>
             </a:r>
             <a:endParaRPr lang="en-US" sz="1700" dirty="0"/>
           </a:p>
@@ -17814,7 +17616,7 @@
                 <a:ea typeface="Trade Gothic Next" pitchFamily="34" charset="-122"/>
                 <a:cs typeface="Trade Gothic Next" pitchFamily="34" charset="-120"/>
               </a:rPr>
-              <a:t>SETUP</a:t>
+              <a:t>IDEAS</a:t>
             </a:r>
             <a:endParaRPr lang="en-US" sz="1200" dirty="0"/>
           </a:p>
@@ -17855,7 +17657,7 @@
                 <a:ea typeface="Trade Gothic Next" pitchFamily="34" charset="-122"/>
                 <a:cs typeface="Trade Gothic Next" pitchFamily="34" charset="-120"/>
               </a:rPr>
-              <a:t>ΔE = final − initial</a:t>
+              <a:t>Energy in lifts the electron.</a:t>
             </a:r>
             <a:endParaRPr lang="en-US" sz="1600" dirty="0"/>
           </a:p>
@@ -17872,7 +17674,7 @@
                 <a:ea typeface="Trade Gothic Next" pitchFamily="34" charset="-122"/>
                 <a:cs typeface="Trade Gothic Next" pitchFamily="34" charset="-120"/>
               </a:rPr>
-              <a:t>Final (n = ∞): 0</a:t>
+              <a:t>No level is above n = ∞.</a:t>
             </a:r>
             <a:endParaRPr lang="en-US" sz="1600" dirty="0"/>
           </a:p>
@@ -17889,7 +17691,7 @@
                 <a:ea typeface="Trade Gothic Next" pitchFamily="34" charset="-122"/>
                 <a:cs typeface="Trade Gothic Next" pitchFamily="34" charset="-120"/>
               </a:rPr>
-              <a:t>Initial (n = 1): E₁</a:t>
+              <a:t>Outermost electron leaves first.</a:t>
             </a:r>
             <a:endParaRPr lang="en-US" sz="1600" dirty="0"/>
           </a:p>
@@ -17930,13 +17732,16 @@
                 <a:ea typeface="Trade Gothic Next" pitchFamily="34" charset="-122"/>
                 <a:cs typeface="Trade Gothic Next" pitchFamily="34" charset="-120"/>
               </a:rPr>
-              <a:t>E₁ = −2.18 × 10</a:t>
-            </a:r>
-            <a:pPr indent="0" marL="0">
-              <a:buNone/>
-            </a:pPr>
-            <a:r>
-              <a:rPr lang="en-US" sz="1900" baseline="30000" dirty="0">
+              <a:t>Start: n = 1</a:t>
+            </a:r>
+            <a:endParaRPr lang="en-US" sz="1900" dirty="0"/>
+          </a:p>
+          <a:p>
+            <a:pPr indent="0" marL="0">
+              <a:buNone/>
+            </a:pPr>
+            <a:r>
+              <a:rPr lang="en-US" sz="1900" dirty="0">
                 <a:solidFill>
                   <a:srgbClr val="14161B"/>
                 </a:solidFill>
@@ -17944,8 +17749,11 @@
                 <a:ea typeface="Trade Gothic Next" pitchFamily="34" charset="-122"/>
                 <a:cs typeface="Trade Gothic Next" pitchFamily="34" charset="-120"/>
               </a:rPr>
-              <a:t>−18</a:t>
-            </a:r>
+              <a:t>Energy in: it goes up</a:t>
+            </a:r>
+            <a:endParaRPr lang="en-US" sz="1900" dirty="0"/>
+          </a:p>
+          <a:p>
             <a:pPr indent="0" marL="0">
               <a:buNone/>
             </a:pPr>
@@ -17958,7 +17766,7 @@
                 <a:ea typeface="Trade Gothic Next" pitchFamily="34" charset="-122"/>
                 <a:cs typeface="Trade Gothic Next" pitchFamily="34" charset="-120"/>
               </a:rPr>
-              <a:t> J</a:t>
+              <a:t>End: n = ∞, it leaves</a:t>
             </a:r>
             <a:endParaRPr lang="en-US" sz="1900" dirty="0"/>
           </a:p>
@@ -17975,69 +17783,7 @@
                 <a:ea typeface="Trade Gothic Next" pitchFamily="34" charset="-122"/>
                 <a:cs typeface="Trade Gothic Next" pitchFamily="34" charset="-120"/>
               </a:rPr>
-              <a:t>ΔE = 0 − E₁</a:t>
-            </a:r>
-            <a:endParaRPr lang="en-US" sz="1900" dirty="0"/>
-          </a:p>
-          <a:p>
-            <a:pPr indent="0" marL="0">
-              <a:buNone/>
-            </a:pPr>
-            <a:r>
-              <a:rPr lang="en-US" sz="1900" dirty="0">
-                <a:solidFill>
-                  <a:srgbClr val="14161B"/>
-                </a:solidFill>
-                <a:latin typeface="Trade Gothic Next" pitchFamily="34" charset="0"/>
-                <a:ea typeface="Trade Gothic Next" pitchFamily="34" charset="-122"/>
-                <a:cs typeface="Trade Gothic Next" pitchFamily="34" charset="-120"/>
-              </a:rPr>
-              <a:t>= +2.18 × 10</a:t>
-            </a:r>
-            <a:pPr indent="0" marL="0">
-              <a:buNone/>
-            </a:pPr>
-            <a:r>
-              <a:rPr lang="en-US" sz="1900" baseline="30000" dirty="0">
-                <a:solidFill>
-                  <a:srgbClr val="14161B"/>
-                </a:solidFill>
-                <a:latin typeface="Trade Gothic Next" pitchFamily="34" charset="0"/>
-                <a:ea typeface="Trade Gothic Next" pitchFamily="34" charset="-122"/>
-                <a:cs typeface="Trade Gothic Next" pitchFamily="34" charset="-120"/>
-              </a:rPr>
-              <a:t>−18</a:t>
-            </a:r>
-            <a:pPr indent="0" marL="0">
-              <a:buNone/>
-            </a:pPr>
-            <a:r>
-              <a:rPr lang="en-US" sz="1900" dirty="0">
-                <a:solidFill>
-                  <a:srgbClr val="14161B"/>
-                </a:solidFill>
-                <a:latin typeface="Trade Gothic Next" pitchFamily="34" charset="0"/>
-                <a:ea typeface="Trade Gothic Next" pitchFamily="34" charset="-122"/>
-                <a:cs typeface="Trade Gothic Next" pitchFamily="34" charset="-120"/>
-              </a:rPr>
-              <a:t> J</a:t>
-            </a:r>
-            <a:endParaRPr lang="en-US" sz="1900" dirty="0"/>
-          </a:p>
-          <a:p>
-            <a:pPr indent="0" marL="0">
-              <a:buNone/>
-            </a:pPr>
-            <a:r>
-              <a:rPr lang="en-US" sz="1900" dirty="0">
-                <a:solidFill>
-                  <a:srgbClr val="14161B"/>
-                </a:solidFill>
-                <a:latin typeface="Trade Gothic Next" pitchFamily="34" charset="0"/>
-                <a:ea typeface="Trade Gothic Next" pitchFamily="34" charset="-122"/>
-                <a:cs typeface="Trade Gothic Next" pitchFamily="34" charset="-120"/>
-              </a:rPr>
-              <a:t>Absorbed.</a:t>
+              <a:t>Atom: a positive ion</a:t>
             </a:r>
             <a:endParaRPr lang="en-US" sz="1900" dirty="0"/>
           </a:p>
@@ -18078,35 +17824,7 @@
                 <a:ea typeface="Trade Gothic Next" pitchFamily="34" charset="-122"/>
                 <a:cs typeface="Trade Gothic Next" pitchFamily="34" charset="-120"/>
               </a:rPr>
-              <a:t>A positive ΔE means energy absorbed. Ionizing hydrogen takes 2.18 × 10</a:t>
-            </a:r>
-            <a:pPr indent="0" marL="0">
-              <a:buNone/>
-            </a:pPr>
-            <a:r>
-              <a:rPr lang="en-US" sz="1600" b="1" baseline="30000" dirty="0">
-                <a:solidFill>
-                  <a:srgbClr val="EDF0E5"/>
-                </a:solidFill>
-                <a:latin typeface="Trade Gothic Next" pitchFamily="34" charset="0"/>
-                <a:ea typeface="Trade Gothic Next" pitchFamily="34" charset="-122"/>
-                <a:cs typeface="Trade Gothic Next" pitchFamily="34" charset="-120"/>
-              </a:rPr>
-              <a:t>−18</a:t>
-            </a:r>
-            <a:pPr indent="0" marL="0">
-              <a:buNone/>
-            </a:pPr>
-            <a:r>
-              <a:rPr lang="en-US" sz="1600" b="1" dirty="0">
-                <a:solidFill>
-                  <a:srgbClr val="EDF0E5"/>
-                </a:solidFill>
-                <a:latin typeface="Trade Gothic Next" pitchFamily="34" charset="0"/>
-                <a:ea typeface="Trade Gothic Next" pitchFamily="34" charset="-122"/>
-                <a:cs typeface="Trade Gothic Next" pitchFamily="34" charset="-120"/>
-              </a:rPr>
-              <a:t> J.</a:t>
+              <a:t>Ionization takes energy in. Hydrogen ends as a positive ion with no electron.</a:t>
             </a:r>
             <a:endParaRPr lang="en-US" sz="1600" dirty="0"/>
           </a:p>
@@ -19272,7 +18990,7 @@
                 <a:ea typeface="Trade Gothic Next" pitchFamily="34" charset="-122"/>
                 <a:cs typeface="Trade Gothic Next" pitchFamily="34" charset="-120"/>
               </a:rPr>
-              <a:t>Calculate the energy of the hydrogen electron at n = 2.</a:t>
+              <a:t>A hydrogen electron drops from n = 2 to n = 1. Is a photon absorbed or emitted? Does the atom gain or lose energy?</a:t>
             </a:r>
             <a:endParaRPr lang="en-US" sz="1600" dirty="0"/>
           </a:p>
@@ -19354,7 +19072,7 @@
                 <a:ea typeface="Trade Gothic Next" pitchFamily="34" charset="-122"/>
                 <a:cs typeface="Trade Gothic Next" pitchFamily="34" charset="-120"/>
               </a:rPr>
-              <a:t>A hydrogen electron drops from n = 4 to n = 2. Is energy absorbed or released? How much?</a:t>
+              <a:t>A photon has too little energy to lift an electron from n = 1 to n = 2. What happens to the photon?</a:t>
             </a:r>
             <a:endParaRPr lang="en-US" sz="1600" dirty="0"/>
           </a:p>
@@ -19395,7 +19113,7 @@
                 <a:ea typeface="Trade Gothic Next" pitchFamily="34" charset="-122"/>
                 <a:cs typeface="Trade Gothic Next" pitchFamily="34" charset="-120"/>
               </a:rPr>
-              <a:t>For every calculation, write the equation first, then the numbers, then the units.</a:t>
+              <a:t>Answer in full sentences. Name the levels and say up or down.</a:t>
             </a:r>
             <a:endParaRPr lang="en-US" sz="1600" dirty="0"/>
           </a:p>
@@ -19696,7 +19414,7 @@
                 <a:ea typeface="Trade Gothic Next" pitchFamily="34" charset="-122"/>
                 <a:cs typeface="Trade Gothic Next" pitchFamily="34" charset="-120"/>
               </a:rPr>
-              <a:t>Which drop releases more energy, n = 3 to n = 2 or n = 2 to n = 1? Find both ΔE values.</a:t>
+              <a:t>Which drop releases more energy, n = 3 to n = 2 or n = 2 to n = 1? How do you know?</a:t>
             </a:r>
             <a:endParaRPr lang="en-US" sz="1600" dirty="0"/>
           </a:p>
@@ -19819,7 +19537,7 @@
                 <a:ea typeface="Trade Gothic Next" pitchFamily="34" charset="-122"/>
                 <a:cs typeface="Trade Gothic Next" pitchFamily="34" charset="-120"/>
               </a:rPr>
-              <a:t>ΔE = final energy minus initial energy.</a:t>
+              <a:t>Down releases energy as a photon. Up absorbs energy.</a:t>
             </a:r>
             <a:endParaRPr lang="en-US" sz="1600" dirty="0"/>
           </a:p>
@@ -22715,7 +22433,7 @@
       </p:grpSpPr>
       <p:pic>
         <p:nvPicPr>
-          <p:cNvPr id="2" name="Image 0" descr="/home/user/WorkWork/templates/slide/assets/chem_u02_s2.1_energy_equation.png">    </p:cNvPr>
+          <p:cNvPr id="2" name="Image 0" descr="/home/user/WorkWork/templates/slide/assets/chem_u02_s2.1_level_numbers.png">    </p:cNvPr>
           <p:cNvPicPr>
             <a:picLocks noChangeAspect="1"/>
           </p:cNvPicPr>
@@ -22772,7 +22490,7 @@
                 <a:ea typeface="Trade Gothic Next" pitchFamily="34" charset="-122"/>
                 <a:cs typeface="Trade Gothic Next" pitchFamily="34" charset="-120"/>
               </a:rPr>
-              <a:t>The Energy of Each Level</a:t>
+              <a:t>Levels Get Whole-Number Labels</a:t>
             </a:r>
             <a:endParaRPr lang="en-US" sz="2800" dirty="0"/>
           </a:p>
@@ -22813,7 +22531,7 @@
                 <a:ea typeface="Trade Gothic Next" pitchFamily="34" charset="-122"/>
                 <a:cs typeface="Trade Gothic Next" pitchFamily="34" charset="-120"/>
               </a:rPr>
-              <a:t>Put in n and you get that level's energy, in joules.</a:t>
+              <a:t>Each level gets a number, n. A higher n means more energy.</a:t>
             </a:r>
             <a:endParaRPr lang="en-US" sz="1700" dirty="0"/>
           </a:p>
@@ -22936,7 +22654,7 @@
                 <a:ea typeface="Trade Gothic Next" pitchFamily="34" charset="-122"/>
                 <a:cs typeface="Trade Gothic Next" pitchFamily="34" charset="-120"/>
               </a:rPr>
-              <a:t>THE NEGATIVE SIGN</a:t>
+              <a:t>HIGHER n</a:t>
             </a:r>
             <a:endParaRPr lang="en-US" sz="1200" dirty="0"/>
           </a:p>
@@ -22977,7 +22695,7 @@
                 <a:ea typeface="Trade Gothic Next" pitchFamily="34" charset="-122"/>
                 <a:cs typeface="Trade Gothic Next" pitchFamily="34" charset="-120"/>
               </a:rPr>
-              <a:t>The electron is bound to the nucleus. E = 0 is a free electron.</a:t>
+              <a:t>n = 1 is the lowest level. Each step up means more energy.</a:t>
             </a:r>
             <a:endParaRPr lang="en-US" sz="1600" dirty="0"/>
           </a:p>
@@ -23059,7 +22777,7 @@
                 <a:ea typeface="Trade Gothic Next" pitchFamily="34" charset="-122"/>
                 <a:cs typeface="Trade Gothic Next" pitchFamily="34" charset="-120"/>
               </a:rPr>
-              <a:t>This formula fails for atoms with 2 or more electrons.</a:t>
+              <a:t>This picture works for hydrogen. It fails for atoms with 2 or more electrons.</a:t>
             </a:r>
             <a:endParaRPr lang="en-US" sz="1600" dirty="0"/>
           </a:p>
@@ -23302,7 +23020,7 @@
                 <a:ea typeface="Trade Gothic Next" pitchFamily="34" charset="-122"/>
                 <a:cs typeface="Trade Gothic Next" pitchFamily="34" charset="-120"/>
               </a:rPr>
-              <a:t>Drawn to scale. Watch what happens to the spacing.</a:t>
+              <a:t>Drawn to scale in spacing. Watch what happens to the gaps.</a:t>
             </a:r>
             <a:endParaRPr lang="en-US" sz="1700" dirty="0"/>
           </a:p>
@@ -23384,7 +23102,7 @@
                 <a:ea typeface="Trade Gothic Next" pitchFamily="34" charset="-122"/>
                 <a:cs typeface="Trade Gothic Next" pitchFamily="34" charset="-120"/>
               </a:rPr>
-              <a:t>More negative means lower. n = 1 is the lowest.</a:t>
+              <a:t>n = 1 is the lowest level, at the bottom.</a:t>
             </a:r>
             <a:endParaRPr lang="en-US" sz="1600" dirty="0"/>
           </a:p>
@@ -23425,7 +23143,7 @@
                 <a:ea typeface="Trade Gothic Next" pitchFamily="34" charset="-122"/>
                 <a:cs typeface="Trade Gothic Next" pitchFamily="34" charset="-120"/>
               </a:rPr>
-              <a:t>THE SPACING SHRINKS</a:t>
+              <a:t>THE GAPS SHRINK</a:t>
             </a:r>
             <a:endParaRPr lang="en-US" sz="1200" dirty="0"/>
           </a:p>
@@ -23507,7 +23225,7 @@
                 <a:ea typeface="Trade Gothic Next" pitchFamily="34" charset="-122"/>
                 <a:cs typeface="Trade Gothic Next" pitchFamily="34" charset="-120"/>
               </a:rPr>
-              <a:t>ZERO</a:t>
+              <a:t>THE TOP</a:t>
             </a:r>
             <a:endParaRPr lang="en-US" sz="1200" dirty="0"/>
           </a:p>
@@ -23548,7 +23266,7 @@
                 <a:ea typeface="Trade Gothic Next" pitchFamily="34" charset="-122"/>
                 <a:cs typeface="Trade Gothic Next" pitchFamily="34" charset="-120"/>
               </a:rPr>
-              <a:t>n = ∞ is E = 0. The electron has left the atom.</a:t>
+              <a:t>n = ∞ is the top. The electron has left the atom.</a:t>
             </a:r>
             <a:endParaRPr lang="en-US" sz="1600" dirty="0"/>
           </a:p>

</xml_diff>

<commit_message>
WIP: S2.5 wording fixes; S2.1 and S2.3 final fixes in progress
Co-Authored-By: Claude Sonnet 5.5 <noreply@anthropic.com>
Claude-Session: https://claude.ai/code/session_01CAqidLLu6PiYNMcZx5qMsE
</commit_message>
<xml_diff>
--- a/deliverables/chem-u02/SHULL_CHEM_Slides_U02_S02.1.pptx
+++ b/deliverables/chem-u02/SHULL_CHEM_Slides_U02_S02.1.pptx
@@ -1051,7 +1051,7 @@
           <a:p>
             <a:r>
               <a:rPr lang="en-US" dirty="0"/>
-              <a:t>Worked together. Leave the energy-levels slide (slide 9) up or flip back to it: the ranking uses the vertical gaps on that diagram, no formula. Answer: B (3 to 2) least, then A (4 to 2), then C (2 to 1) most. The bluest light comes from C, the most energy: more energy means a shorter wavelength, which is bluer. Accuracy note: C is really ultraviolet, beyond violet, so 'bluest' means furthest toward the blue-violet end; B is red and A is blue-green. S2.5 gives the wavelengths in nm. Image prompt (empty slot): a camera-flash bulb mid-discharge in a dark room.</a:t>
+              <a:t>Worked together. Leave the energy-levels slide (slide 9) up or flip back to it: the ranking uses the vertical gaps on that diagram, no formula. Answer: B (3 to 2) least, then A (4 to 2), then C (2 to 1) most. The highest-energy light comes from C. Save the colour idea for the solution slide: more energy means a shorter wavelength, which is bluer, and C is really ultraviolet, beyond violet; B is red and A is blue-green. S2.5 gives the wavelengths in nm. Image prompt (empty slot): a camera-flash bulb mid-discharge in a dark room.</a:t>
             </a:r>
             <a:endParaRPr lang="en-US" dirty="0"/>
           </a:p>
@@ -1139,7 +1139,7 @@
           <a:p>
             <a:r>
               <a:rPr lang="en-US" dirty="0"/>
-              <a:t>Read the arrows: C is longest, then A, then B. The figure is to scale in spacing, so arrow length is the ranking. Bluer means shorter wavelength and higher energy, stated qualitatively; no wavelengths here (S2.5). C is ultraviolet in fact: say so if a student asks.</a:t>
+              <a:t>Read the arrows: C is longest, then A, then B. The figure is to scale in spacing, so arrow length is the ranking. Bluer means shorter wavelength and higher energy, stated qualitatively; no wavelengths here (S2.5). Highest-energy light is C, and C is ultraviolet in fact: say so if a student asks.</a:t>
             </a:r>
             <a:endParaRPr lang="en-US" dirty="0"/>
           </a:p>
@@ -15984,7 +15984,7 @@
                 <a:ea typeface="Trade Gothic Next" pitchFamily="34" charset="-122"/>
                 <a:cs typeface="Trade Gothic Next" pitchFamily="34" charset="-120"/>
               </a:rPr>
-              <a:t>Use the to-scale level diagram. A longer drop is a bigger drop.</a:t>
+              <a:t>Look back at the level diagram on slide 9. A longer drop is a bigger drop.</a:t>
             </a:r>
             <a:endParaRPr lang="en-US" sz="1700" dirty="0"/>
           </a:p>
@@ -16025,7 +16025,7 @@
                 <a:ea typeface="Trade Gothic Next" pitchFamily="34" charset="-122"/>
                 <a:cs typeface="Trade Gothic Next" pitchFamily="34" charset="-120"/>
               </a:rPr>
-              <a:t>Rank drops A, B and C from least to most energy released. Which gives the bluest light?</a:t>
+              <a:t>Rank drops A, B and C from least to most energy released. Which gives the highest-energy light?</a:t>
             </a:r>
             <a:endParaRPr lang="en-US" sz="1600" dirty="0"/>
           </a:p>
@@ -16240,7 +16240,7 @@
                 <a:ea typeface="Trade Gothic Next" pitchFamily="34" charset="-122"/>
                 <a:cs typeface="Trade Gothic Next" pitchFamily="34" charset="-120"/>
               </a:rPr>
-              <a:t>The bluest light</a:t>
+              <a:t>The highest-energy light</a:t>
             </a:r>
             <a:endParaRPr lang="en-US" sz="1600" dirty="0"/>
           </a:p>
@@ -16762,7 +16762,7 @@
                 <a:ea typeface="Trade Gothic Next" pitchFamily="34" charset="-122"/>
                 <a:cs typeface="Trade Gothic Next" pitchFamily="34" charset="-120"/>
               </a:rPr>
-              <a:t>Bluest: C (ultraviolet)</a:t>
+              <a:t>Highest: C (ultraviolet)</a:t>
             </a:r>
             <a:endParaRPr lang="en-US" sz="1900" dirty="0"/>
           </a:p>
@@ -17691,7 +17691,24 @@
                 <a:ea typeface="Trade Gothic Next" pitchFamily="34" charset="-122"/>
                 <a:cs typeface="Trade Gothic Next" pitchFamily="34" charset="-120"/>
               </a:rPr>
-              <a:t>Outermost electron leaves first.</a:t>
+              <a:t>In bigger atoms, the</a:t>
+            </a:r>
+            <a:endParaRPr lang="en-US" sz="1600" dirty="0"/>
+          </a:p>
+          <a:p>
+            <a:pPr indent="0" marL="0">
+              <a:buNone/>
+            </a:pPr>
+            <a:r>
+              <a:rPr lang="en-US" sz="1600" dirty="0">
+                <a:solidFill>
+                  <a:srgbClr val="14161B"/>
+                </a:solidFill>
+                <a:latin typeface="Trade Gothic Next" pitchFamily="34" charset="0"/>
+                <a:ea typeface="Trade Gothic Next" pitchFamily="34" charset="-122"/>
+                <a:cs typeface="Trade Gothic Next" pitchFamily="34" charset="-120"/>
+              </a:rPr>
+              <a:t>outermost electron leaves first.</a:t>
             </a:r>
             <a:endParaRPr lang="en-US" sz="1600" dirty="0"/>
           </a:p>
@@ -19414,7 +19431,7 @@
                 <a:ea typeface="Trade Gothic Next" pitchFamily="34" charset="-122"/>
                 <a:cs typeface="Trade Gothic Next" pitchFamily="34" charset="-120"/>
               </a:rPr>
-              <a:t>Which drop releases more energy, n = 3 to n = 2 or n = 2 to n = 1? How do you know?</a:t>
+              <a:t>Which drop releases more energy, n = 3 to n = 2 or n = 2 to n = 1? How do you know?</a:t>
             </a:r>
             <a:endParaRPr lang="en-US" sz="1600" dirty="0"/>
           </a:p>
@@ -22572,7 +22589,7 @@
                 <a:ea typeface="Trade Gothic Next" pitchFamily="34" charset="-122"/>
                 <a:cs typeface="Trade Gothic Next" pitchFamily="34" charset="-120"/>
               </a:rPr>
-              <a:t>n</a:t>
+              <a:t>LEVEL NUMBER, n</a:t>
             </a:r>
             <a:endParaRPr lang="en-US" sz="1200" dirty="0"/>
           </a:p>

</xml_diff>